<commit_message>
style: overhaul presentation and slide deck to 100% match website visual styling and butter-pine brand identity
</commit_message>
<xml_diff>
--- a/PackShift_Profi_Gigahack2026.pptx
+++ b/PackShift_Profi_Gigahack2026.pptx
@@ -3110,11 +3110,11 @@
             <a:avLst/>
           </a:prstGeom>
           <a:solidFill>
-            <a:srgbClr val="123524"/>
+            <a:srgbClr val="FAF4E4"/>
           </a:solidFill>
           <a:ln>
             <a:solidFill>
-              <a:srgbClr val="123524"/>
+              <a:srgbClr val="FAF4E4"/>
             </a:solidFill>
           </a:ln>
         </p:spPr>
@@ -3148,14 +3148,14 @@
         </p:nvSpPr>
         <p:spPr>
           <a:xfrm>
-            <a:off x="822960" y="914400"/>
-            <a:ext cx="5303520" cy="411480"/>
+            <a:off x="731520" y="320040"/>
+            <a:ext cx="10728655" cy="868680"/>
           </a:xfrm>
           <a:prstGeom prst="roundRect">
             <a:avLst/>
           </a:prstGeom>
           <a:solidFill>
-            <a:srgbClr val="153E2B"/>
+            <a:srgbClr val="123524"/>
           </a:solidFill>
           <a:ln w="12700">
             <a:solidFill>
@@ -3181,17 +3181,7 @@
           <a:bodyPr rtlCol="0" anchor="ctr"/>
           <a:lstStyle/>
           <a:p>
-            <a:pPr algn="ctr">
-              <a:defRPr sz="1100" b="1">
-                <a:solidFill>
-                  <a:srgbClr val="22C55E"/>
-                </a:solidFill>
-                <a:latin typeface="Plus Jakarta Sans"/>
-              </a:defRPr>
-            </a:pPr>
-            <a:r>
-              <a:t>🌱 DEEPTECH GIGAHACK 2026 • BIOMENTORHUB × PROFI</a:t>
-            </a:r>
+            <a:pPr algn="ctr"/>
           </a:p>
         </p:txBody>
       </p:sp>
@@ -3203,8 +3193,8 @@
         </p:nvSpPr>
         <p:spPr>
           <a:xfrm>
-            <a:off x="9144000" y="822960"/>
-            <a:ext cx="2194560" cy="822960"/>
+            <a:off x="914400" y="429768"/>
+            <a:ext cx="2011680" cy="640080"/>
           </a:xfrm>
           <a:prstGeom prst="roundRect">
             <a:avLst/>
@@ -3256,8 +3246,8 @@
         </p:blipFill>
         <p:spPr>
           <a:xfrm>
-            <a:off x="9281160" y="896112"/>
-            <a:ext cx="1920240" cy="640080"/>
+            <a:off x="1051560" y="484632"/>
+            <a:ext cx="1737360" cy="579120"/>
           </a:xfrm>
           <a:prstGeom prst="rect">
             <a:avLst/>
@@ -3272,8 +3262,8 @@
         </p:nvSpPr>
         <p:spPr>
           <a:xfrm>
-            <a:off x="822960" y="1554480"/>
-            <a:ext cx="10515600" cy="1645920"/>
+            <a:off x="3200400" y="365760"/>
+            <a:ext cx="8046720" cy="777240"/>
           </a:xfrm>
           <a:prstGeom prst="rect">
             <a:avLst/>
@@ -3287,7 +3277,20 @@
           <a:lstStyle/>
           <a:p>
             <a:pPr>
-              <a:defRPr sz="3600" b="1">
+              <a:defRPr sz="1000" b="1">
+                <a:solidFill>
+                  <a:srgbClr val="22C55E"/>
+                </a:solidFill>
+                <a:latin typeface="Plus Jakarta Sans"/>
+              </a:defRPr>
+            </a:pPr>
+            <a:r>
+              <a:t>DEEPTECH GIGAHACK 2026 • BIOMENTORHUB × PROFI</a:t>
+            </a:r>
+          </a:p>
+          <a:p>
+            <a:pPr>
+              <a:defRPr sz="1800" b="1">
                 <a:solidFill>
                   <a:srgbClr val="FFFFFF"/>
                 </a:solidFill>
@@ -3295,20 +3298,7 @@
               </a:defRPr>
             </a:pPr>
             <a:r>
-              <a:t>PackShift: Революция пищевой упаковки ритейла</a:t>
-            </a:r>
-          </a:p>
-          <a:p>
-            <a:pPr>
-              <a:defRPr sz="2000" b="1">
-                <a:solidFill>
-                  <a:srgbClr val="22C55E"/>
-                </a:solidFill>
-                <a:latin typeface="Plus Jakarta Sans"/>
-              </a:defRPr>
-            </a:pPr>
-            <a:r>
-              <a:t>0% первичного пластика • Термостойкость до 250°C • EU PPWR 2030 Ready</a:t>
+              <a:t>Революция пищевой упаковки ритейла: 0% первичного пластика</a:t>
             </a:r>
           </a:p>
         </p:txBody>
@@ -3321,8 +3311,8 @@
         </p:nvSpPr>
         <p:spPr>
           <a:xfrm>
-            <a:off x="822960" y="3291840"/>
-            <a:ext cx="10058400" cy="822960"/>
+            <a:off x="731520" y="1463040"/>
+            <a:ext cx="10728655" cy="2468880"/>
           </a:xfrm>
           <a:prstGeom prst="rect">
             <a:avLst/>
@@ -3336,15 +3326,41 @@
           <a:lstStyle/>
           <a:p>
             <a:pPr>
-              <a:defRPr sz="1500">
-                <a:solidFill>
-                  <a:srgbClr val="FAF4E4"/>
+              <a:defRPr sz="1200" b="1">
+                <a:solidFill>
+                  <a:srgbClr val="15803D"/>
                 </a:solidFill>
                 <a:latin typeface="Plus Jakarta Sans"/>
               </a:defRPr>
             </a:pPr>
             <a:r>
-              <a:t>Инженерная система циркулярной упаковки для сети супермаркетов Profi. Биомиметические барьеры против жира, полное устранение токсичных PFAS и прямое снижение экологического сбора ритейлера (EPR Tax) без капитальных затрат (CapEx = 0).</a:t>
+              <a:t>🌱 ТРЕК BIOMENTORHUB × PROFI • ХАКАТОН 2026</a:t>
+            </a:r>
+          </a:p>
+          <a:p>
+            <a:pPr>
+              <a:defRPr sz="3200" b="1">
+                <a:solidFill>
+                  <a:srgbClr val="123524"/>
+                </a:solidFill>
+                <a:latin typeface="Plus Jakarta Sans"/>
+              </a:defRPr>
+            </a:pPr>
+            <a:r>
+              <a:t>PackShift: 0% первичного пластика, 100% циркулярность</a:t>
+            </a:r>
+          </a:p>
+          <a:p>
+            <a:pPr>
+              <a:defRPr sz="1400">
+                <a:solidFill>
+                  <a:srgbClr val="526B5C"/>
+                </a:solidFill>
+                <a:latin typeface="Plus Jakarta Sans"/>
+              </a:defRPr>
+            </a:pPr>
+            <a:r>
+              <a:t>Инженерные решения для сети супермаркетов Profi: биомиметические барьеры против жира, термостойкость до 250°C без токсичных PFAS, продление свежести продуктов и прямое снижение эко-сбора.</a:t>
             </a:r>
           </a:p>
         </p:txBody>
@@ -3357,18 +3373,18 @@
         </p:nvSpPr>
         <p:spPr>
           <a:xfrm>
-            <a:off x="822960" y="4480560"/>
-            <a:ext cx="2468880" cy="1645920"/>
+            <a:off x="731520" y="4114800"/>
+            <a:ext cx="2514600" cy="2286000"/>
           </a:xfrm>
           <a:prstGeom prst="roundRect">
             <a:avLst/>
           </a:prstGeom>
           <a:solidFill>
-            <a:srgbClr val="153E2B"/>
+            <a:srgbClr val="FFFFFF"/>
           </a:solidFill>
           <a:ln w="12700">
             <a:solidFill>
-              <a:srgbClr val="15803D"/>
+              <a:srgbClr val="D8E2DC"/>
             </a:solidFill>
           </a:ln>
         </p:spPr>
@@ -3402,8 +3418,8 @@
         </p:nvSpPr>
         <p:spPr>
           <a:xfrm>
-            <a:off x="960120" y="4617720"/>
-            <a:ext cx="2194560" cy="1371600"/>
+            <a:off x="868680" y="4297680"/>
+            <a:ext cx="2240280" cy="1920240"/>
           </a:xfrm>
           <a:prstGeom prst="rect">
             <a:avLst/>
@@ -3417,9 +3433,9 @@
           <a:lstStyle/>
           <a:p>
             <a:pPr>
-              <a:defRPr sz="2800" b="1">
-                <a:solidFill>
-                  <a:srgbClr val="22C55E"/>
+              <a:defRPr sz="3000" b="1">
+                <a:solidFill>
+                  <a:srgbClr val="15803D"/>
                 </a:solidFill>
                 <a:latin typeface="JetBrains Mono"/>
               </a:defRPr>
@@ -3430,9 +3446,9 @@
           </a:p>
           <a:p>
             <a:pPr>
-              <a:defRPr sz="1300" b="1">
-                <a:solidFill>
-                  <a:srgbClr val="FFFFFF"/>
+              <a:defRPr sz="1400" b="1">
+                <a:solidFill>
+                  <a:srgbClr val="123524"/>
                 </a:solidFill>
                 <a:latin typeface="Plus Jakarta Sans"/>
               </a:defRPr>
@@ -3443,9 +3459,9 @@
           </a:p>
           <a:p>
             <a:pPr>
-              <a:defRPr sz="1000">
-                <a:solidFill>
-                  <a:srgbClr val="FAF4E4"/>
+              <a:defRPr sz="1100">
+                <a:solidFill>
+                  <a:srgbClr val="526B5C"/>
                 </a:solidFill>
                 <a:latin typeface="Plus Jakarta Sans"/>
               </a:defRPr>
@@ -3464,14 +3480,14 @@
         </p:nvSpPr>
         <p:spPr>
           <a:xfrm>
-            <a:off x="3520440" y="4480560"/>
-            <a:ext cx="2468880" cy="1645920"/>
+            <a:off x="3465576" y="4114800"/>
+            <a:ext cx="2514600" cy="2286000"/>
           </a:xfrm>
           <a:prstGeom prst="roundRect">
             <a:avLst/>
           </a:prstGeom>
           <a:solidFill>
-            <a:srgbClr val="153E2B"/>
+            <a:srgbClr val="123524"/>
           </a:solidFill>
           <a:ln w="19050">
             <a:solidFill>
@@ -3509,8 +3525,8 @@
         </p:nvSpPr>
         <p:spPr>
           <a:xfrm>
-            <a:off x="3657600" y="4617720"/>
-            <a:ext cx="2194560" cy="1371600"/>
+            <a:off x="3602736" y="4297680"/>
+            <a:ext cx="2240280" cy="1920240"/>
           </a:xfrm>
           <a:prstGeom prst="rect">
             <a:avLst/>
@@ -3524,7 +3540,7 @@
           <a:lstStyle/>
           <a:p>
             <a:pPr>
-              <a:defRPr sz="2800" b="1">
+              <a:defRPr sz="3000" b="1">
                 <a:solidFill>
                   <a:srgbClr val="22C55E"/>
                 </a:solidFill>
@@ -3537,7 +3553,7 @@
           </a:p>
           <a:p>
             <a:pPr>
-              <a:defRPr sz="1300" b="1">
+              <a:defRPr sz="1400" b="1">
                 <a:solidFill>
                   <a:srgbClr val="FFFFFF"/>
                 </a:solidFill>
@@ -3545,12 +3561,12 @@
               </a:defRPr>
             </a:pPr>
             <a:r>
-              <a:t>Вызов гриля</a:t>
-            </a:r>
-          </a:p>
-          <a:p>
-            <a:pPr>
-              <a:defRPr sz="1000">
+              <a:t>Термостойкость гриля</a:t>
+            </a:r>
+          </a:p>
+          <a:p>
+            <a:pPr>
+              <a:defRPr sz="1100">
                 <a:solidFill>
                   <a:srgbClr val="FAF4E4"/>
                 </a:solidFill>
@@ -3558,7 +3574,7 @@
               </a:defRPr>
             </a:pPr>
             <a:r>
-              <a:t>До 6ч в витрине без протечек</a:t>
+              <a:t>До 6ч в витрине без размягчения</a:t>
             </a:r>
           </a:p>
         </p:txBody>
@@ -3571,18 +3587,18 @@
         </p:nvSpPr>
         <p:spPr>
           <a:xfrm>
-            <a:off x="6217920" y="4480560"/>
-            <a:ext cx="2468880" cy="1645920"/>
+            <a:off x="6199632" y="4114800"/>
+            <a:ext cx="2514600" cy="2286000"/>
           </a:xfrm>
           <a:prstGeom prst="roundRect">
             <a:avLst/>
           </a:prstGeom>
           <a:solidFill>
-            <a:srgbClr val="153E2B"/>
+            <a:srgbClr val="FFFFFF"/>
           </a:solidFill>
           <a:ln w="12700">
             <a:solidFill>
-              <a:srgbClr val="15803D"/>
+              <a:srgbClr val="D8E2DC"/>
             </a:solidFill>
           </a:ln>
         </p:spPr>
@@ -3616,8 +3632,8 @@
         </p:nvSpPr>
         <p:spPr>
           <a:xfrm>
-            <a:off x="6355080" y="4617720"/>
-            <a:ext cx="2194560" cy="1371600"/>
+            <a:off x="6336792" y="4297680"/>
+            <a:ext cx="2240280" cy="1920240"/>
           </a:xfrm>
           <a:prstGeom prst="rect">
             <a:avLst/>
@@ -3631,9 +3647,9 @@
           <a:lstStyle/>
           <a:p>
             <a:pPr>
-              <a:defRPr sz="2800" b="1">
-                <a:solidFill>
-                  <a:srgbClr val="22C55E"/>
+              <a:defRPr sz="3000" b="1">
+                <a:solidFill>
+                  <a:srgbClr val="15803D"/>
                 </a:solidFill>
                 <a:latin typeface="JetBrains Mono"/>
               </a:defRPr>
@@ -3644,9 +3660,9 @@
           </a:p>
           <a:p>
             <a:pPr>
-              <a:defRPr sz="1300" b="1">
-                <a:solidFill>
-                  <a:srgbClr val="FFFFFF"/>
+              <a:defRPr sz="1400" b="1">
+                <a:solidFill>
+                  <a:srgbClr val="123524"/>
                 </a:solidFill>
                 <a:latin typeface="Plus Jakarta Sans"/>
               </a:defRPr>
@@ -3657,9 +3673,9 @@
           </a:p>
           <a:p>
             <a:pPr>
-              <a:defRPr sz="1000">
-                <a:solidFill>
-                  <a:srgbClr val="FAF4E4"/>
+              <a:defRPr sz="1100">
+                <a:solidFill>
+                  <a:srgbClr val="526B5C"/>
                 </a:solidFill>
                 <a:latin typeface="Plus Jakarta Sans"/>
               </a:defRPr>
@@ -3678,18 +3694,18 @@
         </p:nvSpPr>
         <p:spPr>
           <a:xfrm>
-            <a:off x="8915400" y="4480560"/>
-            <a:ext cx="2468880" cy="1645920"/>
+            <a:off x="8933688" y="4114800"/>
+            <a:ext cx="2514600" cy="2286000"/>
           </a:xfrm>
           <a:prstGeom prst="roundRect">
             <a:avLst/>
           </a:prstGeom>
           <a:solidFill>
-            <a:srgbClr val="153E2B"/>
+            <a:srgbClr val="FFFFFF"/>
           </a:solidFill>
           <a:ln w="12700">
             <a:solidFill>
-              <a:srgbClr val="15803D"/>
+              <a:srgbClr val="D8E2DC"/>
             </a:solidFill>
           </a:ln>
         </p:spPr>
@@ -3723,8 +3739,8 @@
         </p:nvSpPr>
         <p:spPr>
           <a:xfrm>
-            <a:off x="9052560" y="4617720"/>
-            <a:ext cx="2194560" cy="1371600"/>
+            <a:off x="9070848" y="4297680"/>
+            <a:ext cx="2240280" cy="1920240"/>
           </a:xfrm>
           <a:prstGeom prst="rect">
             <a:avLst/>
@@ -3738,9 +3754,9 @@
           <a:lstStyle/>
           <a:p>
             <a:pPr>
-              <a:defRPr sz="2800" b="1">
-                <a:solidFill>
-                  <a:srgbClr val="22C55E"/>
+              <a:defRPr sz="3000" b="1">
+                <a:solidFill>
+                  <a:srgbClr val="15803D"/>
                 </a:solidFill>
                 <a:latin typeface="JetBrains Mono"/>
               </a:defRPr>
@@ -3751,9 +3767,9 @@
           </a:p>
           <a:p>
             <a:pPr>
-              <a:defRPr sz="1300" b="1">
-                <a:solidFill>
-                  <a:srgbClr val="FFFFFF"/>
+              <a:defRPr sz="1400" b="1">
+                <a:solidFill>
+                  <a:srgbClr val="123524"/>
                 </a:solidFill>
                 <a:latin typeface="Plus Jakarta Sans"/>
               </a:defRPr>
@@ -3764,9 +3780,9 @@
           </a:p>
           <a:p>
             <a:pPr>
-              <a:defRPr sz="1000">
-                <a:solidFill>
-                  <a:srgbClr val="FAF4E4"/>
+              <a:defRPr sz="1100">
+                <a:solidFill>
+                  <a:srgbClr val="526B5C"/>
                 </a:solidFill>
                 <a:latin typeface="Plus Jakarta Sans"/>
               </a:defRPr>
@@ -3842,86 +3858,59 @@
       </p:sp>
       <p:sp>
         <p:nvSpPr>
-          <p:cNvPr id="3" name="TextBox 2"/>
-          <p:cNvSpPr txBox="1"/>
-          <p:nvPr/>
-        </p:nvSpPr>
-        <p:spPr>
-          <a:xfrm>
-            <a:off x="731520" y="411480"/>
-            <a:ext cx="8229600" cy="320040"/>
-          </a:xfrm>
-          <a:prstGeom prst="rect">
-            <a:avLst/>
-          </a:prstGeom>
-          <a:noFill/>
-        </p:spPr>
-        <p:txBody>
-          <a:bodyPr wrap="square">
-            <a:spAutoFit/>
-          </a:bodyPr>
-          <a:lstStyle/>
-          <a:p>
-            <a:pPr>
-              <a:defRPr sz="1100" b="1">
-                <a:solidFill>
-                  <a:srgbClr val="15803D"/>
-                </a:solidFill>
-                <a:latin typeface="Plus Jakarta Sans"/>
-              </a:defRPr>
-            </a:pPr>
-            <a:r>
-              <a:t>DEEPTECH GIGAHACK 2026 • BIOMENTORHUB × PROFI</a:t>
-            </a:r>
-          </a:p>
-        </p:txBody>
-      </p:sp>
-      <p:sp>
-        <p:nvSpPr>
-          <p:cNvPr id="4" name="TextBox 3"/>
-          <p:cNvSpPr txBox="1"/>
-          <p:nvPr/>
-        </p:nvSpPr>
-        <p:spPr>
-          <a:xfrm>
-            <a:off x="731520" y="685800"/>
-            <a:ext cx="8686800" cy="731520"/>
-          </a:xfrm>
-          <a:prstGeom prst="rect">
-            <a:avLst/>
-          </a:prstGeom>
-          <a:noFill/>
-        </p:spPr>
-        <p:txBody>
-          <a:bodyPr wrap="square">
-            <a:spAutoFit/>
-          </a:bodyPr>
-          <a:lstStyle/>
-          <a:p>
-            <a:pPr>
-              <a:defRPr sz="2400" b="1">
-                <a:solidFill>
-                  <a:srgbClr val="123524"/>
-                </a:solidFill>
-                <a:latin typeface="Plus Jakarta Sans"/>
-              </a:defRPr>
-            </a:pPr>
-            <a:r>
-              <a:t>Двойной вызов ритейла: Регуляторный капкан и боль витрины</a:t>
-            </a:r>
-          </a:p>
-        </p:txBody>
-      </p:sp>
-      <p:sp>
-        <p:nvSpPr>
-          <p:cNvPr id="5" name="Rounded Rectangle 4"/>
+          <p:cNvPr id="3" name="Rounded Rectangle 2"/>
           <p:cNvSpPr/>
           <p:nvPr/>
         </p:nvSpPr>
         <p:spPr>
           <a:xfrm>
-            <a:off x="9692640" y="411480"/>
-            <a:ext cx="1828800" cy="685800"/>
+            <a:off x="731520" y="320040"/>
+            <a:ext cx="10728655" cy="868680"/>
+          </a:xfrm>
+          <a:prstGeom prst="roundRect">
+            <a:avLst/>
+          </a:prstGeom>
+          <a:solidFill>
+            <a:srgbClr val="123524"/>
+          </a:solidFill>
+          <a:ln w="12700">
+            <a:solidFill>
+              <a:srgbClr val="22C55E"/>
+            </a:solidFill>
+          </a:ln>
+        </p:spPr>
+        <p:style>
+          <a:lnRef idx="1">
+            <a:schemeClr val="accent1"/>
+          </a:lnRef>
+          <a:fillRef idx="3">
+            <a:schemeClr val="accent1"/>
+          </a:fillRef>
+          <a:effectRef idx="2">
+            <a:schemeClr val="accent1"/>
+          </a:effectRef>
+          <a:fontRef idx="minor">
+            <a:schemeClr val="lt1"/>
+          </a:fontRef>
+        </p:style>
+        <p:txBody>
+          <a:bodyPr rtlCol="0" anchor="ctr"/>
+          <a:lstStyle/>
+          <a:p>
+            <a:pPr algn="ctr"/>
+          </a:p>
+        </p:txBody>
+      </p:sp>
+      <p:sp>
+        <p:nvSpPr>
+          <p:cNvPr id="4" name="Rounded Rectangle 3"/>
+          <p:cNvSpPr/>
+          <p:nvPr/>
+        </p:nvSpPr>
+        <p:spPr>
+          <a:xfrm>
+            <a:off x="914400" y="429768"/>
+            <a:ext cx="2011680" cy="640080"/>
           </a:xfrm>
           <a:prstGeom prst="roundRect">
             <a:avLst/>
@@ -3931,7 +3920,7 @@
           </a:solidFill>
           <a:ln w="12700">
             <a:solidFill>
-              <a:srgbClr val="15803D"/>
+              <a:srgbClr val="22C55E"/>
             </a:solidFill>
           </a:ln>
         </p:spPr>
@@ -3959,7 +3948,7 @@
       </p:sp>
       <p:pic>
         <p:nvPicPr>
-          <p:cNvPr id="6" name="Picture 5" descr="logo.png"/>
+          <p:cNvPr id="5" name="Picture 4" descr="logo.png"/>
           <p:cNvPicPr>
             <a:picLocks noChangeAspect="1"/>
           </p:cNvPicPr>
@@ -3973,14 +3962,63 @@
         </p:blipFill>
         <p:spPr>
           <a:xfrm>
-            <a:off x="9784080" y="475488"/>
-            <a:ext cx="1645920" cy="548640"/>
+            <a:off x="1051560" y="484632"/>
+            <a:ext cx="1737360" cy="579120"/>
           </a:xfrm>
           <a:prstGeom prst="rect">
             <a:avLst/>
           </a:prstGeom>
         </p:spPr>
       </p:pic>
+      <p:sp>
+        <p:nvSpPr>
+          <p:cNvPr id="6" name="TextBox 5"/>
+          <p:cNvSpPr txBox="1"/>
+          <p:nvPr/>
+        </p:nvSpPr>
+        <p:spPr>
+          <a:xfrm>
+            <a:off x="3200400" y="365760"/>
+            <a:ext cx="8046720" cy="777240"/>
+          </a:xfrm>
+          <a:prstGeom prst="rect">
+            <a:avLst/>
+          </a:prstGeom>
+          <a:noFill/>
+        </p:spPr>
+        <p:txBody>
+          <a:bodyPr wrap="square">
+            <a:spAutoFit/>
+          </a:bodyPr>
+          <a:lstStyle/>
+          <a:p>
+            <a:pPr>
+              <a:defRPr sz="1000" b="1">
+                <a:solidFill>
+                  <a:srgbClr val="22C55E"/>
+                </a:solidFill>
+                <a:latin typeface="Plus Jakarta Sans"/>
+              </a:defRPr>
+            </a:pPr>
+            <a:r>
+              <a:t>ПРОБЛЕМА И КОНТЕКСТ</a:t>
+            </a:r>
+          </a:p>
+          <a:p>
+            <a:pPr>
+              <a:defRPr sz="1800" b="1">
+                <a:solidFill>
+                  <a:srgbClr val="FFFFFF"/>
+                </a:solidFill>
+                <a:latin typeface="Plus Jakarta Sans"/>
+              </a:defRPr>
+            </a:pPr>
+            <a:r>
+              <a:t>Двойной вызов ритейла: Регуляторный капкан и боль витрины</a:t>
+            </a:r>
+          </a:p>
+        </p:txBody>
+      </p:sp>
       <p:sp>
         <p:nvSpPr>
           <p:cNvPr id="7" name="Rounded Rectangle 6"/>
@@ -3989,8 +4027,8 @@
         </p:nvSpPr>
         <p:spPr>
           <a:xfrm>
-            <a:off x="731520" y="1554480"/>
-            <a:ext cx="5120640" cy="4663440"/>
+            <a:off x="731520" y="1463040"/>
+            <a:ext cx="5212080" cy="4937760"/>
           </a:xfrm>
           <a:prstGeom prst="roundRect">
             <a:avLst/>
@@ -4000,7 +4038,7 @@
           </a:solidFill>
           <a:ln w="12700">
             <a:solidFill>
-              <a:srgbClr val="123524"/>
+              <a:srgbClr val="D8E2DC"/>
             </a:solidFill>
           </a:ln>
         </p:spPr>
@@ -4034,8 +4072,8 @@
         </p:nvSpPr>
         <p:spPr>
           <a:xfrm>
-            <a:off x="1005840" y="1737360"/>
-            <a:ext cx="4572000" cy="4297680"/>
+            <a:off x="1005840" y="1645920"/>
+            <a:ext cx="4663440" cy="4572000"/>
           </a:xfrm>
           <a:prstGeom prst="rect">
             <a:avLst/>
@@ -4049,7 +4087,7 @@
           <a:lstStyle/>
           <a:p>
             <a:pPr>
-              <a:defRPr sz="1800" b="1">
+              <a:defRPr sz="1900" b="1">
                 <a:solidFill>
                   <a:srgbClr val="123524"/>
                 </a:solidFill>
@@ -4057,7 +4095,7 @@
               </a:defRPr>
             </a:pPr>
             <a:r>
-              <a:t>⚖️ 1. Регуляторное и налоговое давление</a:t>
+              <a:t>⚖️ 1. Регуляторное давление на Profi</a:t>
             </a:r>
           </a:p>
           <a:p>
@@ -4097,7 +4135,7 @@
                   <a:srgbClr val="526B5C"/>
                 </a:solidFill>
               </a:rPr>
-              <a:t>Налог на комбинированные ламинаты (ПЭ+фольга) вырос на 45%. Трудная упаковка становится прямым убытком.</a:t>
+              <a:t>Рост ставки налога на комбинированные ламинаты (ПЭ+фольга) на 45%. Трудная упаковка становится прямым убытком.</a:t>
             </a:r>
           </a:p>
           <a:p>
@@ -4129,7 +4167,7 @@
               </a:defRPr>
             </a:pPr>
             <a:r>
-              <a:t>• CSRD отчетность Scope 3: </a:t>
+              <a:t>• CSRD аудит (Scope 3): </a:t>
             </a:r>
             <a:r>
               <a:rPr b="0">
@@ -4150,8 +4188,8 @@
         </p:nvSpPr>
         <p:spPr>
           <a:xfrm>
-            <a:off x="6217920" y="1554480"/>
-            <a:ext cx="5212080" cy="4663440"/>
+            <a:off x="6217920" y="1463040"/>
+            <a:ext cx="5212080" cy="4937760"/>
           </a:xfrm>
           <a:prstGeom prst="roundRect">
             <a:avLst/>
@@ -4195,8 +4233,8 @@
         </p:nvSpPr>
         <p:spPr>
           <a:xfrm>
-            <a:off x="6492240" y="1737360"/>
-            <a:ext cx="4663440" cy="4297680"/>
+            <a:off x="6492240" y="1645920"/>
+            <a:ext cx="4663440" cy="4572000"/>
           </a:xfrm>
           <a:prstGeom prst="rect">
             <a:avLst/>
@@ -4210,7 +4248,7 @@
           <a:lstStyle/>
           <a:p>
             <a:pPr>
-              <a:defRPr sz="1800" b="1">
+              <a:defRPr sz="1900" b="1">
                 <a:solidFill>
                   <a:srgbClr val="FFFFFF"/>
                 </a:solidFill>
@@ -4218,7 +4256,7 @@
               </a:defRPr>
             </a:pPr>
             <a:r>
-              <a:t>🔥 2. Острая боль: Отдел гриля и кулинарии</a:t>
+              <a:t>🔥 2. Острая боль: Отдел гриля Profi</a:t>
             </a:r>
           </a:p>
           <a:p>
@@ -4238,7 +4276,7 @@
                   <a:srgbClr val="FAF4E4"/>
                 </a:solidFill>
               </a:rPr>
-              <a:t>Выдержка в витрине при 85°C – 120°C до 6 часов. Пиковые температуры фасовки достигают 180°C – 250°C.</a:t>
+              <a:t>Выдержка в витрине при 85°C – 120°C до 6 часов. Пиковые температуры фасовки — до 250°C.</a:t>
             </a:r>
           </a:p>
           <a:p>
@@ -4258,7 +4296,7 @@
                   <a:srgbClr val="FAF4E4"/>
                 </a:solidFill>
               </a:rPr>
-              <a:t>Полиэтиленовые пакеты с фольгой размягчаются, деформируются, текут и выделяют запах нагретого полимера.</a:t>
+              <a:t>Полиэтиленовые пакеты с фольгой размягчаются, текут горячим жиром и выделяют запах нагретой синтетики.</a:t>
             </a:r>
           </a:p>
           <a:p>
@@ -4298,7 +4336,7 @@
                   <a:srgbClr val="FAF4E4"/>
                 </a:solidFill>
               </a:rPr>
-              <a:t>Жиростойкость текущих упаковок держится на PFAS-добавках, мигрирующих в горячую пищу.</a:t>
+              <a:t>Жиростойкость текущих упаковок держится на PFAS, мигрирующих в горячую пищу.</a:t>
             </a:r>
           </a:p>
         </p:txBody>
@@ -4368,86 +4406,59 @@
       </p:sp>
       <p:sp>
         <p:nvSpPr>
-          <p:cNvPr id="3" name="TextBox 2"/>
-          <p:cNvSpPr txBox="1"/>
-          <p:nvPr/>
-        </p:nvSpPr>
-        <p:spPr>
-          <a:xfrm>
-            <a:off x="731520" y="411480"/>
-            <a:ext cx="8229600" cy="320040"/>
-          </a:xfrm>
-          <a:prstGeom prst="rect">
-            <a:avLst/>
-          </a:prstGeom>
-          <a:noFill/>
-        </p:spPr>
-        <p:txBody>
-          <a:bodyPr wrap="square">
-            <a:spAutoFit/>
-          </a:bodyPr>
-          <a:lstStyle/>
-          <a:p>
-            <a:pPr>
-              <a:defRPr sz="1100" b="1">
-                <a:solidFill>
-                  <a:srgbClr val="15803D"/>
-                </a:solidFill>
-                <a:latin typeface="Plus Jakarta Sans"/>
-              </a:defRPr>
-            </a:pPr>
-            <a:r>
-              <a:t>DEEPTECH GIGAHACK 2026 • BIOMENTORHUB × PROFI</a:t>
-            </a:r>
-          </a:p>
-        </p:txBody>
-      </p:sp>
-      <p:sp>
-        <p:nvSpPr>
-          <p:cNvPr id="4" name="TextBox 3"/>
-          <p:cNvSpPr txBox="1"/>
-          <p:nvPr/>
-        </p:nvSpPr>
-        <p:spPr>
-          <a:xfrm>
-            <a:off x="731520" y="685800"/>
-            <a:ext cx="8686800" cy="731520"/>
-          </a:xfrm>
-          <a:prstGeom prst="rect">
-            <a:avLst/>
-          </a:prstGeom>
-          <a:noFill/>
-        </p:spPr>
-        <p:txBody>
-          <a:bodyPr wrap="square">
-            <a:spAutoFit/>
-          </a:bodyPr>
-          <a:lstStyle/>
-          <a:p>
-            <a:pPr>
-              <a:defRPr sz="2400" b="1">
-                <a:solidFill>
-                  <a:srgbClr val="123524"/>
-                </a:solidFill>
-                <a:latin typeface="Plus Jakarta Sans"/>
-              </a:defRPr>
-            </a:pPr>
-            <a:r>
-              <a:t>Специальный вызов: Инновации для Горячего Гриля (180°C – 250°C)</a:t>
-            </a:r>
-          </a:p>
-        </p:txBody>
-      </p:sp>
-      <p:sp>
-        <p:nvSpPr>
-          <p:cNvPr id="5" name="Rounded Rectangle 4"/>
+          <p:cNvPr id="3" name="Rounded Rectangle 2"/>
           <p:cNvSpPr/>
           <p:nvPr/>
         </p:nvSpPr>
         <p:spPr>
           <a:xfrm>
-            <a:off x="9692640" y="411480"/>
-            <a:ext cx="1828800" cy="685800"/>
+            <a:off x="731520" y="320040"/>
+            <a:ext cx="10728655" cy="868680"/>
+          </a:xfrm>
+          <a:prstGeom prst="roundRect">
+            <a:avLst/>
+          </a:prstGeom>
+          <a:solidFill>
+            <a:srgbClr val="123524"/>
+          </a:solidFill>
+          <a:ln w="12700">
+            <a:solidFill>
+              <a:srgbClr val="22C55E"/>
+            </a:solidFill>
+          </a:ln>
+        </p:spPr>
+        <p:style>
+          <a:lnRef idx="1">
+            <a:schemeClr val="accent1"/>
+          </a:lnRef>
+          <a:fillRef idx="3">
+            <a:schemeClr val="accent1"/>
+          </a:fillRef>
+          <a:effectRef idx="2">
+            <a:schemeClr val="accent1"/>
+          </a:effectRef>
+          <a:fontRef idx="minor">
+            <a:schemeClr val="lt1"/>
+          </a:fontRef>
+        </p:style>
+        <p:txBody>
+          <a:bodyPr rtlCol="0" anchor="ctr"/>
+          <a:lstStyle/>
+          <a:p>
+            <a:pPr algn="ctr"/>
+          </a:p>
+        </p:txBody>
+      </p:sp>
+      <p:sp>
+        <p:nvSpPr>
+          <p:cNvPr id="4" name="Rounded Rectangle 3"/>
+          <p:cNvSpPr/>
+          <p:nvPr/>
+        </p:nvSpPr>
+        <p:spPr>
+          <a:xfrm>
+            <a:off x="914400" y="429768"/>
+            <a:ext cx="2011680" cy="640080"/>
           </a:xfrm>
           <a:prstGeom prst="roundRect">
             <a:avLst/>
@@ -4457,7 +4468,7 @@
           </a:solidFill>
           <a:ln w="12700">
             <a:solidFill>
-              <a:srgbClr val="15803D"/>
+              <a:srgbClr val="22C55E"/>
             </a:solidFill>
           </a:ln>
         </p:spPr>
@@ -4485,7 +4496,7 @@
       </p:sp>
       <p:pic>
         <p:nvPicPr>
-          <p:cNvPr id="6" name="Picture 5" descr="logo.png"/>
+          <p:cNvPr id="5" name="Picture 4" descr="logo.png"/>
           <p:cNvPicPr>
             <a:picLocks noChangeAspect="1"/>
           </p:cNvPicPr>
@@ -4499,14 +4510,63 @@
         </p:blipFill>
         <p:spPr>
           <a:xfrm>
-            <a:off x="9784080" y="475488"/>
-            <a:ext cx="1645920" cy="548640"/>
+            <a:off x="1051560" y="484632"/>
+            <a:ext cx="1737360" cy="579120"/>
           </a:xfrm>
           <a:prstGeom prst="rect">
             <a:avLst/>
           </a:prstGeom>
         </p:spPr>
       </p:pic>
+      <p:sp>
+        <p:nvSpPr>
+          <p:cNvPr id="6" name="TextBox 5"/>
+          <p:cNvSpPr txBox="1"/>
+          <p:nvPr/>
+        </p:nvSpPr>
+        <p:spPr>
+          <a:xfrm>
+            <a:off x="3200400" y="365760"/>
+            <a:ext cx="8046720" cy="777240"/>
+          </a:xfrm>
+          <a:prstGeom prst="rect">
+            <a:avLst/>
+          </a:prstGeom>
+          <a:noFill/>
+        </p:spPr>
+        <p:txBody>
+          <a:bodyPr wrap="square">
+            <a:spAutoFit/>
+          </a:bodyPr>
+          <a:lstStyle/>
+          <a:p>
+            <a:pPr>
+              <a:defRPr sz="1000" b="1">
+                <a:solidFill>
+                  <a:srgbClr val="22C55E"/>
+                </a:solidFill>
+                <a:latin typeface="Plus Jakarta Sans"/>
+              </a:defRPr>
+            </a:pPr>
+            <a:r>
+              <a:t>СПЕЦИАЛЬНЫЙ ВЫЗОВ ХАКАТОНА</a:t>
+            </a:r>
+          </a:p>
+          <a:p>
+            <a:pPr>
+              <a:defRPr sz="1800" b="1">
+                <a:solidFill>
+                  <a:srgbClr val="FFFFFF"/>
+                </a:solidFill>
+                <a:latin typeface="Plus Jakarta Sans"/>
+              </a:defRPr>
+            </a:pPr>
+            <a:r>
+              <a:t>Готовая кулинария: Упаковка гриля высокой температуры</a:t>
+            </a:r>
+          </a:p>
+        </p:txBody>
+      </p:sp>
       <p:sp>
         <p:nvSpPr>
           <p:cNvPr id="7" name="Rounded Rectangle 6"/>
@@ -4515,8 +4575,8 @@
         </p:nvSpPr>
         <p:spPr>
           <a:xfrm>
-            <a:off x="731520" y="1554480"/>
-            <a:ext cx="5120640" cy="4663440"/>
+            <a:off x="731520" y="1463040"/>
+            <a:ext cx="5212080" cy="4937760"/>
           </a:xfrm>
           <a:prstGeom prst="roundRect">
             <a:avLst/>
@@ -4524,9 +4584,9 @@
           <a:solidFill>
             <a:srgbClr val="FFFFFF"/>
           </a:solidFill>
-          <a:ln w="19050">
+          <a:ln w="12700">
             <a:solidFill>
-              <a:srgbClr val="15803D"/>
+              <a:srgbClr val="D8E2DC"/>
             </a:solidFill>
           </a:ln>
         </p:spPr>
@@ -4560,8 +4620,8 @@
         </p:nvSpPr>
         <p:spPr>
           <a:xfrm>
-            <a:off x="1005840" y="1737360"/>
-            <a:ext cx="4572000" cy="4297680"/>
+            <a:off x="1005840" y="1645920"/>
+            <a:ext cx="4663440" cy="4572000"/>
           </a:xfrm>
           <a:prstGeom prst="rect">
             <a:avLst/>
@@ -4583,12 +4643,12 @@
               </a:defRPr>
             </a:pPr>
             <a:r>
-              <a:t>РЕШЕНИЕ А: МОНО-ПАКЕТ</a:t>
-            </a:r>
-          </a:p>
-          <a:p>
-            <a:pPr>
-              <a:defRPr sz="2000" b="1">
+              <a:t>РЕШЕНИЕ А • МОНО-ПАКЕТ</a:t>
+            </a:r>
+          </a:p>
+          <a:p>
+            <a:pPr>
+              <a:defRPr sz="2100" b="1">
                 <a:solidFill>
                   <a:srgbClr val="123524"/>
                 </a:solidFill>
@@ -4601,7 +4661,7 @@
           </a:p>
           <a:p>
             <a:pPr>
-              <a:defRPr b="1" sz="1150">
+              <a:defRPr b="1" sz="1200">
                 <a:solidFill>
                   <a:srgbClr val="123524"/>
                 </a:solidFill>
@@ -4616,12 +4676,12 @@
                   <a:srgbClr val="526B5C"/>
                 </a:solidFill>
               </a:rPr>
-              <a:t>Модифицированный кристаллический rPET (степень кристалличности &gt; 38%).</a:t>
-            </a:r>
-          </a:p>
-          <a:p>
-            <a:pPr>
-              <a:defRPr b="1" sz="1150">
+              <a:t>Кристаллический модифицированный rPET (кристалличность &gt; 38%).</a:t>
+            </a:r>
+          </a:p>
+          <a:p>
+            <a:pPr>
+              <a:defRPr b="1" sz="1200">
                 <a:solidFill>
                   <a:srgbClr val="123524"/>
                 </a:solidFill>
@@ -4636,19 +4696,19 @@
                   <a:srgbClr val="526B5C"/>
                 </a:solidFill>
               </a:rPr>
-              <a:t>от -40°C до +250°C (Dual-Ovenable: духовка + СВЧ).</a:t>
-            </a:r>
-          </a:p>
-          <a:p>
-            <a:pPr>
-              <a:defRPr b="1" sz="1150">
+              <a:t>от -40°C до +250°C (Dual-Ovenable: разогрев прямо в упаковке).</a:t>
+            </a:r>
+          </a:p>
+          <a:p>
+            <a:pPr>
+              <a:defRPr b="1" sz="1200">
                 <a:solidFill>
                   <a:srgbClr val="123524"/>
                 </a:solidFill>
               </a:defRPr>
             </a:pPr>
             <a:r>
-              <a:t>Тепловая витрина: </a:t>
+              <a:t>Витрина гриля: </a:t>
             </a:r>
             <a:r>
               <a:rPr b="0">
@@ -4656,12 +4716,12 @@
                   <a:srgbClr val="526B5C"/>
                 </a:solidFill>
               </a:rPr>
-              <a:t>6+ часов при 95°C–120°C без усадки, протечек и запаха.</a:t>
-            </a:r>
-          </a:p>
-          <a:p>
-            <a:pPr>
-              <a:defRPr b="1" sz="1150">
+              <a:t>6+ часов при 95°C–120°C без усадки, запаха и деформации.</a:t>
+            </a:r>
+          </a:p>
+          <a:p>
+            <a:pPr>
+              <a:defRPr b="1" sz="1200">
                 <a:solidFill>
                   <a:srgbClr val="123524"/>
                 </a:solidFill>
@@ -4681,14 +4741,14 @@
           </a:p>
           <a:p>
             <a:pPr>
-              <a:defRPr b="1" sz="1150">
+              <a:defRPr b="1" sz="1200">
                 <a:solidFill>
                   <a:srgbClr val="123524"/>
                 </a:solidFill>
               </a:defRPr>
             </a:pPr>
             <a:r>
-              <a:t>Рециклинг: </a:t>
+              <a:t>Циркулярность: </a:t>
             </a:r>
             <a:r>
               <a:rPr b="0">
@@ -4701,7 +4761,7 @@
           </a:p>
           <a:p>
             <a:pPr>
-              <a:defRPr b="1" sz="1150">
+              <a:defRPr b="1" sz="1200">
                 <a:solidFill>
                   <a:srgbClr val="123524"/>
                 </a:solidFill>
@@ -4716,7 +4776,7 @@
                   <a:srgbClr val="526B5C"/>
                 </a:solidFill>
               </a:rPr>
-              <a:t>Себестоимость на 14% ниже импортных алюминиевых ламинатов.</a:t>
+              <a:t>Себестоимость на 14% ниже импортных фольгированных ламинатов.</a:t>
             </a:r>
           </a:p>
         </p:txBody>
@@ -4729,8 +4789,8 @@
         </p:nvSpPr>
         <p:spPr>
           <a:xfrm>
-            <a:off x="6217920" y="1554480"/>
-            <a:ext cx="5212080" cy="4663440"/>
+            <a:off x="6217920" y="1463040"/>
+            <a:ext cx="5212080" cy="4937760"/>
           </a:xfrm>
           <a:prstGeom prst="roundRect">
             <a:avLst/>
@@ -4774,8 +4834,8 @@
         </p:nvSpPr>
         <p:spPr>
           <a:xfrm>
-            <a:off x="6492240" y="1737360"/>
-            <a:ext cx="4663440" cy="4297680"/>
+            <a:off x="6492240" y="1645920"/>
+            <a:ext cx="4663440" cy="4572000"/>
           </a:xfrm>
           <a:prstGeom prst="rect">
             <a:avLst/>
@@ -4797,12 +4857,12 @@
               </a:defRPr>
             </a:pPr>
             <a:r>
-              <a:t>РЕШЕНИЕ Б: БИО-КОМПОЗИТ (ДЛЯ PROFI BIO)</a:t>
-            </a:r>
-          </a:p>
-          <a:p>
-            <a:pPr>
-              <a:defRPr sz="2000" b="1">
+              <a:t>РЕШЕНИЕ Б • БИО-КОМПОЗИТ (PROFI BIO)</a:t>
+            </a:r>
+          </a:p>
+          <a:p>
+            <a:pPr>
+              <a:defRPr sz="2100" b="1">
                 <a:solidFill>
                   <a:srgbClr val="FFFFFF"/>
                 </a:solidFill>
@@ -4815,7 +4875,7 @@
           </a:p>
           <a:p>
             <a:pPr>
-              <a:defRPr b="1" sz="1150">
+              <a:defRPr b="1" sz="1200">
                 <a:solidFill>
                   <a:srgbClr val="22C55E"/>
                 </a:solidFill>
@@ -4830,12 +4890,12 @@
                   <a:srgbClr val="FAF4E4"/>
                 </a:solidFill>
               </a:rPr>
-              <a:t>100% формованная багасса сахарного тростника + альгинат/хитозан из водорослей.</a:t>
-            </a:r>
-          </a:p>
-          <a:p>
-            <a:pPr>
-              <a:defRPr b="1" sz="1150">
+              <a:t>100% формованная багасса сахарного тростника + био-барьер из водорослей.</a:t>
+            </a:r>
+          </a:p>
+          <a:p>
+            <a:pPr>
+              <a:defRPr b="1" sz="1200">
                 <a:solidFill>
                   <a:srgbClr val="22C55E"/>
                 </a:solidFill>
@@ -4850,12 +4910,12 @@
                   <a:srgbClr val="FAF4E4"/>
                 </a:solidFill>
               </a:rPr>
-              <a:t>Микропористая структура отводит влажный пар. Сохраняет корочку хрустящей.</a:t>
-            </a:r>
-          </a:p>
-          <a:p>
-            <a:pPr>
-              <a:defRPr b="1" sz="1150">
+              <a:t>Стравливает лишний пар, сохраняя корочку гриля хрустящей.</a:t>
+            </a:r>
+          </a:p>
+          <a:p>
+            <a:pPr>
+              <a:defRPr b="1" sz="1200">
                 <a:solidFill>
                   <a:srgbClr val="22C55E"/>
                 </a:solidFill>
@@ -4870,19 +4930,19 @@
                   <a:srgbClr val="FAF4E4"/>
                 </a:solidFill>
               </a:rPr>
-              <a:t>Водный нано-барьер. 0% пластика, 0% фтора, 0% полиэтилена.</a:t>
-            </a:r>
-          </a:p>
-          <a:p>
-            <a:pPr>
-              <a:defRPr b="1" sz="1150">
+              <a:t>Альгинат натрия + хитозан на водной основе. 0% пластика, 0% фтора.</a:t>
+            </a:r>
+          </a:p>
+          <a:p>
+            <a:pPr>
+              <a:defRPr b="1" sz="1200">
                 <a:solidFill>
                   <a:srgbClr val="22C55E"/>
                 </a:solidFill>
               </a:defRPr>
             </a:pPr>
             <a:r>
-              <a:t>Температура: </a:t>
+              <a:t>Термостойкость: </a:t>
             </a:r>
             <a:r>
               <a:rPr b="0">
@@ -4890,12 +4950,12 @@
                   <a:srgbClr val="FAF4E4"/>
                 </a:solidFill>
               </a:rPr>
-              <a:t>До +220°C кратковременно, 6 часов в витрине гриля.</a:t>
-            </a:r>
-          </a:p>
-          <a:p>
-            <a:pPr>
-              <a:defRPr b="1" sz="1150">
+              <a:t>До +220°C кратковременно, 6 часов в тепловой витрине.</a:t>
+            </a:r>
+          </a:p>
+          <a:p>
+            <a:pPr>
+              <a:defRPr b="1" sz="1200">
                 <a:solidFill>
                   <a:srgbClr val="22C55E"/>
                 </a:solidFill>
@@ -4915,14 +4975,14 @@
           </a:p>
           <a:p>
             <a:pPr>
-              <a:defRPr b="1" sz="1150">
+              <a:defRPr b="1" sz="1200">
                 <a:solidFill>
                   <a:srgbClr val="22C55E"/>
                 </a:solidFill>
               </a:defRPr>
             </a:pPr>
             <a:r>
-              <a:t>Статус: </a:t>
+              <a:t>Позиционирование: </a:t>
             </a:r>
             <a:r>
               <a:rPr b="0">
@@ -4930,7 +4990,7 @@
                   <a:srgbClr val="FAF4E4"/>
                 </a:solidFill>
               </a:rPr>
-              <a:t>Идеальное позиционирование для премиальной эко-линейки Profi.</a:t>
+              <a:t>Идеально для премиальной эко-кулинарии сети Profi.</a:t>
             </a:r>
           </a:p>
         </p:txBody>
@@ -5000,86 +5060,59 @@
       </p:sp>
       <p:sp>
         <p:nvSpPr>
-          <p:cNvPr id="3" name="TextBox 2"/>
-          <p:cNvSpPr txBox="1"/>
-          <p:nvPr/>
-        </p:nvSpPr>
-        <p:spPr>
-          <a:xfrm>
-            <a:off x="731520" y="411480"/>
-            <a:ext cx="8229600" cy="320040"/>
-          </a:xfrm>
-          <a:prstGeom prst="rect">
-            <a:avLst/>
-          </a:prstGeom>
-          <a:noFill/>
-        </p:spPr>
-        <p:txBody>
-          <a:bodyPr wrap="square">
-            <a:spAutoFit/>
-          </a:bodyPr>
-          <a:lstStyle/>
-          <a:p>
-            <a:pPr>
-              <a:defRPr sz="1100" b="1">
-                <a:solidFill>
-                  <a:srgbClr val="15803D"/>
-                </a:solidFill>
-                <a:latin typeface="Plus Jakarta Sans"/>
-              </a:defRPr>
-            </a:pPr>
-            <a:r>
-              <a:t>DEEPTECH GIGAHACK 2026 • BIOMENTORHUB × PROFI</a:t>
-            </a:r>
-          </a:p>
-        </p:txBody>
-      </p:sp>
-      <p:sp>
-        <p:nvSpPr>
-          <p:cNvPr id="4" name="TextBox 3"/>
-          <p:cNvSpPr txBox="1"/>
-          <p:nvPr/>
-        </p:nvSpPr>
-        <p:spPr>
-          <a:xfrm>
-            <a:off x="731520" y="685800"/>
-            <a:ext cx="8686800" cy="731520"/>
-          </a:xfrm>
-          <a:prstGeom prst="rect">
-            <a:avLst/>
-          </a:prstGeom>
-          <a:noFill/>
-        </p:spPr>
-        <p:txBody>
-          <a:bodyPr wrap="square">
-            <a:spAutoFit/>
-          </a:bodyPr>
-          <a:lstStyle/>
-          <a:p>
-            <a:pPr>
-              <a:defRPr sz="2400" b="1">
-                <a:solidFill>
-                  <a:srgbClr val="123524"/>
-                </a:solidFill>
-                <a:latin typeface="Plus Jakarta Sans"/>
-              </a:defRPr>
-            </a:pPr>
-            <a:r>
-              <a:t>Оптимизация отделов Profi: Овощи, Мясо, Выпечка</a:t>
-            </a:r>
-          </a:p>
-        </p:txBody>
-      </p:sp>
-      <p:sp>
-        <p:nvSpPr>
-          <p:cNvPr id="5" name="Rounded Rectangle 4"/>
+          <p:cNvPr id="3" name="Rounded Rectangle 2"/>
           <p:cNvSpPr/>
           <p:nvPr/>
         </p:nvSpPr>
         <p:spPr>
           <a:xfrm>
-            <a:off x="9692640" y="411480"/>
-            <a:ext cx="1828800" cy="685800"/>
+            <a:off x="731520" y="320040"/>
+            <a:ext cx="10728655" cy="868680"/>
+          </a:xfrm>
+          <a:prstGeom prst="roundRect">
+            <a:avLst/>
+          </a:prstGeom>
+          <a:solidFill>
+            <a:srgbClr val="123524"/>
+          </a:solidFill>
+          <a:ln w="12700">
+            <a:solidFill>
+              <a:srgbClr val="22C55E"/>
+            </a:solidFill>
+          </a:ln>
+        </p:spPr>
+        <p:style>
+          <a:lnRef idx="1">
+            <a:schemeClr val="accent1"/>
+          </a:lnRef>
+          <a:fillRef idx="3">
+            <a:schemeClr val="accent1"/>
+          </a:fillRef>
+          <a:effectRef idx="2">
+            <a:schemeClr val="accent1"/>
+          </a:effectRef>
+          <a:fontRef idx="minor">
+            <a:schemeClr val="lt1"/>
+          </a:fontRef>
+        </p:style>
+        <p:txBody>
+          <a:bodyPr rtlCol="0" anchor="ctr"/>
+          <a:lstStyle/>
+          <a:p>
+            <a:pPr algn="ctr"/>
+          </a:p>
+        </p:txBody>
+      </p:sp>
+      <p:sp>
+        <p:nvSpPr>
+          <p:cNvPr id="4" name="Rounded Rectangle 3"/>
+          <p:cNvSpPr/>
+          <p:nvPr/>
+        </p:nvSpPr>
+        <p:spPr>
+          <a:xfrm>
+            <a:off x="914400" y="429768"/>
+            <a:ext cx="2011680" cy="640080"/>
           </a:xfrm>
           <a:prstGeom prst="roundRect">
             <a:avLst/>
@@ -5089,7 +5122,7 @@
           </a:solidFill>
           <a:ln w="12700">
             <a:solidFill>
-              <a:srgbClr val="15803D"/>
+              <a:srgbClr val="22C55E"/>
             </a:solidFill>
           </a:ln>
         </p:spPr>
@@ -5117,7 +5150,7 @@
       </p:sp>
       <p:pic>
         <p:nvPicPr>
-          <p:cNvPr id="6" name="Picture 5" descr="logo.png"/>
+          <p:cNvPr id="5" name="Picture 4" descr="logo.png"/>
           <p:cNvPicPr>
             <a:picLocks noChangeAspect="1"/>
           </p:cNvPicPr>
@@ -5131,14 +5164,63 @@
         </p:blipFill>
         <p:spPr>
           <a:xfrm>
-            <a:off x="9784080" y="475488"/>
-            <a:ext cx="1645920" cy="548640"/>
+            <a:off x="1051560" y="484632"/>
+            <a:ext cx="1737360" cy="579120"/>
           </a:xfrm>
           <a:prstGeom prst="rect">
             <a:avLst/>
           </a:prstGeom>
         </p:spPr>
       </p:pic>
+      <p:sp>
+        <p:nvSpPr>
+          <p:cNvPr id="6" name="TextBox 5"/>
+          <p:cNvSpPr txBox="1"/>
+          <p:nvPr/>
+        </p:nvSpPr>
+        <p:spPr>
+          <a:xfrm>
+            <a:off x="3200400" y="365760"/>
+            <a:ext cx="8046720" cy="777240"/>
+          </a:xfrm>
+          <a:prstGeom prst="rect">
+            <a:avLst/>
+          </a:prstGeom>
+          <a:noFill/>
+        </p:spPr>
+        <p:txBody>
+          <a:bodyPr wrap="square">
+            <a:spAutoFit/>
+          </a:bodyPr>
+          <a:lstStyle/>
+          <a:p>
+            <a:pPr>
+              <a:defRPr sz="1000" b="1">
+                <a:solidFill>
+                  <a:srgbClr val="22C55E"/>
+                </a:solidFill>
+                <a:latin typeface="Plus Jakarta Sans"/>
+              </a:defRPr>
+            </a:pPr>
+            <a:r>
+              <a:t>КАТАЛОГ РЕШЕНИЙ ПО ОТДЕЛАМ</a:t>
+            </a:r>
+          </a:p>
+          <a:p>
+            <a:pPr>
+              <a:defRPr sz="1800" b="1">
+                <a:solidFill>
+                  <a:srgbClr val="FFFFFF"/>
+                </a:solidFill>
+                <a:latin typeface="Plus Jakarta Sans"/>
+              </a:defRPr>
+            </a:pPr>
+            <a:r>
+              <a:t>Комплексная оптимизация отделов супермаркета</a:t>
+            </a:r>
+          </a:p>
+        </p:txBody>
+      </p:sp>
       <p:sp>
         <p:nvSpPr>
           <p:cNvPr id="7" name="Rounded Rectangle 6"/>
@@ -5147,8 +5229,8 @@
         </p:nvSpPr>
         <p:spPr>
           <a:xfrm>
-            <a:off x="731520" y="1554480"/>
-            <a:ext cx="3383280" cy="4663440"/>
+            <a:off x="731520" y="1463040"/>
+            <a:ext cx="3383280" cy="4937760"/>
           </a:xfrm>
           <a:prstGeom prst="roundRect">
             <a:avLst/>
@@ -5158,7 +5240,7 @@
           </a:solidFill>
           <a:ln w="12700">
             <a:solidFill>
-              <a:srgbClr val="123524"/>
+              <a:srgbClr val="D8E2DC"/>
             </a:solidFill>
           </a:ln>
         </p:spPr>
@@ -5192,8 +5274,8 @@
         </p:nvSpPr>
         <p:spPr>
           <a:xfrm>
-            <a:off x="914400" y="1737360"/>
-            <a:ext cx="3017520" cy="4297680"/>
+            <a:off x="914400" y="1645920"/>
+            <a:ext cx="3017520" cy="4572000"/>
           </a:xfrm>
           <a:prstGeom prst="rect">
             <a:avLst/>
@@ -5207,7 +5289,7 @@
           <a:lstStyle/>
           <a:p>
             <a:pPr>
-              <a:defRPr sz="1200" b="1">
+              <a:defRPr sz="1100" b="1">
                 <a:solidFill>
                   <a:srgbClr val="15803D"/>
                 </a:solidFill>
@@ -5215,7 +5297,7 @@
               </a:defRPr>
             </a:pPr>
             <a:r>
-              <a:t>🥬 СВЕЖИЕ ОВОЩИ</a:t>
+              <a:t>🥬 СВЕЖИЕ ОВОЩИ И ЗЕЛЕНЬ</a:t>
             </a:r>
           </a:p>
           <a:p>
@@ -5233,7 +5315,7 @@
           </a:p>
           <a:p>
             <a:pPr>
-              <a:defRPr b="1" sz="1100">
+              <a:defRPr b="1" sz="1150">
                 <a:solidFill>
                   <a:srgbClr val="123524"/>
                 </a:solidFill>
@@ -5248,19 +5330,19 @@
                   <a:srgbClr val="526B5C"/>
                 </a:solidFill>
               </a:rPr>
-              <a:t>Конденсат, плесень, 28-35% списаний ягод и зелени.</a:t>
-            </a:r>
-          </a:p>
-          <a:p>
-            <a:pPr>
-              <a:defRPr b="1" sz="1100">
+              <a:t>Конденсат, плесень, 28-35% списаний зелени и ягод.</a:t>
+            </a:r>
+          </a:p>
+          <a:p>
+            <a:pPr>
+              <a:defRPr b="1" sz="1150">
                 <a:solidFill>
                   <a:srgbClr val="123524"/>
                 </a:solidFill>
               </a:defRPr>
             </a:pPr>
             <a:r>
-              <a:t>• Инновация: </a:t>
+              <a:t>• Технология: </a:t>
             </a:r>
             <a:r>
               <a:rPr b="0">
@@ -5268,12 +5350,12 @@
                   <a:srgbClr val="526B5C"/>
                 </a:solidFill>
               </a:rPr>
-              <a:t>Моно-пленка rBOPP с лазерной микроперфорацией. Динамический баланс O₂ (3-5%) и CO₂ (5-8%).</a:t>
-            </a:r>
-          </a:p>
-          <a:p>
-            <a:pPr>
-              <a:defRPr b="1" sz="1100">
+              <a:t>Моно-пленка rBOPP с лазерной микроперфорацией. Баланс O₂ (3-5%) и CO₂ (5-8%).</a:t>
+            </a:r>
+          </a:p>
+          <a:p>
+            <a:pPr>
+              <a:defRPr b="1" sz="1150">
                 <a:solidFill>
                   <a:srgbClr val="123524"/>
                 </a:solidFill>
@@ -5288,19 +5370,19 @@
                   <a:srgbClr val="526B5C"/>
                 </a:solidFill>
               </a:rPr>
-              <a:t>+4 дня к сроку годности на полке.</a:t>
-            </a:r>
-          </a:p>
-          <a:p>
-            <a:pPr>
-              <a:defRPr b="1" sz="1100">
+              <a:t>+4 дня срока годности на полке.</a:t>
+            </a:r>
+          </a:p>
+          <a:p>
+            <a:pPr>
+              <a:defRPr b="1" sz="1150">
                 <a:solidFill>
                   <a:srgbClr val="123524"/>
                 </a:solidFill>
               </a:defRPr>
             </a:pPr>
             <a:r>
-              <a:t>• Ритейл: </a:t>
+              <a:t>• Результат: </a:t>
             </a:r>
             <a:r>
               <a:rPr b="0">
@@ -5308,7 +5390,27 @@
                   <a:srgbClr val="526B5C"/>
                 </a:solidFill>
               </a:rPr>
-              <a:t>Снижение списаний в супермаркетах на 32%.</a:t>
+              <a:t>Сокращение списаний в супермаркетах на 32%.</a:t>
+            </a:r>
+          </a:p>
+          <a:p>
+            <a:pPr>
+              <a:defRPr b="1" sz="1150">
+                <a:solidFill>
+                  <a:srgbClr val="123524"/>
+                </a:solidFill>
+              </a:defRPr>
+            </a:pPr>
+            <a:r>
+              <a:t>• Материал: </a:t>
+            </a:r>
+            <a:r>
+              <a:rPr b="0">
+                <a:solidFill>
+                  <a:srgbClr val="526B5C"/>
+                </a:solidFill>
+              </a:rPr>
+              <a:t>Моно-rBOPP • 100% Recyclable.</a:t>
             </a:r>
           </a:p>
         </p:txBody>
@@ -5321,8 +5423,8 @@
         </p:nvSpPr>
         <p:spPr>
           <a:xfrm>
-            <a:off x="4389120" y="1554480"/>
-            <a:ext cx="3383280" cy="4663440"/>
+            <a:off x="4389120" y="1463040"/>
+            <a:ext cx="3383280" cy="4937760"/>
           </a:xfrm>
           <a:prstGeom prst="roundRect">
             <a:avLst/>
@@ -5332,7 +5434,7 @@
           </a:solidFill>
           <a:ln w="12700">
             <a:solidFill>
-              <a:srgbClr val="123524"/>
+              <a:srgbClr val="D8E2DC"/>
             </a:solidFill>
           </a:ln>
         </p:spPr>
@@ -5366,8 +5468,8 @@
         </p:nvSpPr>
         <p:spPr>
           <a:xfrm>
-            <a:off x="4572000" y="1737360"/>
-            <a:ext cx="3017520" cy="4297680"/>
+            <a:off x="4572000" y="1645920"/>
+            <a:ext cx="3017520" cy="4572000"/>
           </a:xfrm>
           <a:prstGeom prst="rect">
             <a:avLst/>
@@ -5381,7 +5483,7 @@
           <a:lstStyle/>
           <a:p>
             <a:pPr>
-              <a:defRPr sz="1200" b="1">
+              <a:defRPr sz="1100" b="1">
                 <a:solidFill>
                   <a:srgbClr val="15803D"/>
                 </a:solidFill>
@@ -5389,7 +5491,7 @@
               </a:defRPr>
             </a:pPr>
             <a:r>
-              <a:t>🥩 МЯСНОЙ ОТДЕЛ</a:t>
+              <a:t>🥩 МЯСНОЙ И РЫБНЫЙ ОТДЕЛ</a:t>
             </a:r>
           </a:p>
           <a:p>
@@ -5407,7 +5509,7 @@
           </a:p>
           <a:p>
             <a:pPr>
-              <a:defRPr b="1" sz="1100">
+              <a:defRPr b="1" sz="1150">
                 <a:solidFill>
                   <a:srgbClr val="123524"/>
                 </a:solidFill>
@@ -5422,19 +5524,19 @@
                   <a:srgbClr val="526B5C"/>
                 </a:solidFill>
               </a:rPr>
-              <a:t>Грязная салфетка-вкладыш делает лоток неперерабатываемым.</a:t>
-            </a:r>
-          </a:p>
-          <a:p>
-            <a:pPr>
-              <a:defRPr b="1" sz="1100">
+              <a:t>Грязная салфетка-вкладыш исключает лоток из рециклинга.</a:t>
+            </a:r>
+          </a:p>
+          <a:p>
+            <a:pPr>
+              <a:defRPr b="1" sz="1150">
                 <a:solidFill>
                   <a:srgbClr val="123524"/>
                 </a:solidFill>
               </a:defRPr>
             </a:pPr>
             <a:r>
-              <a:t>• Инновация: </a:t>
+              <a:t>• Технология: </a:t>
             </a:r>
             <a:r>
               <a:rPr b="0">
@@ -5442,12 +5544,12 @@
                   <a:srgbClr val="526B5C"/>
                 </a:solidFill>
               </a:rPr>
-              <a:t>Глубокоформованный моно-rPET лоток с капиллярным гидро-замком. Сбор до 45 мл экссудата.</a:t>
-            </a:r>
-          </a:p>
-          <a:p>
-            <a:pPr>
-              <a:defRPr b="1" sz="1100">
+              <a:t>Глубокоформованный моно-rPET лоток с капиллярным гидро-замком на 45 мл экссудата.</a:t>
+            </a:r>
+          </a:p>
+          <a:p>
+            <a:pPr>
+              <a:defRPr b="1" sz="1150">
                 <a:solidFill>
                   <a:srgbClr val="123524"/>
                 </a:solidFill>
@@ -5467,14 +5569,14 @@
           </a:p>
           <a:p>
             <a:pPr>
-              <a:defRPr b="1" sz="1100">
+              <a:defRPr b="1" sz="1150">
                 <a:solidFill>
                   <a:srgbClr val="123524"/>
                 </a:solidFill>
               </a:defRPr>
             </a:pPr>
             <a:r>
-              <a:t>• Рециклинг: </a:t>
+              <a:t>• Результат: </a:t>
             </a:r>
             <a:r>
               <a:rPr b="0">
@@ -5482,7 +5584,27 @@
                   <a:srgbClr val="526B5C"/>
                 </a:solidFill>
               </a:rPr>
-              <a:t>100% чистый поток сортировки и рециклинга.</a:t>
+              <a:t>100% чистый поток вторичной переработки.</a:t>
+            </a:r>
+          </a:p>
+          <a:p>
+            <a:pPr>
+              <a:defRPr b="1" sz="1150">
+                <a:solidFill>
+                  <a:srgbClr val="123524"/>
+                </a:solidFill>
+              </a:defRPr>
+            </a:pPr>
+            <a:r>
+              <a:t>• Материал: </a:t>
+            </a:r>
+            <a:r>
+              <a:rPr b="0">
+                <a:solidFill>
+                  <a:srgbClr val="526B5C"/>
+                </a:solidFill>
+              </a:rPr>
+              <a:t>85% rPET • RecyClass Class A.</a:t>
             </a:r>
           </a:p>
         </p:txBody>
@@ -5495,8 +5617,8 @@
         </p:nvSpPr>
         <p:spPr>
           <a:xfrm>
-            <a:off x="8046720" y="1554480"/>
-            <a:ext cx="3383280" cy="4663440"/>
+            <a:off x="8046720" y="1463040"/>
+            <a:ext cx="3383280" cy="4937760"/>
           </a:xfrm>
           <a:prstGeom prst="roundRect">
             <a:avLst/>
@@ -5506,7 +5628,7 @@
           </a:solidFill>
           <a:ln w="12700">
             <a:solidFill>
-              <a:srgbClr val="123524"/>
+              <a:srgbClr val="D8E2DC"/>
             </a:solidFill>
           </a:ln>
         </p:spPr>
@@ -5540,8 +5662,8 @@
         </p:nvSpPr>
         <p:spPr>
           <a:xfrm>
-            <a:off x="8229600" y="1737360"/>
-            <a:ext cx="3017520" cy="4297680"/>
+            <a:off x="8229600" y="1645920"/>
+            <a:ext cx="3017520" cy="4572000"/>
           </a:xfrm>
           <a:prstGeom prst="rect">
             <a:avLst/>
@@ -5555,7 +5677,7 @@
           <a:lstStyle/>
           <a:p>
             <a:pPr>
-              <a:defRPr sz="1200" b="1">
+              <a:defRPr sz="1100" b="1">
                 <a:solidFill>
                   <a:srgbClr val="15803D"/>
                 </a:solidFill>
@@ -5563,7 +5685,7 @@
               </a:defRPr>
             </a:pPr>
             <a:r>
-              <a:t>🥐 ПЕКАРНЯ</a:t>
+              <a:t>🥐 ПЕКАРНЯ И ВЫПЕЧКА</a:t>
             </a:r>
           </a:p>
           <a:p>
@@ -5581,7 +5703,7 @@
           </a:p>
           <a:p>
             <a:pPr>
-              <a:defRPr b="1" sz="1100">
+              <a:defRPr b="1" sz="1150">
                 <a:solidFill>
                   <a:srgbClr val="123524"/>
                 </a:solidFill>
@@ -5596,19 +5718,19 @@
                   <a:srgbClr val="526B5C"/>
                 </a:solidFill>
               </a:rPr>
-              <a:t>Полиэтиленовые окна пакетов сжигаются на полигоне.</a:t>
-            </a:r>
-          </a:p>
-          <a:p>
-            <a:pPr>
-              <a:defRPr b="1" sz="1100">
+              <a:t>Пакеты с пластиковыми окнами не перерабатываются.</a:t>
+            </a:r>
+          </a:p>
+          <a:p>
+            <a:pPr>
+              <a:defRPr b="1" sz="1150">
                 <a:solidFill>
                   <a:srgbClr val="123524"/>
                 </a:solidFill>
               </a:defRPr>
             </a:pPr>
             <a:r>
-              <a:t>• Инновация: </a:t>
+              <a:t>• Технология: </a:t>
             </a:r>
             <a:r>
               <a:rPr b="0">
@@ -5616,12 +5738,12 @@
                   <a:srgbClr val="526B5C"/>
                 </a:solidFill>
               </a:rPr>
-              <a:t>Крафт FSC + прозрачное смотровое био-окно NatureFlex™ из древесной массы + био-воск.</a:t>
-            </a:r>
-          </a:p>
-          <a:p>
-            <a:pPr>
-              <a:defRPr b="1" sz="1100">
+              <a:t>Крафт FSC + прозрачное смотровое окно NatureFlex™ из древесной массы + био-воск.</a:t>
+            </a:r>
+          </a:p>
+          <a:p>
+            <a:pPr>
+              <a:defRPr b="1" sz="1150">
                 <a:solidFill>
                   <a:srgbClr val="123524"/>
                 </a:solidFill>
@@ -5636,19 +5758,19 @@
                   <a:srgbClr val="526B5C"/>
                 </a:solidFill>
               </a:rPr>
-              <a:t>Сохранение хрустящей корочки выпечки.</a:t>
-            </a:r>
-          </a:p>
-          <a:p>
-            <a:pPr>
-              <a:defRPr b="1" sz="1100">
+              <a:t>Сохранение хрустящей корочки круассанов.</a:t>
+            </a:r>
+          </a:p>
+          <a:p>
+            <a:pPr>
+              <a:defRPr b="1" sz="1150">
                 <a:solidFill>
                   <a:srgbClr val="123524"/>
                 </a:solidFill>
               </a:defRPr>
             </a:pPr>
             <a:r>
-              <a:t>• Рециклинг: </a:t>
+              <a:t>• Результат: </a:t>
             </a:r>
             <a:r>
               <a:rPr b="0">
@@ -5656,7 +5778,27 @@
                   <a:srgbClr val="526B5C"/>
                 </a:solidFill>
               </a:rPr>
-              <a:t>100% Pulpable (полная переработка с бумагой).</a:t>
+              <a:t>100% Pulpable (переработка с бумагой).</a:t>
+            </a:r>
+          </a:p>
+          <a:p>
+            <a:pPr>
+              <a:defRPr b="1" sz="1150">
+                <a:solidFill>
+                  <a:srgbClr val="123524"/>
+                </a:solidFill>
+              </a:defRPr>
+            </a:pPr>
+            <a:r>
+              <a:t>• Материал: </a:t>
+            </a:r>
+            <a:r>
+              <a:rPr b="0">
+                <a:solidFill>
+                  <a:srgbClr val="526B5C"/>
+                </a:solidFill>
+              </a:rPr>
+              <a:t>Крафт FSC + целлюлоза • 0% ПЭ.</a:t>
             </a:r>
           </a:p>
         </p:txBody>
@@ -5694,11 +5836,11 @@
             <a:avLst/>
           </a:prstGeom>
           <a:solidFill>
-            <a:srgbClr val="123524"/>
+            <a:srgbClr val="FAF4E4"/>
           </a:solidFill>
           <a:ln>
             <a:solidFill>
-              <a:srgbClr val="123524"/>
+              <a:srgbClr val="FAF4E4"/>
             </a:solidFill>
           </a:ln>
         </p:spPr>
@@ -5726,86 +5868,59 @@
       </p:sp>
       <p:sp>
         <p:nvSpPr>
-          <p:cNvPr id="3" name="TextBox 2"/>
-          <p:cNvSpPr txBox="1"/>
-          <p:nvPr/>
-        </p:nvSpPr>
-        <p:spPr>
-          <a:xfrm>
-            <a:off x="731520" y="411480"/>
-            <a:ext cx="8229600" cy="320040"/>
-          </a:xfrm>
-          <a:prstGeom prst="rect">
-            <a:avLst/>
-          </a:prstGeom>
-          <a:noFill/>
-        </p:spPr>
-        <p:txBody>
-          <a:bodyPr wrap="square">
-            <a:spAutoFit/>
-          </a:bodyPr>
-          <a:lstStyle/>
-          <a:p>
-            <a:pPr>
-              <a:defRPr sz="1100" b="1">
-                <a:solidFill>
-                  <a:srgbClr val="22C55E"/>
-                </a:solidFill>
-                <a:latin typeface="Plus Jakarta Sans"/>
-              </a:defRPr>
-            </a:pPr>
-            <a:r>
-              <a:t>DEEPTECH GIGAHACK 2026 • BIOMENTORHUB × PROFI</a:t>
-            </a:r>
-          </a:p>
-        </p:txBody>
-      </p:sp>
-      <p:sp>
-        <p:nvSpPr>
-          <p:cNvPr id="4" name="TextBox 3"/>
-          <p:cNvSpPr txBox="1"/>
-          <p:nvPr/>
-        </p:nvSpPr>
-        <p:spPr>
-          <a:xfrm>
-            <a:off x="731520" y="685800"/>
-            <a:ext cx="8686800" cy="731520"/>
-          </a:xfrm>
-          <a:prstGeom prst="rect">
-            <a:avLst/>
-          </a:prstGeom>
-          <a:noFill/>
-        </p:spPr>
-        <p:txBody>
-          <a:bodyPr wrap="square">
-            <a:spAutoFit/>
-          </a:bodyPr>
-          <a:lstStyle/>
-          <a:p>
-            <a:pPr>
-              <a:defRPr sz="2400" b="1">
-                <a:solidFill>
-                  <a:srgbClr val="FFFFFF"/>
-                </a:solidFill>
-                <a:latin typeface="Plus Jakarta Sans"/>
-              </a:defRPr>
-            </a:pPr>
-            <a:r>
-              <a:t>Экономика и ESG-эффект: Калькулятор для сети Profi</a:t>
-            </a:r>
-          </a:p>
-        </p:txBody>
-      </p:sp>
-      <p:sp>
-        <p:nvSpPr>
-          <p:cNvPr id="5" name="Rounded Rectangle 4"/>
+          <p:cNvPr id="3" name="Rounded Rectangle 2"/>
           <p:cNvSpPr/>
           <p:nvPr/>
         </p:nvSpPr>
         <p:spPr>
           <a:xfrm>
-            <a:off x="9692640" y="411480"/>
-            <a:ext cx="1828800" cy="685800"/>
+            <a:off x="731520" y="320040"/>
+            <a:ext cx="10728655" cy="868680"/>
+          </a:xfrm>
+          <a:prstGeom prst="roundRect">
+            <a:avLst/>
+          </a:prstGeom>
+          <a:solidFill>
+            <a:srgbClr val="123524"/>
+          </a:solidFill>
+          <a:ln w="12700">
+            <a:solidFill>
+              <a:srgbClr val="22C55E"/>
+            </a:solidFill>
+          </a:ln>
+        </p:spPr>
+        <p:style>
+          <a:lnRef idx="1">
+            <a:schemeClr val="accent1"/>
+          </a:lnRef>
+          <a:fillRef idx="3">
+            <a:schemeClr val="accent1"/>
+          </a:fillRef>
+          <a:effectRef idx="2">
+            <a:schemeClr val="accent1"/>
+          </a:effectRef>
+          <a:fontRef idx="minor">
+            <a:schemeClr val="lt1"/>
+          </a:fontRef>
+        </p:style>
+        <p:txBody>
+          <a:bodyPr rtlCol="0" anchor="ctr"/>
+          <a:lstStyle/>
+          <a:p>
+            <a:pPr algn="ctr"/>
+          </a:p>
+        </p:txBody>
+      </p:sp>
+      <p:sp>
+        <p:nvSpPr>
+          <p:cNvPr id="4" name="Rounded Rectangle 3"/>
+          <p:cNvSpPr/>
+          <p:nvPr/>
+        </p:nvSpPr>
+        <p:spPr>
+          <a:xfrm>
+            <a:off x="914400" y="429768"/>
+            <a:ext cx="2011680" cy="640080"/>
           </a:xfrm>
           <a:prstGeom prst="roundRect">
             <a:avLst/>
@@ -5843,7 +5958,7 @@
       </p:sp>
       <p:pic>
         <p:nvPicPr>
-          <p:cNvPr id="6" name="Picture 5" descr="logo.png"/>
+          <p:cNvPr id="5" name="Picture 4" descr="logo.png"/>
           <p:cNvPicPr>
             <a:picLocks noChangeAspect="1"/>
           </p:cNvPicPr>
@@ -5857,14 +5972,63 @@
         </p:blipFill>
         <p:spPr>
           <a:xfrm>
-            <a:off x="9784080" y="475488"/>
-            <a:ext cx="1645920" cy="548640"/>
+            <a:off x="1051560" y="484632"/>
+            <a:ext cx="1737360" cy="579120"/>
           </a:xfrm>
           <a:prstGeom prst="rect">
             <a:avLst/>
           </a:prstGeom>
         </p:spPr>
       </p:pic>
+      <p:sp>
+        <p:nvSpPr>
+          <p:cNvPr id="6" name="TextBox 5"/>
+          <p:cNvSpPr txBox="1"/>
+          <p:nvPr/>
+        </p:nvSpPr>
+        <p:spPr>
+          <a:xfrm>
+            <a:off x="3200400" y="365760"/>
+            <a:ext cx="8046720" cy="777240"/>
+          </a:xfrm>
+          <a:prstGeom prst="rect">
+            <a:avLst/>
+          </a:prstGeom>
+          <a:noFill/>
+        </p:spPr>
+        <p:txBody>
+          <a:bodyPr wrap="square">
+            <a:spAutoFit/>
+          </a:bodyPr>
+          <a:lstStyle/>
+          <a:p>
+            <a:pPr>
+              <a:defRPr sz="1000" b="1">
+                <a:solidFill>
+                  <a:srgbClr val="22C55E"/>
+                </a:solidFill>
+                <a:latin typeface="Plus Jakarta Sans"/>
+              </a:defRPr>
+            </a:pPr>
+            <a:r>
+              <a:t>ИНТЕРАКТИВНАЯ АНАЛИТИКА</a:t>
+            </a:r>
+          </a:p>
+          <a:p>
+            <a:pPr>
+              <a:defRPr sz="1800" b="1">
+                <a:solidFill>
+                  <a:srgbClr val="FFFFFF"/>
+                </a:solidFill>
+                <a:latin typeface="Plus Jakarta Sans"/>
+              </a:defRPr>
+            </a:pPr>
+            <a:r>
+              <a:t>Калькулятор ESG-эффекта и экономии для сети Profi</a:t>
+            </a:r>
+          </a:p>
+        </p:txBody>
+      </p:sp>
       <p:sp>
         <p:nvSpPr>
           <p:cNvPr id="7" name="Rounded Rectangle 6"/>
@@ -5874,15 +6038,15 @@
         <p:spPr>
           <a:xfrm>
             <a:off x="731520" y="1463040"/>
-            <a:ext cx="10698480" cy="685800"/>
+            <a:ext cx="10728655" cy="4937760"/>
           </a:xfrm>
           <a:prstGeom prst="roundRect">
             <a:avLst/>
           </a:prstGeom>
           <a:solidFill>
-            <a:srgbClr val="153E2B"/>
+            <a:srgbClr val="123524"/>
           </a:solidFill>
-          <a:ln w="12700">
+          <a:ln w="19050">
             <a:solidFill>
               <a:srgbClr val="22C55E"/>
             </a:solidFill>
@@ -5906,8 +6070,34 @@
           <a:bodyPr rtlCol="0" anchor="ctr"/>
           <a:lstStyle/>
           <a:p>
-            <a:pPr algn="ctr">
-              <a:defRPr sz="1400" b="1">
+            <a:pPr algn="ctr"/>
+          </a:p>
+        </p:txBody>
+      </p:sp>
+      <p:sp>
+        <p:nvSpPr>
+          <p:cNvPr id="8" name="TextBox 7"/>
+          <p:cNvSpPr txBox="1"/>
+          <p:nvPr/>
+        </p:nvSpPr>
+        <p:spPr>
+          <a:xfrm>
+            <a:off x="1005840" y="1645920"/>
+            <a:ext cx="10149840" cy="731520"/>
+          </a:xfrm>
+          <a:prstGeom prst="rect">
+            <a:avLst/>
+          </a:prstGeom>
+          <a:noFill/>
+        </p:spPr>
+        <p:txBody>
+          <a:bodyPr wrap="square">
+            <a:spAutoFit/>
+          </a:bodyPr>
+          <a:lstStyle/>
+          <a:p>
+            <a:pPr>
+              <a:defRPr sz="1800" b="1">
                 <a:solidFill>
                   <a:srgbClr val="FFFFFF"/>
                 </a:solidFill>
@@ -5915,21 +6105,21 @@
               </a:defRPr>
             </a:pPr>
             <a:r>
-              <a:t>🎯 Моделирование эффекта на масштабе 100 супермаркетов Profi (базовый охват)</a:t>
-            </a:r>
-          </a:p>
-        </p:txBody>
-      </p:sp>
-      <p:sp>
-        <p:nvSpPr>
-          <p:cNvPr id="8" name="Rounded Rectangle 7"/>
+              <a:t>🎯 Моделирование эффекта на масштабе 100 супермаркетов Profi:</a:t>
+            </a:r>
+          </a:p>
+        </p:txBody>
+      </p:sp>
+      <p:sp>
+        <p:nvSpPr>
+          <p:cNvPr id="9" name="Rounded Rectangle 8"/>
           <p:cNvSpPr/>
           <p:nvPr/>
         </p:nvSpPr>
         <p:spPr>
           <a:xfrm>
-            <a:off x="731520" y="2377440"/>
-            <a:ext cx="2514600" cy="2743200"/>
+            <a:off x="1005840" y="2468880"/>
+            <a:ext cx="2377440" cy="2468880"/>
           </a:xfrm>
           <a:prstGeom prst="roundRect">
             <a:avLst/>
@@ -5967,14 +6157,14 @@
       </p:sp>
       <p:sp>
         <p:nvSpPr>
-          <p:cNvPr id="9" name="TextBox 8"/>
+          <p:cNvPr id="10" name="TextBox 9"/>
           <p:cNvSpPr txBox="1"/>
           <p:nvPr/>
         </p:nvSpPr>
         <p:spPr>
           <a:xfrm>
-            <a:off x="868680" y="2560320"/>
-            <a:ext cx="2240280" cy="2377440"/>
+            <a:off x="1115568" y="2606040"/>
+            <a:ext cx="2157984" cy="2194560"/>
           </a:xfrm>
           <a:prstGeom prst="rect">
             <a:avLst/>
@@ -5988,7 +6178,7 @@
           <a:lstStyle/>
           <a:p>
             <a:pPr>
-              <a:defRPr sz="2600" b="1">
+              <a:defRPr sz="2400" b="1">
                 <a:solidFill>
                   <a:srgbClr val="22C55E"/>
                 </a:solidFill>
@@ -6001,7 +6191,7 @@
           </a:p>
           <a:p>
             <a:pPr>
-              <a:defRPr sz="1400" b="1">
+              <a:defRPr sz="1300" b="1">
                 <a:solidFill>
                   <a:srgbClr val="FFFFFF"/>
                 </a:solidFill>
@@ -6014,7 +6204,7 @@
           </a:p>
           <a:p>
             <a:pPr>
-              <a:defRPr sz="1100">
+              <a:defRPr sz="1050">
                 <a:solidFill>
                   <a:srgbClr val="FAF4E4"/>
                 </a:solidFill>
@@ -6029,14 +6219,14 @@
       </p:sp>
       <p:sp>
         <p:nvSpPr>
-          <p:cNvPr id="10" name="Rounded Rectangle 9"/>
+          <p:cNvPr id="11" name="Rounded Rectangle 10"/>
           <p:cNvSpPr/>
           <p:nvPr/>
         </p:nvSpPr>
         <p:spPr>
           <a:xfrm>
-            <a:off x="3456432" y="2377440"/>
-            <a:ext cx="2514600" cy="2743200"/>
+            <a:off x="3602736" y="2468880"/>
+            <a:ext cx="2377440" cy="2468880"/>
           </a:xfrm>
           <a:prstGeom prst="roundRect">
             <a:avLst/>
@@ -6074,14 +6264,14 @@
       </p:sp>
       <p:sp>
         <p:nvSpPr>
-          <p:cNvPr id="11" name="TextBox 10"/>
+          <p:cNvPr id="12" name="TextBox 11"/>
           <p:cNvSpPr txBox="1"/>
           <p:nvPr/>
         </p:nvSpPr>
         <p:spPr>
           <a:xfrm>
-            <a:off x="3593592" y="2560320"/>
-            <a:ext cx="2240280" cy="2377440"/>
+            <a:off x="3712464" y="2606040"/>
+            <a:ext cx="2157984" cy="2194560"/>
           </a:xfrm>
           <a:prstGeom prst="rect">
             <a:avLst/>
@@ -6095,7 +6285,7 @@
           <a:lstStyle/>
           <a:p>
             <a:pPr>
-              <a:defRPr sz="2600" b="1">
+              <a:defRPr sz="2400" b="1">
                 <a:solidFill>
                   <a:srgbClr val="22C55E"/>
                 </a:solidFill>
@@ -6108,7 +6298,7 @@
           </a:p>
           <a:p>
             <a:pPr>
-              <a:defRPr sz="1400" b="1">
+              <a:defRPr sz="1300" b="1">
                 <a:solidFill>
                   <a:srgbClr val="FFFFFF"/>
                 </a:solidFill>
@@ -6121,7 +6311,7 @@
           </a:p>
           <a:p>
             <a:pPr>
-              <a:defRPr sz="1100">
+              <a:defRPr sz="1050">
                 <a:solidFill>
                   <a:srgbClr val="FAF4E4"/>
                 </a:solidFill>
@@ -6136,14 +6326,14 @@
       </p:sp>
       <p:sp>
         <p:nvSpPr>
-          <p:cNvPr id="12" name="Rounded Rectangle 11"/>
+          <p:cNvPr id="13" name="Rounded Rectangle 12"/>
           <p:cNvSpPr/>
           <p:nvPr/>
         </p:nvSpPr>
         <p:spPr>
           <a:xfrm>
-            <a:off x="6181344" y="2377440"/>
-            <a:ext cx="2514600" cy="2743200"/>
+            <a:off x="6199632" y="2468880"/>
+            <a:ext cx="2377440" cy="2468880"/>
           </a:xfrm>
           <a:prstGeom prst="roundRect">
             <a:avLst/>
@@ -6181,14 +6371,14 @@
       </p:sp>
       <p:sp>
         <p:nvSpPr>
-          <p:cNvPr id="13" name="TextBox 12"/>
+          <p:cNvPr id="14" name="TextBox 13"/>
           <p:cNvSpPr txBox="1"/>
           <p:nvPr/>
         </p:nvSpPr>
         <p:spPr>
           <a:xfrm>
-            <a:off x="6318504" y="2560320"/>
-            <a:ext cx="2240280" cy="2377440"/>
+            <a:off x="6309360" y="2606040"/>
+            <a:ext cx="2157984" cy="2194560"/>
           </a:xfrm>
           <a:prstGeom prst="rect">
             <a:avLst/>
@@ -6202,7 +6392,7 @@
           <a:lstStyle/>
           <a:p>
             <a:pPr>
-              <a:defRPr sz="2600" b="1">
+              <a:defRPr sz="2400" b="1">
                 <a:solidFill>
                   <a:srgbClr val="22C55E"/>
                 </a:solidFill>
@@ -6215,7 +6405,7 @@
           </a:p>
           <a:p>
             <a:pPr>
-              <a:defRPr sz="1400" b="1">
+              <a:defRPr sz="1300" b="1">
                 <a:solidFill>
                   <a:srgbClr val="FFFFFF"/>
                 </a:solidFill>
@@ -6228,7 +6418,7 @@
           </a:p>
           <a:p>
             <a:pPr>
-              <a:defRPr sz="1100">
+              <a:defRPr sz="1050">
                 <a:solidFill>
                   <a:srgbClr val="FAF4E4"/>
                 </a:solidFill>
@@ -6243,14 +6433,14 @@
       </p:sp>
       <p:sp>
         <p:nvSpPr>
-          <p:cNvPr id="14" name="Rounded Rectangle 13"/>
+          <p:cNvPr id="15" name="Rounded Rectangle 14"/>
           <p:cNvSpPr/>
           <p:nvPr/>
         </p:nvSpPr>
         <p:spPr>
           <a:xfrm>
-            <a:off x="8906256" y="2377440"/>
-            <a:ext cx="2514600" cy="2743200"/>
+            <a:off x="8796528" y="2468880"/>
+            <a:ext cx="2377440" cy="2468880"/>
           </a:xfrm>
           <a:prstGeom prst="roundRect">
             <a:avLst/>
@@ -6288,14 +6478,14 @@
       </p:sp>
       <p:sp>
         <p:nvSpPr>
-          <p:cNvPr id="15" name="TextBox 14"/>
+          <p:cNvPr id="16" name="TextBox 15"/>
           <p:cNvSpPr txBox="1"/>
           <p:nvPr/>
         </p:nvSpPr>
         <p:spPr>
           <a:xfrm>
-            <a:off x="9043416" y="2560320"/>
-            <a:ext cx="2240280" cy="2377440"/>
+            <a:off x="8906256" y="2606040"/>
+            <a:ext cx="2157984" cy="2194560"/>
           </a:xfrm>
           <a:prstGeom prst="rect">
             <a:avLst/>
@@ -6309,7 +6499,7 @@
           <a:lstStyle/>
           <a:p>
             <a:pPr>
-              <a:defRPr sz="2600" b="1">
+              <a:defRPr sz="2400" b="1">
                 <a:solidFill>
                   <a:srgbClr val="22C55E"/>
                 </a:solidFill>
@@ -6322,7 +6512,7 @@
           </a:p>
           <a:p>
             <a:pPr>
-              <a:defRPr sz="1400" b="1">
+              <a:defRPr sz="1300" b="1">
                 <a:solidFill>
                   <a:srgbClr val="FFFFFF"/>
                 </a:solidFill>
@@ -6335,7 +6525,7 @@
           </a:p>
           <a:p>
             <a:pPr>
-              <a:defRPr sz="1100">
+              <a:defRPr sz="1050">
                 <a:solidFill>
                   <a:srgbClr val="FAF4E4"/>
                 </a:solidFill>
@@ -6350,46 +6540,27 @@
       </p:sp>
       <p:sp>
         <p:nvSpPr>
-          <p:cNvPr id="16" name="Rounded Rectangle 15"/>
-          <p:cNvSpPr/>
-          <p:nvPr/>
-        </p:nvSpPr>
-        <p:spPr>
-          <a:xfrm>
-            <a:off x="731520" y="5349240"/>
-            <a:ext cx="10698480" cy="868680"/>
-          </a:xfrm>
-          <a:prstGeom prst="roundRect">
-            <a:avLst/>
-          </a:prstGeom>
-          <a:solidFill>
-            <a:srgbClr val="153E2B"/>
-          </a:solidFill>
-          <a:ln w="12700">
-            <a:solidFill>
-              <a:srgbClr val="22C55E"/>
-            </a:solidFill>
-          </a:ln>
-        </p:spPr>
-        <p:style>
-          <a:lnRef idx="1">
-            <a:schemeClr val="accent1"/>
-          </a:lnRef>
-          <a:fillRef idx="3">
-            <a:schemeClr val="accent1"/>
-          </a:fillRef>
-          <a:effectRef idx="2">
-            <a:schemeClr val="accent1"/>
-          </a:effectRef>
-          <a:fontRef idx="minor">
-            <a:schemeClr val="lt1"/>
-          </a:fontRef>
-        </p:style>
-        <p:txBody>
-          <a:bodyPr rtlCol="0" anchor="ctr" wrap="square"/>
-          <a:lstStyle/>
-          <a:p>
-            <a:pPr algn="ctr">
+          <p:cNvPr id="17" name="TextBox 16"/>
+          <p:cNvSpPr txBox="1"/>
+          <p:nvPr/>
+        </p:nvSpPr>
+        <p:spPr>
+          <a:xfrm>
+            <a:off x="1005840" y="5212080"/>
+            <a:ext cx="10149840" cy="914400"/>
+          </a:xfrm>
+          <a:prstGeom prst="rect">
+            <a:avLst/>
+          </a:prstGeom>
+          <a:noFill/>
+        </p:spPr>
+        <p:txBody>
+          <a:bodyPr wrap="square">
+            <a:spAutoFit/>
+          </a:bodyPr>
+          <a:lstStyle/>
+          <a:p>
+            <a:pPr>
               <a:defRPr b="1" sz="1300">
                 <a:solidFill>
                   <a:srgbClr val="22C55E"/>
@@ -6397,7 +6568,7 @@
               </a:defRPr>
             </a:pPr>
             <a:r>
-              <a:t>💡 Нулевой CapEx для ритейлера:</a:t>
+              <a:t>💡 Нулевой CapEx для ритейлера: </a:t>
             </a:r>
             <a:r>
               <a:rPr b="0">
@@ -6405,7 +6576,7 @@
                   <a:srgbClr val="FFFFFF"/>
                 </a:solidFill>
               </a:rPr>
-              <a:t> Упаковка PackShift полностью адаптирована под стандартные упаковочные линии, запайщики лотков и витрины сети Profi. Переоборудование магазинов не требуется.</a:t>
+              <a:t>Упаковка PackShift полностью адаптирована под запайщики, весы и витрины сети Profi. Себестоимость моно-пакетов CPET на 14% ниже импортных фольгированных ламинатов.</a:t>
             </a:r>
           </a:p>
         </p:txBody>
@@ -6475,86 +6646,59 @@
       </p:sp>
       <p:sp>
         <p:nvSpPr>
-          <p:cNvPr id="3" name="TextBox 2"/>
-          <p:cNvSpPr txBox="1"/>
-          <p:nvPr/>
-        </p:nvSpPr>
-        <p:spPr>
-          <a:xfrm>
-            <a:off x="731520" y="411480"/>
-            <a:ext cx="8229600" cy="320040"/>
-          </a:xfrm>
-          <a:prstGeom prst="rect">
-            <a:avLst/>
-          </a:prstGeom>
-          <a:noFill/>
-        </p:spPr>
-        <p:txBody>
-          <a:bodyPr wrap="square">
-            <a:spAutoFit/>
-          </a:bodyPr>
-          <a:lstStyle/>
-          <a:p>
-            <a:pPr>
-              <a:defRPr sz="1100" b="1">
-                <a:solidFill>
-                  <a:srgbClr val="15803D"/>
-                </a:solidFill>
-                <a:latin typeface="Plus Jakarta Sans"/>
-              </a:defRPr>
-            </a:pPr>
-            <a:r>
-              <a:t>DEEPTECH GIGAHACK 2026 • BIOMENTORHUB × PROFI</a:t>
-            </a:r>
-          </a:p>
-        </p:txBody>
-      </p:sp>
-      <p:sp>
-        <p:nvSpPr>
-          <p:cNvPr id="4" name="TextBox 3"/>
-          <p:cNvSpPr txBox="1"/>
-          <p:nvPr/>
-        </p:nvSpPr>
-        <p:spPr>
-          <a:xfrm>
-            <a:off x="731520" y="685800"/>
-            <a:ext cx="8686800" cy="731520"/>
-          </a:xfrm>
-          <a:prstGeom prst="rect">
-            <a:avLst/>
-          </a:prstGeom>
-          <a:noFill/>
-        </p:spPr>
-        <p:txBody>
-          <a:bodyPr wrap="square">
-            <a:spAutoFit/>
-          </a:bodyPr>
-          <a:lstStyle/>
-          <a:p>
-            <a:pPr>
-              <a:defRPr sz="2400" b="1">
-                <a:solidFill>
-                  <a:srgbClr val="123524"/>
-                </a:solidFill>
-                <a:latin typeface="Plus Jakarta Sans"/>
-              </a:defRPr>
-            </a:pPr>
-            <a:r>
-              <a:t>Стандарты и Сертификация: Регуляторный щит Profi</a:t>
-            </a:r>
-          </a:p>
-        </p:txBody>
-      </p:sp>
-      <p:sp>
-        <p:nvSpPr>
-          <p:cNvPr id="5" name="Rounded Rectangle 4"/>
+          <p:cNvPr id="3" name="Rounded Rectangle 2"/>
           <p:cNvSpPr/>
           <p:nvPr/>
         </p:nvSpPr>
         <p:spPr>
           <a:xfrm>
-            <a:off x="9692640" y="411480"/>
-            <a:ext cx="1828800" cy="685800"/>
+            <a:off x="731520" y="320040"/>
+            <a:ext cx="10728655" cy="868680"/>
+          </a:xfrm>
+          <a:prstGeom prst="roundRect">
+            <a:avLst/>
+          </a:prstGeom>
+          <a:solidFill>
+            <a:srgbClr val="123524"/>
+          </a:solidFill>
+          <a:ln w="12700">
+            <a:solidFill>
+              <a:srgbClr val="22C55E"/>
+            </a:solidFill>
+          </a:ln>
+        </p:spPr>
+        <p:style>
+          <a:lnRef idx="1">
+            <a:schemeClr val="accent1"/>
+          </a:lnRef>
+          <a:fillRef idx="3">
+            <a:schemeClr val="accent1"/>
+          </a:fillRef>
+          <a:effectRef idx="2">
+            <a:schemeClr val="accent1"/>
+          </a:effectRef>
+          <a:fontRef idx="minor">
+            <a:schemeClr val="lt1"/>
+          </a:fontRef>
+        </p:style>
+        <p:txBody>
+          <a:bodyPr rtlCol="0" anchor="ctr"/>
+          <a:lstStyle/>
+          <a:p>
+            <a:pPr algn="ctr"/>
+          </a:p>
+        </p:txBody>
+      </p:sp>
+      <p:sp>
+        <p:nvSpPr>
+          <p:cNvPr id="4" name="Rounded Rectangle 3"/>
+          <p:cNvSpPr/>
+          <p:nvPr/>
+        </p:nvSpPr>
+        <p:spPr>
+          <a:xfrm>
+            <a:off x="914400" y="429768"/>
+            <a:ext cx="2011680" cy="640080"/>
           </a:xfrm>
           <a:prstGeom prst="roundRect">
             <a:avLst/>
@@ -6564,7 +6708,7 @@
           </a:solidFill>
           <a:ln w="12700">
             <a:solidFill>
-              <a:srgbClr val="15803D"/>
+              <a:srgbClr val="22C55E"/>
             </a:solidFill>
           </a:ln>
         </p:spPr>
@@ -6592,7 +6736,7 @@
       </p:sp>
       <p:pic>
         <p:nvPicPr>
-          <p:cNvPr id="6" name="Picture 5" descr="logo.png"/>
+          <p:cNvPr id="5" name="Picture 4" descr="logo.png"/>
           <p:cNvPicPr>
             <a:picLocks noChangeAspect="1"/>
           </p:cNvPicPr>
@@ -6606,14 +6750,63 @@
         </p:blipFill>
         <p:spPr>
           <a:xfrm>
-            <a:off x="9784080" y="475488"/>
-            <a:ext cx="1645920" cy="548640"/>
+            <a:off x="1051560" y="484632"/>
+            <a:ext cx="1737360" cy="579120"/>
           </a:xfrm>
           <a:prstGeom prst="rect">
             <a:avLst/>
           </a:prstGeom>
         </p:spPr>
       </p:pic>
+      <p:sp>
+        <p:nvSpPr>
+          <p:cNvPr id="6" name="TextBox 5"/>
+          <p:cNvSpPr txBox="1"/>
+          <p:nvPr/>
+        </p:nvSpPr>
+        <p:spPr>
+          <a:xfrm>
+            <a:off x="3200400" y="365760"/>
+            <a:ext cx="8046720" cy="777240"/>
+          </a:xfrm>
+          <a:prstGeom prst="rect">
+            <a:avLst/>
+          </a:prstGeom>
+          <a:noFill/>
+        </p:spPr>
+        <p:txBody>
+          <a:bodyPr wrap="square">
+            <a:spAutoFit/>
+          </a:bodyPr>
+          <a:lstStyle/>
+          <a:p>
+            <a:pPr>
+              <a:defRPr sz="1000" b="1">
+                <a:solidFill>
+                  <a:srgbClr val="22C55E"/>
+                </a:solidFill>
+                <a:latin typeface="Plus Jakarta Sans"/>
+              </a:defRPr>
+            </a:pPr>
+            <a:r>
+              <a:t>МЕЖДУНАРОДНАЯ СЕРТИФИКАЦИЯ</a:t>
+            </a:r>
+          </a:p>
+          <a:p>
+            <a:pPr>
+              <a:defRPr sz="1800" b="1">
+                <a:solidFill>
+                  <a:srgbClr val="FFFFFF"/>
+                </a:solidFill>
+                <a:latin typeface="Plus Jakarta Sans"/>
+              </a:defRPr>
+            </a:pPr>
+            <a:r>
+              <a:t>Соответствие европейским и национальным регуляциям</a:t>
+            </a:r>
+          </a:p>
+        </p:txBody>
+      </p:sp>
       <p:sp>
         <p:nvSpPr>
           <p:cNvPr id="7" name="Rounded Rectangle 6"/>
@@ -6622,8 +6815,8 @@
         </p:nvSpPr>
         <p:spPr>
           <a:xfrm>
-            <a:off x="731520" y="1554480"/>
-            <a:ext cx="2514600" cy="4663440"/>
+            <a:off x="731520" y="1463040"/>
+            <a:ext cx="2514600" cy="4937760"/>
           </a:xfrm>
           <a:prstGeom prst="roundRect">
             <a:avLst/>
@@ -6633,7 +6826,7 @@
           </a:solidFill>
           <a:ln w="12700">
             <a:solidFill>
-              <a:srgbClr val="123524"/>
+              <a:srgbClr val="D8E2DC"/>
             </a:solidFill>
           </a:ln>
         </p:spPr>
@@ -6667,8 +6860,8 @@
         </p:nvSpPr>
         <p:spPr>
           <a:xfrm>
-            <a:off x="896112" y="1737360"/>
-            <a:ext cx="2185416" cy="4297680"/>
+            <a:off x="896112" y="1645920"/>
+            <a:ext cx="2185416" cy="4572000"/>
           </a:xfrm>
           <a:prstGeom prst="rect">
             <a:avLst/>
@@ -6729,8 +6922,8 @@
         </p:nvSpPr>
         <p:spPr>
           <a:xfrm>
-            <a:off x="3456432" y="1554480"/>
-            <a:ext cx="2514600" cy="4663440"/>
+            <a:off x="3465576" y="1463040"/>
+            <a:ext cx="2514600" cy="4937760"/>
           </a:xfrm>
           <a:prstGeom prst="roundRect">
             <a:avLst/>
@@ -6740,7 +6933,7 @@
           </a:solidFill>
           <a:ln w="12700">
             <a:solidFill>
-              <a:srgbClr val="123524"/>
+              <a:srgbClr val="D8E2DC"/>
             </a:solidFill>
           </a:ln>
         </p:spPr>
@@ -6774,8 +6967,8 @@
         </p:nvSpPr>
         <p:spPr>
           <a:xfrm>
-            <a:off x="3621024" y="1737360"/>
-            <a:ext cx="2185416" cy="4297680"/>
+            <a:off x="3630168" y="1645920"/>
+            <a:ext cx="2185416" cy="4572000"/>
           </a:xfrm>
           <a:prstGeom prst="rect">
             <a:avLst/>
@@ -6836,8 +7029,8 @@
         </p:nvSpPr>
         <p:spPr>
           <a:xfrm>
-            <a:off x="6181344" y="1554480"/>
-            <a:ext cx="2514600" cy="4663440"/>
+            <a:off x="6199632" y="1463040"/>
+            <a:ext cx="2514600" cy="4937760"/>
           </a:xfrm>
           <a:prstGeom prst="roundRect">
             <a:avLst/>
@@ -6847,7 +7040,7 @@
           </a:solidFill>
           <a:ln w="12700">
             <a:solidFill>
-              <a:srgbClr val="123524"/>
+              <a:srgbClr val="D8E2DC"/>
             </a:solidFill>
           </a:ln>
         </p:spPr>
@@ -6881,8 +7074,8 @@
         </p:nvSpPr>
         <p:spPr>
           <a:xfrm>
-            <a:off x="6345936" y="1737360"/>
-            <a:ext cx="2185416" cy="4297680"/>
+            <a:off x="6364224" y="1645920"/>
+            <a:ext cx="2185416" cy="4572000"/>
           </a:xfrm>
           <a:prstGeom prst="rect">
             <a:avLst/>
@@ -6943,8 +7136,8 @@
         </p:nvSpPr>
         <p:spPr>
           <a:xfrm>
-            <a:off x="8906256" y="1554480"/>
-            <a:ext cx="2514600" cy="4663440"/>
+            <a:off x="8933688" y="1463040"/>
+            <a:ext cx="2514600" cy="4937760"/>
           </a:xfrm>
           <a:prstGeom prst="roundRect">
             <a:avLst/>
@@ -6954,7 +7147,7 @@
           </a:solidFill>
           <a:ln w="12700">
             <a:solidFill>
-              <a:srgbClr val="123524"/>
+              <a:srgbClr val="D8E2DC"/>
             </a:solidFill>
           </a:ln>
         </p:spPr>
@@ -6988,8 +7181,8 @@
         </p:nvSpPr>
         <p:spPr>
           <a:xfrm>
-            <a:off x="9070848" y="1737360"/>
-            <a:ext cx="2185416" cy="4297680"/>
+            <a:off x="9098280" y="1645920"/>
+            <a:ext cx="2185416" cy="4572000"/>
           </a:xfrm>
           <a:prstGeom prst="rect">
             <a:avLst/>
@@ -7107,86 +7300,59 @@
       </p:sp>
       <p:sp>
         <p:nvSpPr>
-          <p:cNvPr id="3" name="TextBox 2"/>
-          <p:cNvSpPr txBox="1"/>
-          <p:nvPr/>
-        </p:nvSpPr>
-        <p:spPr>
-          <a:xfrm>
-            <a:off x="731520" y="411480"/>
-            <a:ext cx="8229600" cy="320040"/>
-          </a:xfrm>
-          <a:prstGeom prst="rect">
-            <a:avLst/>
-          </a:prstGeom>
-          <a:noFill/>
-        </p:spPr>
-        <p:txBody>
-          <a:bodyPr wrap="square">
-            <a:spAutoFit/>
-          </a:bodyPr>
-          <a:lstStyle/>
-          <a:p>
-            <a:pPr>
-              <a:defRPr sz="1100" b="1">
-                <a:solidFill>
-                  <a:srgbClr val="15803D"/>
-                </a:solidFill>
-                <a:latin typeface="Plus Jakarta Sans"/>
-              </a:defRPr>
-            </a:pPr>
-            <a:r>
-              <a:t>DEEPTECH GIGAHACK 2026 • BIOMENTORHUB × PROFI</a:t>
-            </a:r>
-          </a:p>
-        </p:txBody>
-      </p:sp>
-      <p:sp>
-        <p:nvSpPr>
-          <p:cNvPr id="4" name="TextBox 3"/>
-          <p:cNvSpPr txBox="1"/>
-          <p:nvPr/>
-        </p:nvSpPr>
-        <p:spPr>
-          <a:xfrm>
-            <a:off x="731520" y="685800"/>
-            <a:ext cx="8686800" cy="731520"/>
-          </a:xfrm>
-          <a:prstGeom prst="rect">
-            <a:avLst/>
-          </a:prstGeom>
-          <a:noFill/>
-        </p:spPr>
-        <p:txBody>
-          <a:bodyPr wrap="square">
-            <a:spAutoFit/>
-          </a:bodyPr>
-          <a:lstStyle/>
-          <a:p>
-            <a:pPr>
-              <a:defRPr sz="2400" b="1">
-                <a:solidFill>
-                  <a:srgbClr val="123524"/>
-                </a:solidFill>
-                <a:latin typeface="Plus Jakarta Sans"/>
-              </a:defRPr>
-            </a:pPr>
-            <a:r>
-              <a:t>План пилотного внедрения в Profi: 6 недель до результата</a:t>
-            </a:r>
-          </a:p>
-        </p:txBody>
-      </p:sp>
-      <p:sp>
-        <p:nvSpPr>
-          <p:cNvPr id="5" name="Rounded Rectangle 4"/>
+          <p:cNvPr id="3" name="Rounded Rectangle 2"/>
           <p:cNvSpPr/>
           <p:nvPr/>
         </p:nvSpPr>
         <p:spPr>
           <a:xfrm>
-            <a:off x="9692640" y="411480"/>
-            <a:ext cx="1828800" cy="685800"/>
+            <a:off x="731520" y="320040"/>
+            <a:ext cx="10728655" cy="868680"/>
+          </a:xfrm>
+          <a:prstGeom prst="roundRect">
+            <a:avLst/>
+          </a:prstGeom>
+          <a:solidFill>
+            <a:srgbClr val="123524"/>
+          </a:solidFill>
+          <a:ln w="12700">
+            <a:solidFill>
+              <a:srgbClr val="22C55E"/>
+            </a:solidFill>
+          </a:ln>
+        </p:spPr>
+        <p:style>
+          <a:lnRef idx="1">
+            <a:schemeClr val="accent1"/>
+          </a:lnRef>
+          <a:fillRef idx="3">
+            <a:schemeClr val="accent1"/>
+          </a:fillRef>
+          <a:effectRef idx="2">
+            <a:schemeClr val="accent1"/>
+          </a:effectRef>
+          <a:fontRef idx="minor">
+            <a:schemeClr val="lt1"/>
+          </a:fontRef>
+        </p:style>
+        <p:txBody>
+          <a:bodyPr rtlCol="0" anchor="ctr"/>
+          <a:lstStyle/>
+          <a:p>
+            <a:pPr algn="ctr"/>
+          </a:p>
+        </p:txBody>
+      </p:sp>
+      <p:sp>
+        <p:nvSpPr>
+          <p:cNvPr id="4" name="Rounded Rectangle 3"/>
+          <p:cNvSpPr/>
+          <p:nvPr/>
+        </p:nvSpPr>
+        <p:spPr>
+          <a:xfrm>
+            <a:off x="914400" y="429768"/>
+            <a:ext cx="2011680" cy="640080"/>
           </a:xfrm>
           <a:prstGeom prst="roundRect">
             <a:avLst/>
@@ -7196,7 +7362,7 @@
           </a:solidFill>
           <a:ln w="12700">
             <a:solidFill>
-              <a:srgbClr val="15803D"/>
+              <a:srgbClr val="22C55E"/>
             </a:solidFill>
           </a:ln>
         </p:spPr>
@@ -7224,7 +7390,7 @@
       </p:sp>
       <p:pic>
         <p:nvPicPr>
-          <p:cNvPr id="6" name="Picture 5" descr="logo.png"/>
+          <p:cNvPr id="5" name="Picture 4" descr="logo.png"/>
           <p:cNvPicPr>
             <a:picLocks noChangeAspect="1"/>
           </p:cNvPicPr>
@@ -7238,14 +7404,63 @@
         </p:blipFill>
         <p:spPr>
           <a:xfrm>
-            <a:off x="9784080" y="475488"/>
-            <a:ext cx="1645920" cy="548640"/>
+            <a:off x="1051560" y="484632"/>
+            <a:ext cx="1737360" cy="579120"/>
           </a:xfrm>
           <a:prstGeom prst="rect">
             <a:avLst/>
           </a:prstGeom>
         </p:spPr>
       </p:pic>
+      <p:sp>
+        <p:nvSpPr>
+          <p:cNvPr id="6" name="TextBox 5"/>
+          <p:cNvSpPr txBox="1"/>
+          <p:nvPr/>
+        </p:nvSpPr>
+        <p:spPr>
+          <a:xfrm>
+            <a:off x="3200400" y="365760"/>
+            <a:ext cx="8046720" cy="777240"/>
+          </a:xfrm>
+          <a:prstGeom prst="rect">
+            <a:avLst/>
+          </a:prstGeom>
+          <a:noFill/>
+        </p:spPr>
+        <p:txBody>
+          <a:bodyPr wrap="square">
+            <a:spAutoFit/>
+          </a:bodyPr>
+          <a:lstStyle/>
+          <a:p>
+            <a:pPr>
+              <a:defRPr sz="1000" b="1">
+                <a:solidFill>
+                  <a:srgbClr val="22C55E"/>
+                </a:solidFill>
+                <a:latin typeface="Plus Jakarta Sans"/>
+              </a:defRPr>
+            </a:pPr>
+            <a:r>
+              <a:t>ДОРОЖНАЯ КАРТА ВНЕДРЕНИЯ</a:t>
+            </a:r>
+          </a:p>
+          <a:p>
+            <a:pPr>
+              <a:defRPr sz="1800" b="1">
+                <a:solidFill>
+                  <a:srgbClr val="FFFFFF"/>
+                </a:solidFill>
+                <a:latin typeface="Plus Jakarta Sans"/>
+              </a:defRPr>
+            </a:pPr>
+            <a:r>
+              <a:t>План пилотного запуска в супермаркетах Profi</a:t>
+            </a:r>
+          </a:p>
+        </p:txBody>
+      </p:sp>
       <p:sp>
         <p:nvSpPr>
           <p:cNvPr id="7" name="Rounded Rectangle 6"/>
@@ -7254,8 +7469,8 @@
         </p:nvSpPr>
         <p:spPr>
           <a:xfrm>
-            <a:off x="731520" y="1554480"/>
-            <a:ext cx="3383280" cy="3291840"/>
+            <a:off x="731520" y="1463040"/>
+            <a:ext cx="3383280" cy="3474720"/>
           </a:xfrm>
           <a:prstGeom prst="roundRect">
             <a:avLst/>
@@ -7299,8 +7514,8 @@
         </p:nvSpPr>
         <p:spPr>
           <a:xfrm>
-            <a:off x="896112" y="1719072"/>
-            <a:ext cx="3054096" cy="2962656"/>
+            <a:off x="896112" y="1627632"/>
+            <a:ext cx="3054096" cy="3145536"/>
           </a:xfrm>
           <a:prstGeom prst="rect">
             <a:avLst/>
@@ -7340,7 +7555,7 @@
           </a:p>
           <a:p>
             <a:pPr>
-              <a:defRPr sz="1100">
+              <a:defRPr sz="1150">
                 <a:solidFill>
                   <a:srgbClr val="526B5C"/>
                 </a:solidFill>
@@ -7353,7 +7568,7 @@
           </a:p>
           <a:p>
             <a:pPr>
-              <a:defRPr sz="1100">
+              <a:defRPr sz="1150">
                 <a:solidFill>
                   <a:srgbClr val="526B5C"/>
                 </a:solidFill>
@@ -7366,7 +7581,7 @@
           </a:p>
           <a:p>
             <a:pPr>
-              <a:defRPr sz="1100">
+              <a:defRPr sz="1150">
                 <a:solidFill>
                   <a:srgbClr val="526B5C"/>
                 </a:solidFill>
@@ -7387,8 +7602,8 @@
         </p:nvSpPr>
         <p:spPr>
           <a:xfrm>
-            <a:off x="4389120" y="1554480"/>
-            <a:ext cx="3383280" cy="3291840"/>
+            <a:off x="4389120" y="1463040"/>
+            <a:ext cx="3383280" cy="3474720"/>
           </a:xfrm>
           <a:prstGeom prst="roundRect">
             <a:avLst/>
@@ -7398,7 +7613,7 @@
           </a:solidFill>
           <a:ln w="12700">
             <a:solidFill>
-              <a:srgbClr val="123524"/>
+              <a:srgbClr val="D8E2DC"/>
             </a:solidFill>
           </a:ln>
         </p:spPr>
@@ -7432,8 +7647,8 @@
         </p:nvSpPr>
         <p:spPr>
           <a:xfrm>
-            <a:off x="4553712" y="1719072"/>
-            <a:ext cx="3054096" cy="2962656"/>
+            <a:off x="4553712" y="1627632"/>
+            <a:ext cx="3054096" cy="3145536"/>
           </a:xfrm>
           <a:prstGeom prst="rect">
             <a:avLst/>
@@ -7473,7 +7688,7 @@
           </a:p>
           <a:p>
             <a:pPr>
-              <a:defRPr sz="1100">
+              <a:defRPr sz="1150">
                 <a:solidFill>
                   <a:srgbClr val="526B5C"/>
                 </a:solidFill>
@@ -7486,7 +7701,7 @@
           </a:p>
           <a:p>
             <a:pPr>
-              <a:defRPr sz="1100">
+              <a:defRPr sz="1150">
                 <a:solidFill>
                   <a:srgbClr val="526B5C"/>
                 </a:solidFill>
@@ -7499,7 +7714,7 @@
           </a:p>
           <a:p>
             <a:pPr>
-              <a:defRPr sz="1100">
+              <a:defRPr sz="1150">
                 <a:solidFill>
                   <a:srgbClr val="526B5C"/>
                 </a:solidFill>
@@ -7520,8 +7735,8 @@
         </p:nvSpPr>
         <p:spPr>
           <a:xfrm>
-            <a:off x="8046720" y="1554480"/>
-            <a:ext cx="3383280" cy="3291840"/>
+            <a:off x="8046720" y="1463040"/>
+            <a:ext cx="3383280" cy="3474720"/>
           </a:xfrm>
           <a:prstGeom prst="roundRect">
             <a:avLst/>
@@ -7531,7 +7746,7 @@
           </a:solidFill>
           <a:ln w="12700">
             <a:solidFill>
-              <a:srgbClr val="123524"/>
+              <a:srgbClr val="D8E2DC"/>
             </a:solidFill>
           </a:ln>
         </p:spPr>
@@ -7565,8 +7780,8 @@
         </p:nvSpPr>
         <p:spPr>
           <a:xfrm>
-            <a:off x="8211312" y="1719072"/>
-            <a:ext cx="3054096" cy="2962656"/>
+            <a:off x="8211312" y="1627632"/>
+            <a:ext cx="3054096" cy="3145536"/>
           </a:xfrm>
           <a:prstGeom prst="rect">
             <a:avLst/>
@@ -7606,7 +7821,7 @@
           </a:p>
           <a:p>
             <a:pPr>
-              <a:defRPr sz="1100">
+              <a:defRPr sz="1150">
                 <a:solidFill>
                   <a:srgbClr val="526B5C"/>
                 </a:solidFill>
@@ -7619,7 +7834,7 @@
           </a:p>
           <a:p>
             <a:pPr>
-              <a:defRPr sz="1100">
+              <a:defRPr sz="1150">
                 <a:solidFill>
                   <a:srgbClr val="526B5C"/>
                 </a:solidFill>
@@ -7632,7 +7847,7 @@
           </a:p>
           <a:p>
             <a:pPr>
-              <a:defRPr sz="1100">
+              <a:defRPr sz="1150">
                 <a:solidFill>
                   <a:srgbClr val="526B5C"/>
                 </a:solidFill>
@@ -7653,8 +7868,8 @@
         </p:nvSpPr>
         <p:spPr>
           <a:xfrm>
-            <a:off x="731520" y="5120640"/>
-            <a:ext cx="10698480" cy="1097280"/>
+            <a:off x="731520" y="5212080"/>
+            <a:ext cx="10728655" cy="1188720"/>
           </a:xfrm>
           <a:prstGeom prst="roundRect">
             <a:avLst/>
@@ -7687,14 +7902,14 @@
           <a:lstStyle/>
           <a:p>
             <a:pPr algn="ctr">
-              <a:defRPr b="1" sz="1400">
+              <a:defRPr b="1" sz="1500">
                 <a:solidFill>
                   <a:srgbClr val="22C55E"/>
                 </a:solidFill>
               </a:defRPr>
             </a:pPr>
             <a:r>
-              <a:t>📦 Готовность тестовой партии к передаче:</a:t>
+              <a:t>📦 Комплект из 200 тестовых образцов готов к передаче!</a:t>
             </a:r>
             <a:r>
               <a:rPr b="0">
@@ -7702,7 +7917,7 @@
                   <a:srgbClr val="FFFFFF"/>
                 </a:solidFill>
               </a:rPr>
-              <a:t> Мы подготовили комплект из 200 образцов пакетов CPET Ultra-Flex и биобоксов LignoShield. Готовы передать их технологическому отделу Profi для старта испытаний на следующей неделе.</a:t>
+              <a:t> Партия пакетов CPET Ultra-Flex и термобоксов LignoShield подготовлена для старта испытаний в сети Profi на следующей неделе.</a:t>
             </a:r>
           </a:p>
         </p:txBody>
@@ -7740,11 +7955,11 @@
             <a:avLst/>
           </a:prstGeom>
           <a:solidFill>
-            <a:srgbClr val="123524"/>
+            <a:srgbClr val="FAF4E4"/>
           </a:solidFill>
           <a:ln>
             <a:solidFill>
-              <a:srgbClr val="123524"/>
+              <a:srgbClr val="FAF4E4"/>
             </a:solidFill>
           </a:ln>
         </p:spPr>
@@ -7778,8 +7993,53 @@
         </p:nvSpPr>
         <p:spPr>
           <a:xfrm>
-            <a:off x="4754880" y="731520"/>
-            <a:ext cx="2743200" cy="914400"/>
+            <a:off x="731520" y="320040"/>
+            <a:ext cx="10728655" cy="868680"/>
+          </a:xfrm>
+          <a:prstGeom prst="roundRect">
+            <a:avLst/>
+          </a:prstGeom>
+          <a:solidFill>
+            <a:srgbClr val="123524"/>
+          </a:solidFill>
+          <a:ln w="12700">
+            <a:solidFill>
+              <a:srgbClr val="22C55E"/>
+            </a:solidFill>
+          </a:ln>
+        </p:spPr>
+        <p:style>
+          <a:lnRef idx="1">
+            <a:schemeClr val="accent1"/>
+          </a:lnRef>
+          <a:fillRef idx="3">
+            <a:schemeClr val="accent1"/>
+          </a:fillRef>
+          <a:effectRef idx="2">
+            <a:schemeClr val="accent1"/>
+          </a:effectRef>
+          <a:fontRef idx="minor">
+            <a:schemeClr val="lt1"/>
+          </a:fontRef>
+        </p:style>
+        <p:txBody>
+          <a:bodyPr rtlCol="0" anchor="ctr"/>
+          <a:lstStyle/>
+          <a:p>
+            <a:pPr algn="ctr"/>
+          </a:p>
+        </p:txBody>
+      </p:sp>
+      <p:sp>
+        <p:nvSpPr>
+          <p:cNvPr id="4" name="Rounded Rectangle 3"/>
+          <p:cNvSpPr/>
+          <p:nvPr/>
+        </p:nvSpPr>
+        <p:spPr>
+          <a:xfrm>
+            <a:off x="914400" y="429768"/>
+            <a:ext cx="2011680" cy="640080"/>
           </a:xfrm>
           <a:prstGeom prst="roundRect">
             <a:avLst/>
@@ -7817,7 +8077,7 @@
       </p:sp>
       <p:pic>
         <p:nvPicPr>
-          <p:cNvPr id="4" name="Picture 3" descr="logo.png"/>
+          <p:cNvPr id="5" name="Picture 4" descr="logo.png"/>
           <p:cNvPicPr>
             <a:picLocks noChangeAspect="1"/>
           </p:cNvPicPr>
@@ -7831,8 +8091,8 @@
         </p:blipFill>
         <p:spPr>
           <a:xfrm>
-            <a:off x="4892040" y="804672"/>
-            <a:ext cx="2468880" cy="822960"/>
+            <a:off x="1051560" y="484632"/>
+            <a:ext cx="1737360" cy="579120"/>
           </a:xfrm>
           <a:prstGeom prst="rect">
             <a:avLst/>
@@ -7841,14 +8101,14 @@
       </p:pic>
       <p:sp>
         <p:nvSpPr>
-          <p:cNvPr id="5" name="TextBox 4"/>
+          <p:cNvPr id="6" name="TextBox 5"/>
           <p:cNvSpPr txBox="1"/>
           <p:nvPr/>
         </p:nvSpPr>
         <p:spPr>
           <a:xfrm>
-            <a:off x="914400" y="2011680"/>
-            <a:ext cx="10362895" cy="2011680"/>
+            <a:off x="3200400" y="365760"/>
+            <a:ext cx="8046720" cy="777240"/>
           </a:xfrm>
           <a:prstGeom prst="rect">
             <a:avLst/>
@@ -7861,8 +8121,21 @@
           </a:bodyPr>
           <a:lstStyle/>
           <a:p>
-            <a:pPr algn="ctr">
-              <a:defRPr sz="3200" b="1">
+            <a:pPr>
+              <a:defRPr sz="1000" b="1">
+                <a:solidFill>
+                  <a:srgbClr val="22C55E"/>
+                </a:solidFill>
+                <a:latin typeface="Plus Jakarta Sans"/>
+              </a:defRPr>
+            </a:pPr>
+            <a:r>
+              <a:t>КОМАНДА И КОНТАКТЫ</a:t>
+            </a:r>
+          </a:p>
+          <a:p>
+            <a:pPr>
+              <a:defRPr sz="1800" b="1">
                 <a:solidFill>
                   <a:srgbClr val="FFFFFF"/>
                 </a:solidFill>
@@ -7873,39 +8146,26 @@
               <a:t>Делаем циркулярность прибыльной для Profi уже сегодня</a:t>
             </a:r>
           </a:p>
-          <a:p>
-            <a:pPr algn="ctr">
-              <a:defRPr sz="1800" b="1">
-                <a:solidFill>
-                  <a:srgbClr val="22C55E"/>
-                </a:solidFill>
-                <a:latin typeface="Plus Jakarta Sans"/>
-              </a:defRPr>
-            </a:pPr>
-            <a:r>
-              <a:t>0% первичного пластика • Защита маржинальности • Соответствие PPWR 2030</a:t>
-            </a:r>
-          </a:p>
-        </p:txBody>
-      </p:sp>
-      <p:sp>
-        <p:nvSpPr>
-          <p:cNvPr id="6" name="Rounded Rectangle 5"/>
+        </p:txBody>
+      </p:sp>
+      <p:sp>
+        <p:nvSpPr>
+          <p:cNvPr id="7" name="Rounded Rectangle 6"/>
           <p:cNvSpPr/>
           <p:nvPr/>
         </p:nvSpPr>
         <p:spPr>
           <a:xfrm>
-            <a:off x="2286000" y="3931920"/>
-            <a:ext cx="7619695" cy="2011680"/>
+            <a:off x="2011680" y="1645920"/>
+            <a:ext cx="8168335" cy="4663440"/>
           </a:xfrm>
           <a:prstGeom prst="roundRect">
             <a:avLst/>
           </a:prstGeom>
           <a:solidFill>
-            <a:srgbClr val="153E2B"/>
+            <a:srgbClr val="FFFFFF"/>
           </a:solidFill>
-          <a:ln w="19050">
+          <a:ln w="25400">
             <a:solidFill>
               <a:srgbClr val="22C55E"/>
             </a:solidFill>
@@ -7935,14 +8195,14 @@
       </p:sp>
       <p:sp>
         <p:nvSpPr>
-          <p:cNvPr id="7" name="TextBox 6"/>
+          <p:cNvPr id="8" name="TextBox 7"/>
           <p:cNvSpPr txBox="1"/>
           <p:nvPr/>
         </p:nvSpPr>
         <p:spPr>
           <a:xfrm>
-            <a:off x="2468880" y="4114800"/>
-            <a:ext cx="7253935" cy="1645920"/>
+            <a:off x="2286000" y="1920240"/>
+            <a:ext cx="7619695" cy="4114800"/>
           </a:xfrm>
           <a:prstGeom prst="rect">
             <a:avLst/>
@@ -7956,21 +8216,48 @@
           <a:lstStyle/>
           <a:p>
             <a:pPr algn="ctr">
-              <a:defRPr b="1" sz="1400">
-                <a:solidFill>
-                  <a:srgbClr val="FAF4E4"/>
-                </a:solidFill>
-              </a:defRPr>
-            </a:pPr>
-            <a:r>
-              <a:t>🌐 Интерактивная платформа и ESG-калькулятор:</a:t>
+              <a:defRPr sz="3000" b="1">
+                <a:solidFill>
+                  <a:srgbClr val="123524"/>
+                </a:solidFill>
+                <a:latin typeface="Plus Jakarta Sans"/>
+              </a:defRPr>
+            </a:pPr>
+            <a:r>
+              <a:t>PackShift (Profi EcoPack)</a:t>
             </a:r>
           </a:p>
           <a:p>
             <a:pPr algn="ctr">
-              <a:defRPr b="1" sz="1600">
-                <a:solidFill>
-                  <a:srgbClr val="22C55E"/>
+              <a:defRPr sz="1700" b="1">
+                <a:solidFill>
+                  <a:srgbClr val="15803D"/>
+                </a:solidFill>
+                <a:latin typeface="Plus Jakarta Sans"/>
+              </a:defRPr>
+            </a:pPr>
+            <a:r>
+              <a:t>0% первичного пластика • Защита маржинальности • Соответствие PPWR 2030</a:t>
+            </a:r>
+          </a:p>
+          <a:p>
+            <a:pPr algn="ctr">
+              <a:defRPr sz="1400">
+                <a:solidFill>
+                  <a:srgbClr val="526B5C"/>
+                </a:solidFill>
+              </a:defRPr>
+            </a:pPr>
+            <a:br/>
+            <a:r>
+              <a:t>🌐 Интерактивная веб-платформа и ESG-калькулятор сети Profi:</a:t>
+            </a:r>
+          </a:p>
+          <a:p>
+            <a:pPr algn="ctr">
+              <a:defRPr sz="2000" b="1">
+                <a:solidFill>
+                  <a:srgbClr val="15803D"/>
                 </a:solidFill>
                 <a:latin typeface="JetBrains Mono"/>
               </a:defRPr>
@@ -7981,26 +8268,29 @@
           </a:p>
           <a:p>
             <a:pPr algn="ctr">
-              <a:defRPr sz="1200">
-                <a:solidFill>
-                  <a:srgbClr val="FAF4E4"/>
-                </a:solidFill>
-              </a:defRPr>
-            </a:pPr>
-            <a:r>
-              <a:t>Открытый репозиторий: github.com/denis100strike/Hackaton-202636 (PR #1)</a:t>
+              <a:defRPr sz="1300">
+                <a:solidFill>
+                  <a:srgbClr val="526B5C"/>
+                </a:solidFill>
+              </a:defRPr>
+            </a:pPr>
+            <a:br/>
+            <a:r>
+              <a:t>Deeptech Gigahack 2026 • Biomentorhub × Profi Track</a:t>
             </a:r>
           </a:p>
           <a:p>
             <a:pPr algn="ctr">
-              <a:defRPr b="1" sz="1400">
-                <a:solidFill>
-                  <a:srgbClr val="FFFFFF"/>
-                </a:solidFill>
-              </a:defRPr>
-            </a:pPr>
-            <a:r>
-              <a:t>Спасибо за внимание! Готовы ответить на ваши вопросы.</a:t>
+              <a:defRPr sz="1600" b="1">
+                <a:solidFill>
+                  <a:srgbClr val="123524"/>
+                </a:solidFill>
+                <a:latin typeface="Plus Jakarta Sans"/>
+              </a:defRPr>
+            </a:pPr>
+            <a:br/>
+            <a:r>
+              <a:t>Благодарим за внимание! Готовы ответить на ваши вопросы.</a:t>
             </a:r>
           </a:p>
         </p:txBody>

</xml_diff>

<commit_message>
style: minimalist centered presentation with diagrams, process schemas, and deeptech typography
</commit_message>
<xml_diff>
--- a/PackShift_Profi_Gigahack2026.pptx
+++ b/PackShift_Profi_Gigahack2026.pptx
@@ -3110,11 +3110,11 @@
             <a:avLst/>
           </a:prstGeom>
           <a:solidFill>
-            <a:srgbClr val="0F1418"/>
+            <a:srgbClr val="0A0E11"/>
           </a:solidFill>
           <a:ln>
             <a:solidFill>
-              <a:srgbClr val="0F1418"/>
+              <a:srgbClr val="0A0E11"/>
             </a:solidFill>
           </a:ln>
         </p:spPr>
@@ -3142,24 +3142,101 @@
       </p:sp>
       <p:sp>
         <p:nvSpPr>
-          <p:cNvPr id="3" name="Rounded Rectangle 2"/>
+          <p:cNvPr id="3" name="TextBox 2"/>
+          <p:cNvSpPr txBox="1"/>
+          <p:nvPr/>
+        </p:nvSpPr>
+        <p:spPr>
+          <a:xfrm>
+            <a:off x="914400" y="1097280"/>
+            <a:ext cx="10362895" cy="2926080"/>
+          </a:xfrm>
+          <a:prstGeom prst="rect">
+            <a:avLst/>
+          </a:prstGeom>
+          <a:noFill/>
+        </p:spPr>
+        <p:txBody>
+          <a:bodyPr wrap="square">
+            <a:spAutoFit/>
+          </a:bodyPr>
+          <a:lstStyle/>
+          <a:p>
+            <a:pPr algn="ctr">
+              <a:defRPr sz="1200" b="1">
+                <a:solidFill>
+                  <a:srgbClr val="34D399"/>
+                </a:solidFill>
+                <a:latin typeface="JetBrains Mono"/>
+              </a:defRPr>
+            </a:pPr>
+            <a:r>
+              <a:t>DEEPTECH GIGAHACK 2026 • BIOMENTORHUB × PROFI TRACK</a:t>
+            </a:r>
+          </a:p>
+          <a:p>
+            <a:pPr algn="ctr">
+              <a:defRPr sz="4800" b="1">
+                <a:solidFill>
+                  <a:srgbClr val="FFFFFF"/>
+                </a:solidFill>
+                <a:latin typeface="Plus Jakarta Sans"/>
+              </a:defRPr>
+            </a:pPr>
+            <a:br/>
+            <a:r>
+              <a:t>PackShift</a:t>
+            </a:r>
+          </a:p>
+          <a:p>
+            <a:pPr algn="ctr">
+              <a:defRPr sz="1600" b="1">
+                <a:solidFill>
+                  <a:srgbClr val="34D399"/>
+                </a:solidFill>
+                <a:latin typeface="JetBrains Mono"/>
+              </a:defRPr>
+            </a:pPr>
+            <a:r>
+              <a:t>0% ПЕРВИЧНОГО ПЛАСТИКА • 100% ЦИРКУЛЯРНОСТЬ</a:t>
+            </a:r>
+          </a:p>
+          <a:p>
+            <a:pPr algn="ctr">
+              <a:defRPr sz="1500">
+                <a:solidFill>
+                  <a:srgbClr val="94A3B8"/>
+                </a:solidFill>
+                <a:latin typeface="Plus Jakarta Sans"/>
+              </a:defRPr>
+            </a:pPr>
+            <a:br/>
+            <a:r>
+              <a:t>Инженерная система циркулярной пищевой упаковки для сети супермаркетов Profi</a:t>
+            </a:r>
+          </a:p>
+        </p:txBody>
+      </p:sp>
+      <p:sp>
+        <p:nvSpPr>
+          <p:cNvPr id="4" name="Rounded Rectangle 3"/>
           <p:cNvSpPr/>
           <p:nvPr/>
         </p:nvSpPr>
         <p:spPr>
           <a:xfrm>
-            <a:off x="822960" y="822960"/>
-            <a:ext cx="5669280" cy="411480"/>
+            <a:off x="1005840" y="4389120"/>
+            <a:ext cx="2377440" cy="1645920"/>
           </a:xfrm>
           <a:prstGeom prst="roundRect">
             <a:avLst/>
           </a:prstGeom>
           <a:solidFill>
-            <a:srgbClr val="122E24"/>
+            <a:srgbClr val="12181D"/>
           </a:solidFill>
           <a:ln w="12700">
             <a:solidFill>
-              <a:srgbClr val="10B981"/>
+              <a:srgbClr val="1E2932"/>
             </a:solidFill>
           </a:ln>
         </p:spPr>
@@ -3181,30 +3258,20 @@
           <a:bodyPr rtlCol="0" anchor="ctr"/>
           <a:lstStyle/>
           <a:p>
-            <a:pPr algn="ctr">
-              <a:defRPr sz="1000" b="1">
-                <a:solidFill>
-                  <a:srgbClr val="34D399"/>
-                </a:solidFill>
-                <a:latin typeface="JetBrains Mono"/>
-              </a:defRPr>
-            </a:pPr>
-            <a:r>
-              <a:t>⚡ DEEPTECH GIGAHACK 2026 • BIOMENTORHUB × PROFI TRACK</a:t>
-            </a:r>
-          </a:p>
-        </p:txBody>
-      </p:sp>
-      <p:sp>
-        <p:nvSpPr>
-          <p:cNvPr id="4" name="TextBox 3"/>
+            <a:pPr algn="ctr"/>
+          </a:p>
+        </p:txBody>
+      </p:sp>
+      <p:sp>
+        <p:nvSpPr>
+          <p:cNvPr id="5" name="TextBox 4"/>
           <p:cNvSpPr txBox="1"/>
           <p:nvPr/>
         </p:nvSpPr>
         <p:spPr>
           <a:xfrm>
-            <a:off x="822960" y="1463040"/>
-            <a:ext cx="10515600" cy="2011680"/>
+            <a:off x="1097280" y="4572000"/>
+            <a:ext cx="2194560" cy="1280160"/>
           </a:xfrm>
           <a:prstGeom prst="rect">
             <a:avLst/>
@@ -3217,78 +3284,29 @@
           </a:bodyPr>
           <a:lstStyle/>
           <a:p>
-            <a:pPr>
-              <a:defRPr sz="4600" b="1">
+            <a:pPr algn="ctr">
+              <a:defRPr sz="2800" b="1">
                 <a:solidFill>
                   <a:srgbClr val="34D399"/>
                 </a:solidFill>
+                <a:latin typeface="JetBrains Mono"/>
+              </a:defRPr>
+            </a:pPr>
+            <a:r>
+              <a:t>-88%</a:t>
+            </a:r>
+          </a:p>
+          <a:p>
+            <a:pPr algn="ctr">
+              <a:defRPr sz="1200" b="1">
+                <a:solidFill>
+                  <a:srgbClr val="FFFFFF"/>
+                </a:solidFill>
                 <a:latin typeface="Plus Jakarta Sans"/>
               </a:defRPr>
             </a:pPr>
             <a:r>
-              <a:t>PackShift</a:t>
-            </a:r>
-          </a:p>
-          <a:p>
-            <a:pPr>
-              <a:defRPr sz="2800" b="1">
-                <a:solidFill>
-                  <a:srgbClr val="FFFFFF"/>
-                </a:solidFill>
-                <a:latin typeface="Plus Jakarta Sans"/>
-              </a:defRPr>
-            </a:pPr>
-            <a:r>
-              <a:t>Циркулярная эко-упаковка для пищевого ритейла</a:t>
-            </a:r>
-          </a:p>
-          <a:p>
-            <a:pPr>
-              <a:defRPr sz="1300">
-                <a:solidFill>
-                  <a:srgbClr val="10B981"/>
-                </a:solidFill>
-                <a:latin typeface="JetBrains Mono"/>
-              </a:defRPr>
-            </a:pPr>
-            <a:r>
-              <a:t>0% первичного пластика • Термостойкость 250°C • Zero PFAS • EU PPWR 2030 Ready</a:t>
-            </a:r>
-          </a:p>
-        </p:txBody>
-      </p:sp>
-      <p:sp>
-        <p:nvSpPr>
-          <p:cNvPr id="5" name="TextBox 4"/>
-          <p:cNvSpPr txBox="1"/>
-          <p:nvPr/>
-        </p:nvSpPr>
-        <p:spPr>
-          <a:xfrm>
-            <a:off x="822960" y="3566160"/>
-            <a:ext cx="10241280" cy="777240"/>
-          </a:xfrm>
-          <a:prstGeom prst="rect">
-            <a:avLst/>
-          </a:prstGeom>
-          <a:noFill/>
-        </p:spPr>
-        <p:txBody>
-          <a:bodyPr wrap="square">
-            <a:spAutoFit/>
-          </a:bodyPr>
-          <a:lstStyle/>
-          <a:p>
-            <a:pPr>
-              <a:defRPr sz="1400">
-                <a:solidFill>
-                  <a:srgbClr val="94A3B8"/>
-                </a:solidFill>
-                <a:latin typeface="Plus Jakarta Sans"/>
-              </a:defRPr>
-            </a:pPr>
-            <a:r>
-              <a:t>Инженерная система замещения первичного пластика на базе модифицированных моно-материалов rPET и биомиметических растительных барьеров. Разработано под операционные стандарты сети супермаркетов Profi.</a:t>
+              <a:t>Первичный пластик</a:t>
             </a:r>
           </a:p>
         </p:txBody>
@@ -3301,121 +3319,14 @@
         </p:nvSpPr>
         <p:spPr>
           <a:xfrm>
-            <a:off x="822960" y="4480560"/>
-            <a:ext cx="2468880" cy="1645920"/>
+            <a:off x="3657600" y="4389120"/>
+            <a:ext cx="2377440" cy="1645920"/>
           </a:xfrm>
           <a:prstGeom prst="roundRect">
             <a:avLst/>
           </a:prstGeom>
           <a:solidFill>
-            <a:srgbClr val="182026"/>
-          </a:solidFill>
-          <a:ln w="12700">
-            <a:solidFill>
-              <a:srgbClr val="24323B"/>
-            </a:solidFill>
-          </a:ln>
-        </p:spPr>
-        <p:style>
-          <a:lnRef idx="1">
-            <a:schemeClr val="accent1"/>
-          </a:lnRef>
-          <a:fillRef idx="3">
-            <a:schemeClr val="accent1"/>
-          </a:fillRef>
-          <a:effectRef idx="2">
-            <a:schemeClr val="accent1"/>
-          </a:effectRef>
-          <a:fontRef idx="minor">
-            <a:schemeClr val="lt1"/>
-          </a:fontRef>
-        </p:style>
-        <p:txBody>
-          <a:bodyPr rtlCol="0" anchor="ctr"/>
-          <a:lstStyle/>
-          <a:p>
-            <a:pPr algn="ctr"/>
-          </a:p>
-        </p:txBody>
-      </p:sp>
-      <p:sp>
-        <p:nvSpPr>
-          <p:cNvPr id="7" name="TextBox 6"/>
-          <p:cNvSpPr txBox="1"/>
-          <p:nvPr/>
-        </p:nvSpPr>
-        <p:spPr>
-          <a:xfrm>
-            <a:off x="960120" y="4617720"/>
-            <a:ext cx="2194560" cy="1371600"/>
-          </a:xfrm>
-          <a:prstGeom prst="rect">
-            <a:avLst/>
-          </a:prstGeom>
-          <a:noFill/>
-        </p:spPr>
-        <p:txBody>
-          <a:bodyPr wrap="square">
-            <a:spAutoFit/>
-          </a:bodyPr>
-          <a:lstStyle/>
-          <a:p>
-            <a:pPr>
-              <a:defRPr sz="2600" b="1">
-                <a:solidFill>
-                  <a:srgbClr val="34D399"/>
-                </a:solidFill>
-                <a:latin typeface="JetBrains Mono"/>
-              </a:defRPr>
-            </a:pPr>
-            <a:r>
-              <a:t>-88%</a:t>
-            </a:r>
-          </a:p>
-          <a:p>
-            <a:pPr>
-              <a:defRPr sz="1300" b="1">
-                <a:solidFill>
-                  <a:srgbClr val="FFFFFF"/>
-                </a:solidFill>
-                <a:latin typeface="Plus Jakarta Sans"/>
-              </a:defRPr>
-            </a:pPr>
-            <a:r>
-              <a:t>Первичный пластик</a:t>
-            </a:r>
-          </a:p>
-          <a:p>
-            <a:pPr>
-              <a:defRPr sz="1050">
-                <a:solidFill>
-                  <a:srgbClr val="94A3B8"/>
-                </a:solidFill>
-                <a:latin typeface="Plus Jakarta Sans"/>
-              </a:defRPr>
-            </a:pPr>
-            <a:r>
-              <a:t>Замена на rPET и растительное сырье</a:t>
-            </a:r>
-          </a:p>
-        </p:txBody>
-      </p:sp>
-      <p:sp>
-        <p:nvSpPr>
-          <p:cNvPr id="8" name="Rounded Rectangle 7"/>
-          <p:cNvSpPr/>
-          <p:nvPr/>
-        </p:nvSpPr>
-        <p:spPr>
-          <a:xfrm>
-            <a:off x="3511296" y="4480560"/>
-            <a:ext cx="2468880" cy="1645920"/>
-          </a:xfrm>
-          <a:prstGeom prst="roundRect">
-            <a:avLst/>
-          </a:prstGeom>
-          <a:solidFill>
-            <a:srgbClr val="182026"/>
+            <a:srgbClr val="102E22"/>
           </a:solidFill>
           <a:ln w="19050">
             <a:solidFill>
@@ -3447,14 +3358,14 @@
       </p:sp>
       <p:sp>
         <p:nvSpPr>
-          <p:cNvPr id="9" name="TextBox 8"/>
+          <p:cNvPr id="7" name="TextBox 6"/>
           <p:cNvSpPr txBox="1"/>
           <p:nvPr/>
         </p:nvSpPr>
         <p:spPr>
           <a:xfrm>
-            <a:off x="3648456" y="4617720"/>
-            <a:ext cx="2194560" cy="1371600"/>
+            <a:off x="3749040" y="4572000"/>
+            <a:ext cx="2194560" cy="1280160"/>
           </a:xfrm>
           <a:prstGeom prst="rect">
             <a:avLst/>
@@ -3467,8 +3378,8 @@
           </a:bodyPr>
           <a:lstStyle/>
           <a:p>
-            <a:pPr>
-              <a:defRPr sz="2600" b="1">
+            <a:pPr algn="ctr">
+              <a:defRPr sz="2800" b="1">
                 <a:solidFill>
                   <a:srgbClr val="34D399"/>
                 </a:solidFill>
@@ -3480,8 +3391,8 @@
             </a:r>
           </a:p>
           <a:p>
-            <a:pPr>
-              <a:defRPr sz="1300" b="1">
+            <a:pPr algn="ctr">
+              <a:defRPr sz="1200" b="1">
                 <a:solidFill>
                   <a:srgbClr val="FFFFFF"/>
                 </a:solidFill>
@@ -3492,41 +3403,28 @@
               <a:t>Вызов гриля (Annex)</a:t>
             </a:r>
           </a:p>
-          <a:p>
-            <a:pPr>
-              <a:defRPr sz="1050">
-                <a:solidFill>
-                  <a:srgbClr val="94A3B8"/>
-                </a:solidFill>
-                <a:latin typeface="Plus Jakarta Sans"/>
-              </a:defRPr>
-            </a:pPr>
-            <a:r>
-              <a:t>6ч в тепловой витрине без размягчения</a:t>
-            </a:r>
-          </a:p>
-        </p:txBody>
-      </p:sp>
-      <p:sp>
-        <p:nvSpPr>
-          <p:cNvPr id="10" name="Rounded Rectangle 9"/>
+        </p:txBody>
+      </p:sp>
+      <p:sp>
+        <p:nvSpPr>
+          <p:cNvPr id="8" name="Rounded Rectangle 7"/>
           <p:cNvSpPr/>
           <p:nvPr/>
         </p:nvSpPr>
         <p:spPr>
           <a:xfrm>
-            <a:off x="6199632" y="4480560"/>
-            <a:ext cx="2468880" cy="1645920"/>
+            <a:off x="6309360" y="4389120"/>
+            <a:ext cx="2377440" cy="1645920"/>
           </a:xfrm>
           <a:prstGeom prst="roundRect">
             <a:avLst/>
           </a:prstGeom>
           <a:solidFill>
-            <a:srgbClr val="182026"/>
+            <a:srgbClr val="12181D"/>
           </a:solidFill>
           <a:ln w="12700">
             <a:solidFill>
-              <a:srgbClr val="24323B"/>
+              <a:srgbClr val="1E2932"/>
             </a:solidFill>
           </a:ln>
         </p:spPr>
@@ -3554,14 +3452,14 @@
       </p:sp>
       <p:sp>
         <p:nvSpPr>
-          <p:cNvPr id="11" name="TextBox 10"/>
+          <p:cNvPr id="9" name="TextBox 8"/>
           <p:cNvSpPr txBox="1"/>
           <p:nvPr/>
         </p:nvSpPr>
         <p:spPr>
           <a:xfrm>
-            <a:off x="6336792" y="4617720"/>
-            <a:ext cx="2194560" cy="1371600"/>
+            <a:off x="6400800" y="4572000"/>
+            <a:ext cx="2194560" cy="1280160"/>
           </a:xfrm>
           <a:prstGeom prst="rect">
             <a:avLst/>
@@ -3574,8 +3472,8 @@
           </a:bodyPr>
           <a:lstStyle/>
           <a:p>
-            <a:pPr>
-              <a:defRPr sz="2600" b="1">
+            <a:pPr algn="ctr">
+              <a:defRPr sz="2800" b="1">
                 <a:solidFill>
                   <a:srgbClr val="34D399"/>
                 </a:solidFill>
@@ -3587,8 +3485,8 @@
             </a:r>
           </a:p>
           <a:p>
-            <a:pPr>
-              <a:defRPr sz="1300" b="1">
+            <a:pPr algn="ctr">
+              <a:defRPr sz="1200" b="1">
                 <a:solidFill>
                   <a:srgbClr val="FFFFFF"/>
                 </a:solidFill>
@@ -3596,44 +3494,31 @@
               </a:defRPr>
             </a:pPr>
             <a:r>
-              <a:t>Срок годности</a:t>
-            </a:r>
-          </a:p>
-          <a:p>
-            <a:pPr>
-              <a:defRPr sz="1050">
-                <a:solidFill>
-                  <a:srgbClr val="94A3B8"/>
-                </a:solidFill>
-                <a:latin typeface="Plus Jakarta Sans"/>
-              </a:defRPr>
-            </a:pPr>
-            <a:r>
-              <a:t>Лазерная микроперфорация EMAP (-32% списаний)</a:t>
-            </a:r>
-          </a:p>
-        </p:txBody>
-      </p:sp>
-      <p:sp>
-        <p:nvSpPr>
-          <p:cNvPr id="12" name="Rounded Rectangle 11"/>
+              <a:t>Свежесть продуктов</a:t>
+            </a:r>
+          </a:p>
+        </p:txBody>
+      </p:sp>
+      <p:sp>
+        <p:nvSpPr>
+          <p:cNvPr id="10" name="Rounded Rectangle 9"/>
           <p:cNvSpPr/>
           <p:nvPr/>
         </p:nvSpPr>
         <p:spPr>
           <a:xfrm>
-            <a:off x="8887968" y="4480560"/>
-            <a:ext cx="2468880" cy="1645920"/>
+            <a:off x="8961120" y="4389120"/>
+            <a:ext cx="2377440" cy="1645920"/>
           </a:xfrm>
           <a:prstGeom prst="roundRect">
             <a:avLst/>
           </a:prstGeom>
           <a:solidFill>
-            <a:srgbClr val="182026"/>
+            <a:srgbClr val="12181D"/>
           </a:solidFill>
           <a:ln w="12700">
             <a:solidFill>
-              <a:srgbClr val="24323B"/>
+              <a:srgbClr val="1E2932"/>
             </a:solidFill>
           </a:ln>
         </p:spPr>
@@ -3661,14 +3546,14 @@
       </p:sp>
       <p:sp>
         <p:nvSpPr>
-          <p:cNvPr id="13" name="TextBox 12"/>
+          <p:cNvPr id="11" name="TextBox 10"/>
           <p:cNvSpPr txBox="1"/>
           <p:nvPr/>
         </p:nvSpPr>
         <p:spPr>
           <a:xfrm>
-            <a:off x="9025128" y="4617720"/>
-            <a:ext cx="2194560" cy="1371600"/>
+            <a:off x="9052560" y="4572000"/>
+            <a:ext cx="2194560" cy="1280160"/>
           </a:xfrm>
           <a:prstGeom prst="rect">
             <a:avLst/>
@@ -3681,8 +3566,8 @@
           </a:bodyPr>
           <a:lstStyle/>
           <a:p>
-            <a:pPr>
-              <a:defRPr sz="2600" b="1">
+            <a:pPr algn="ctr">
+              <a:defRPr sz="2800" b="1">
                 <a:solidFill>
                   <a:srgbClr val="34D399"/>
                 </a:solidFill>
@@ -3694,8 +3579,8 @@
             </a:r>
           </a:p>
           <a:p>
-            <a:pPr>
-              <a:defRPr sz="1300" b="1">
+            <a:pPr algn="ctr">
+              <a:defRPr sz="1200" b="1">
                 <a:solidFill>
                   <a:srgbClr val="FFFFFF"/>
                 </a:solidFill>
@@ -3704,19 +3589,6 @@
             </a:pPr>
             <a:r>
               <a:t>RecyClass &amp; PPWR</a:t>
-            </a:r>
-          </a:p>
-          <a:p>
-            <a:pPr>
-              <a:defRPr sz="1050">
-                <a:solidFill>
-                  <a:srgbClr val="94A3B8"/>
-                </a:solidFill>
-                <a:latin typeface="Plus Jakarta Sans"/>
-              </a:defRPr>
-            </a:pPr>
-            <a:r>
-              <a:t>100% моно-материалы в сортировочные потоки</a:t>
             </a:r>
           </a:p>
         </p:txBody>
@@ -3754,11 +3626,11 @@
             <a:avLst/>
           </a:prstGeom>
           <a:solidFill>
-            <a:srgbClr val="0F1418"/>
+            <a:srgbClr val="0A0E11"/>
           </a:solidFill>
           <a:ln>
             <a:solidFill>
-              <a:srgbClr val="0F1418"/>
+              <a:srgbClr val="0A0E11"/>
             </a:solidFill>
           </a:ln>
         </p:spPr>
@@ -3792,8 +3664,8 @@
         </p:nvSpPr>
         <p:spPr>
           <a:xfrm>
-            <a:off x="822960" y="411480"/>
-            <a:ext cx="8686800" cy="320040"/>
+            <a:off x="914400" y="365760"/>
+            <a:ext cx="10362895" cy="320040"/>
           </a:xfrm>
           <a:prstGeom prst="rect">
             <a:avLst/>
@@ -3806,7 +3678,7 @@
           </a:bodyPr>
           <a:lstStyle/>
           <a:p>
-            <a:pPr>
+            <a:pPr algn="ctr">
               <a:defRPr sz="1100" b="1">
                 <a:solidFill>
                   <a:srgbClr val="34D399"/>
@@ -3815,7 +3687,7 @@
               </a:defRPr>
             </a:pPr>
             <a:r>
-              <a:t>КОНТЕКСТ И ВЫЗОВ • GIGAHACK 2026</a:t>
+              <a:t>ТЕХНОЛОГИЧЕСКИЙ РАЗРЫВ</a:t>
             </a:r>
           </a:p>
         </p:txBody>
@@ -3828,8 +3700,8 @@
         </p:nvSpPr>
         <p:spPr>
           <a:xfrm>
-            <a:off x="822960" y="685800"/>
-            <a:ext cx="8686800" cy="731520"/>
+            <a:off x="914400" y="685800"/>
+            <a:ext cx="10362895" cy="685800"/>
           </a:xfrm>
           <a:prstGeom prst="rect">
             <a:avLst/>
@@ -3842,8 +3714,8 @@
           </a:bodyPr>
           <a:lstStyle/>
           <a:p>
-            <a:pPr>
-              <a:defRPr sz="2200" b="1">
+            <a:pPr algn="ctr">
+              <a:defRPr sz="2400" b="1">
                 <a:solidFill>
                   <a:srgbClr val="FFFFFF"/>
                 </a:solidFill>
@@ -3851,7 +3723,7 @@
               </a:defRPr>
             </a:pPr>
             <a:r>
-              <a:t>Регуляторный капкан ритейла и острая боль витрин</a:t>
+              <a:t>Традиционная упаковка vs Решение PackShift</a:t>
             </a:r>
           </a:p>
         </p:txBody>
@@ -3864,8 +3736,8 @@
         </p:nvSpPr>
         <p:spPr>
           <a:xfrm>
-            <a:off x="10241280" y="457200"/>
-            <a:ext cx="1188720" cy="365760"/>
+            <a:off x="10332720" y="365760"/>
+            <a:ext cx="1097280" cy="320040"/>
           </a:xfrm>
           <a:prstGeom prst="rect">
             <a:avLst/>
@@ -3879,7 +3751,7 @@
           <a:lstStyle/>
           <a:p>
             <a:pPr algn="r">
-              <a:defRPr sz="1200" b="1">
+              <a:defRPr sz="1100" b="1">
                 <a:solidFill>
                   <a:srgbClr val="94A3B8"/>
                 </a:solidFill>
@@ -3894,24 +3766,24 @@
       </p:sp>
       <p:sp>
         <p:nvSpPr>
-          <p:cNvPr id="6" name="Rectangle 5"/>
+          <p:cNvPr id="6" name="Rounded Rectangle 5"/>
           <p:cNvSpPr/>
           <p:nvPr/>
         </p:nvSpPr>
         <p:spPr>
           <a:xfrm>
-            <a:off x="822960" y="1371600"/>
-            <a:ext cx="10545775" cy="18288"/>
-          </a:xfrm>
-          <a:prstGeom prst="rect">
+            <a:off x="914400" y="1645920"/>
+            <a:ext cx="4754880" cy="4572000"/>
+          </a:xfrm>
+          <a:prstGeom prst="roundRect">
             <a:avLst/>
           </a:prstGeom>
           <a:solidFill>
-            <a:srgbClr val="24323B"/>
+            <a:srgbClr val="12181D"/>
           </a:solidFill>
-          <a:ln>
+          <a:ln w="19050">
             <a:solidFill>
-              <a:srgbClr val="24323B"/>
+              <a:srgbClr val="7F1D1D"/>
             </a:solidFill>
           </a:ln>
         </p:spPr>
@@ -3939,59 +3811,14 @@
       </p:sp>
       <p:sp>
         <p:nvSpPr>
-          <p:cNvPr id="7" name="Rounded Rectangle 6"/>
-          <p:cNvSpPr/>
-          <p:nvPr/>
-        </p:nvSpPr>
-        <p:spPr>
-          <a:xfrm>
-            <a:off x="822960" y="1645920"/>
-            <a:ext cx="5120640" cy="4572000"/>
-          </a:xfrm>
-          <a:prstGeom prst="roundRect">
-            <a:avLst/>
-          </a:prstGeom>
-          <a:solidFill>
-            <a:srgbClr val="182026"/>
-          </a:solidFill>
-          <a:ln w="12700">
-            <a:solidFill>
-              <a:srgbClr val="24323B"/>
-            </a:solidFill>
-          </a:ln>
-        </p:spPr>
-        <p:style>
-          <a:lnRef idx="1">
-            <a:schemeClr val="accent1"/>
-          </a:lnRef>
-          <a:fillRef idx="3">
-            <a:schemeClr val="accent1"/>
-          </a:fillRef>
-          <a:effectRef idx="2">
-            <a:schemeClr val="accent1"/>
-          </a:effectRef>
-          <a:fontRef idx="minor">
-            <a:schemeClr val="lt1"/>
-          </a:fontRef>
-        </p:style>
-        <p:txBody>
-          <a:bodyPr rtlCol="0" anchor="ctr"/>
-          <a:lstStyle/>
-          <a:p>
-            <a:pPr algn="ctr"/>
-          </a:p>
-        </p:txBody>
-      </p:sp>
-      <p:sp>
-        <p:nvSpPr>
-          <p:cNvPr id="8" name="TextBox 7"/>
+          <p:cNvPr id="7" name="TextBox 6"/>
           <p:cNvSpPr txBox="1"/>
           <p:nvPr/>
         </p:nvSpPr>
         <p:spPr>
           <a:xfrm>
-            <a:off x="1051560" y="1828800"/>
-            <a:ext cx="4663440" cy="4206240"/>
+            <a:off x="1097280" y="1828800"/>
+            <a:ext cx="4389120" cy="4114800"/>
           </a:xfrm>
           <a:prstGeom prst="rect">
             <a:avLst/>
@@ -4005,115 +3832,135 @@
           <a:lstStyle/>
           <a:p>
             <a:pPr>
-              <a:defRPr sz="1800" b="1">
-                <a:solidFill>
-                  <a:srgbClr val="34D399"/>
-                </a:solidFill>
-                <a:latin typeface="Plus Jakarta Sans"/>
-              </a:defRPr>
-            </a:pPr>
-            <a:r>
-              <a:t>⚖️ 1. Регуляторное давление и налоги</a:t>
-            </a:r>
-          </a:p>
-          <a:p>
+              <a:defRPr sz="1200" b="1">
+                <a:solidFill>
+                  <a:srgbClr val="EF4444"/>
+                </a:solidFill>
+                <a:latin typeface="JetBrains Mono"/>
+              </a:defRPr>
+            </a:pPr>
+            <a:r>
+              <a:t>❌ ТРАДИЦИОННАЯ УПАКОВКА (ТУПИК)</a:t>
+            </a:r>
+          </a:p>
+          <a:p>
+            <a:br/>
             <a:pPr>
-              <a:defRPr b="1" sz="1150">
+              <a:defRPr b="1" sz="1200">
                 <a:solidFill>
                   <a:srgbClr val="FFFFFF"/>
                 </a:solidFill>
               </a:defRPr>
             </a:pPr>
             <a:r>
-              <a:t>• Директива EU PPWR 2030: </a:t>
-            </a:r>
-            <a:r>
-              <a:rPr b="0">
+              <a:t>▪ Многослойный ламинат (ПЭ+ALU)</a:t>
+            </a:r>
+            <a:br/>
+            <a:r>
+              <a:t>  </a:t>
+            </a:r>
+            <a:r>
+              <a:rPr b="0" sz="1050">
                 <a:solidFill>
                   <a:srgbClr val="94A3B8"/>
                 </a:solidFill>
               </a:rPr>
-              <a:t>Запрет многослойных неперерабатываемых полимеров. Штрафы ритейлерам за превышение квот первичного пластика.</a:t>
-            </a:r>
-          </a:p>
-          <a:p>
+              <a:t>Не перерабатывается $_x000D_ightarrow$ штрафы EPR до +45%</a:t>
+            </a:r>
+          </a:p>
+          <a:p>
+            <a:br/>
             <a:pPr>
-              <a:defRPr b="1" sz="1150">
+              <a:defRPr b="1" sz="1200">
                 <a:solidFill>
                   <a:srgbClr val="FFFFFF"/>
                 </a:solidFill>
               </a:defRPr>
             </a:pPr>
             <a:r>
-              <a:t>• Экологический сбор (EPR): </a:t>
-            </a:r>
-            <a:r>
-              <a:rPr b="0">
+              <a:t>▪ Плавление при 95°C–120°C</a:t>
+            </a:r>
+            <a:br/>
+            <a:r>
+              <a:t>  </a:t>
+            </a:r>
+            <a:r>
+              <a:rPr b="0" sz="1050">
                 <a:solidFill>
                   <a:srgbClr val="94A3B8"/>
                 </a:solidFill>
               </a:rPr>
-              <a:t>Ставка налога на комбинированные ламинаты (ПЭ+алюминий) выросла на 45%. Неперерабатываемая упаковка становится прямым убытком.</a:t>
-            </a:r>
-          </a:p>
-          <a:p>
+              <a:t>Течь горячего жира в витрине и запах синтетики</a:t>
+            </a:r>
+          </a:p>
+          <a:p>
+            <a:br/>
             <a:pPr>
-              <a:defRPr b="1" sz="1150">
+              <a:defRPr b="1" sz="1200">
                 <a:solidFill>
                   <a:srgbClr val="FFFFFF"/>
                 </a:solidFill>
               </a:defRPr>
             </a:pPr>
             <a:r>
-              <a:t>• Тотальный бан на PFAS: </a:t>
-            </a:r>
-            <a:r>
-              <a:rPr b="0">
+              <a:t>▪ Токсичные добавки PFAS</a:t>
+            </a:r>
+            <a:br/>
+            <a:r>
+              <a:t>  </a:t>
+            </a:r>
+            <a:r>
+              <a:rPr b="0" sz="1050">
                 <a:solidFill>
                   <a:srgbClr val="94A3B8"/>
                 </a:solidFill>
               </a:rPr>
-              <a:t>Европейский запрет пер- и полифторалкильных гидрофобизаторов в прямом пищевом контакте.</a:t>
-            </a:r>
-          </a:p>
-          <a:p>
+              <a:t>Миграция опасных фторорганик в пищу при нагреве</a:t>
+            </a:r>
+          </a:p>
+          <a:p>
+            <a:br/>
             <a:pPr>
-              <a:defRPr b="1" sz="1150">
+              <a:defRPr b="1" sz="1200">
                 <a:solidFill>
                   <a:srgbClr val="FFFFFF"/>
                 </a:solidFill>
               </a:defRPr>
             </a:pPr>
             <a:r>
-              <a:t>• Аудит Scope 3 (CSRD): </a:t>
-            </a:r>
-            <a:r>
-              <a:rPr b="0">
+              <a:t>▪ «Парниковый эффект»</a:t>
+            </a:r>
+            <a:br/>
+            <a:r>
+              <a:t>  </a:t>
+            </a:r>
+            <a:r>
+              <a:rPr b="0" sz="1050">
                 <a:solidFill>
                   <a:srgbClr val="94A3B8"/>
                 </a:solidFill>
               </a:rPr>
-              <a:t>Сеть Profi обязана публично сокращать углеродный след упаковки по всей цепочке.</a:t>
-            </a:r>
-          </a:p>
-        </p:txBody>
-      </p:sp>
-      <p:sp>
-        <p:nvSpPr>
-          <p:cNvPr id="9" name="Rounded Rectangle 8"/>
+              <a:t>Пар блокирован: корочка гриля размокает за 40 мин</a:t>
+            </a:r>
+          </a:p>
+        </p:txBody>
+      </p:sp>
+      <p:sp>
+        <p:nvSpPr>
+          <p:cNvPr id="8" name="Rounded Rectangle 7"/>
           <p:cNvSpPr/>
           <p:nvPr/>
         </p:nvSpPr>
         <p:spPr>
           <a:xfrm>
-            <a:off x="6217920" y="1645920"/>
-            <a:ext cx="5120640" cy="4572000"/>
+            <a:off x="6492240" y="1645920"/>
+            <a:ext cx="4754880" cy="4572000"/>
           </a:xfrm>
           <a:prstGeom prst="roundRect">
             <a:avLst/>
           </a:prstGeom>
           <a:solidFill>
-            <a:srgbClr val="182026"/>
+            <a:srgbClr val="102E22"/>
           </a:solidFill>
           <a:ln w="19050">
             <a:solidFill>
@@ -4145,14 +3992,14 @@
       </p:sp>
       <p:sp>
         <p:nvSpPr>
-          <p:cNvPr id="10" name="TextBox 9"/>
+          <p:cNvPr id="9" name="TextBox 8"/>
           <p:cNvSpPr txBox="1"/>
           <p:nvPr/>
         </p:nvSpPr>
         <p:spPr>
           <a:xfrm>
-            <a:off x="6446520" y="1828800"/>
-            <a:ext cx="4663440" cy="4206240"/>
+            <a:off x="6675120" y="1828800"/>
+            <a:ext cx="4389120" cy="4114800"/>
           </a:xfrm>
           <a:prstGeom prst="rect">
             <a:avLst/>
@@ -4166,95 +4013,115 @@
           <a:lstStyle/>
           <a:p>
             <a:pPr>
-              <a:defRPr sz="1800" b="1">
+              <a:defRPr sz="1200" b="1">
                 <a:solidFill>
                   <a:srgbClr val="34D399"/>
                 </a:solidFill>
-                <a:latin typeface="Plus Jakarta Sans"/>
-              </a:defRPr>
-            </a:pPr>
-            <a:r>
-              <a:t>🔥 2. Острая боль: Отдел гриля и кулинарии</a:t>
-            </a:r>
-          </a:p>
-          <a:p>
+                <a:latin typeface="JetBrains Mono"/>
+              </a:defRPr>
+            </a:pPr>
+            <a:r>
+              <a:t>✔ ИННОВАЦИЯ PACKSHIFT DEEPTECH</a:t>
+            </a:r>
+          </a:p>
+          <a:p>
+            <a:br/>
             <a:pPr>
-              <a:defRPr b="1" sz="1150">
+              <a:defRPr b="1" sz="1200">
+                <a:solidFill>
+                  <a:srgbClr val="34D399"/>
+                </a:solidFill>
+              </a:defRPr>
+            </a:pPr>
+            <a:r>
+              <a:t>✔ 100% моно-материал rPET</a:t>
+            </a:r>
+            <a:br/>
+            <a:r>
+              <a:t>  </a:t>
+            </a:r>
+            <a:r>
+              <a:rPr b="0" sz="1050">
                 <a:solidFill>
                   <a:srgbClr val="FFFFFF"/>
                 </a:solidFill>
-              </a:defRPr>
-            </a:pPr>
-            <a:r>
-              <a:t>• Экстремальный режим: </a:t>
-            </a:r>
-            <a:r>
-              <a:rPr b="0">
-                <a:solidFill>
-                  <a:srgbClr val="94A3B8"/>
-                </a:solidFill>
               </a:rPr>
-              <a:t>Выдержка в витрине при 85°C – 120°C до 6 часов. Пиковые температуры фасовки достигают 180°C – 250°C.</a:t>
-            </a:r>
-          </a:p>
-          <a:p>
+              <a:t>RecyClass Class A $_x000D_ightarrow$ прямое освобождение от EPR-налога</a:t>
+            </a:r>
+          </a:p>
+          <a:p>
+            <a:br/>
             <a:pPr>
-              <a:defRPr b="1" sz="1150">
+              <a:defRPr b="1" sz="1200">
+                <a:solidFill>
+                  <a:srgbClr val="34D399"/>
+                </a:solidFill>
+              </a:defRPr>
+            </a:pPr>
+            <a:r>
+              <a:t>✔ Стойкость до 250°C (Dual-Oven)</a:t>
+            </a:r>
+            <a:br/>
+            <a:r>
+              <a:t>  </a:t>
+            </a:r>
+            <a:r>
+              <a:rPr b="0" sz="1050">
                 <a:solidFill>
                   <a:srgbClr val="FFFFFF"/>
                 </a:solidFill>
-              </a:defRPr>
-            </a:pPr>
-            <a:r>
-              <a:t>• Дефекты текущих пакетов: </a:t>
-            </a:r>
-            <a:r>
-              <a:rPr b="0">
-                <a:solidFill>
-                  <a:srgbClr val="94A3B8"/>
-                </a:solidFill>
               </a:rPr>
-              <a:t>Полиэтилен с фольгой плавится, дает течь жира и выделяет резкий запах нагретого пластика.</a:t>
-            </a:r>
-          </a:p>
-          <a:p>
+              <a:t>Более 6 часов в витрине при 95°C без усадки и дефектов</a:t>
+            </a:r>
+          </a:p>
+          <a:p>
+            <a:br/>
             <a:pPr>
-              <a:defRPr b="1" sz="1150">
+              <a:defRPr b="1" sz="1200">
+                <a:solidFill>
+                  <a:srgbClr val="34D399"/>
+                </a:solidFill>
+              </a:defRPr>
+            </a:pPr>
+            <a:r>
+              <a:t>✔ 100% PFAS-Free барьер Kit 12</a:t>
+            </a:r>
+            <a:br/>
+            <a:r>
+              <a:t>  </a:t>
+            </a:r>
+            <a:r>
+              <a:rPr b="0" sz="1050">
                 <a:solidFill>
                   <a:srgbClr val="FFFFFF"/>
                 </a:solidFill>
-              </a:defRPr>
-            </a:pPr>
-            <a:r>
-              <a:t>• «Парниковый эффект»: </a:t>
-            </a:r>
-            <a:r>
-              <a:rPr b="0">
-                <a:solidFill>
-                  <a:srgbClr val="94A3B8"/>
-                </a:solidFill>
               </a:rPr>
-              <a:t>Пар блокируется, аппетитная корочка гриля размокает в кашу за 40 минут — потеря лояльности покупателей.</a:t>
-            </a:r>
-          </a:p>
-          <a:p>
+              <a:t>Водная нано-дисперсия альгината водорослей и хитозана</a:t>
+            </a:r>
+          </a:p>
+          <a:p>
+            <a:br/>
             <a:pPr>
-              <a:defRPr b="1" sz="1150">
+              <a:defRPr b="1" sz="1200">
+                <a:solidFill>
+                  <a:srgbClr val="34D399"/>
+                </a:solidFill>
+              </a:defRPr>
+            </a:pPr>
+            <a:r>
+              <a:t>✔ Дышащая микропористая мембрана</a:t>
+            </a:r>
+            <a:br/>
+            <a:r>
+              <a:t>  </a:t>
+            </a:r>
+            <a:r>
+              <a:rPr b="0" sz="1050">
                 <a:solidFill>
                   <a:srgbClr val="FFFFFF"/>
                 </a:solidFill>
-              </a:defRPr>
-            </a:pPr>
-            <a:r>
-              <a:t>• Скрытые токсины: </a:t>
-            </a:r>
-            <a:r>
-              <a:rPr b="0">
-                <a:solidFill>
-                  <a:srgbClr val="94A3B8"/>
-                </a:solidFill>
               </a:rPr>
-              <a:t>Жиростойкость текущих пакетов держится на PFAS, мигрирующих в горячую пищу.</a:t>
+              <a:t>Отводит лишний пар, сохраняя корочку гриля хрустящей</a:t>
             </a:r>
           </a:p>
         </p:txBody>
@@ -4292,11 +4159,11 @@
             <a:avLst/>
           </a:prstGeom>
           <a:solidFill>
-            <a:srgbClr val="0F1418"/>
+            <a:srgbClr val="0A0E11"/>
           </a:solidFill>
           <a:ln>
             <a:solidFill>
-              <a:srgbClr val="0F1418"/>
+              <a:srgbClr val="0A0E11"/>
             </a:solidFill>
           </a:ln>
         </p:spPr>
@@ -4330,8 +4197,8 @@
         </p:nvSpPr>
         <p:spPr>
           <a:xfrm>
-            <a:off x="822960" y="411480"/>
-            <a:ext cx="8686800" cy="320040"/>
+            <a:off x="914400" y="365760"/>
+            <a:ext cx="10362895" cy="320040"/>
           </a:xfrm>
           <a:prstGeom prst="rect">
             <a:avLst/>
@@ -4344,7 +4211,7 @@
           </a:bodyPr>
           <a:lstStyle/>
           <a:p>
-            <a:pPr>
+            <a:pPr algn="ctr">
               <a:defRPr sz="1100" b="1">
                 <a:solidFill>
                   <a:srgbClr val="34D399"/>
@@ -4353,7 +4220,7 @@
               </a:defRPr>
             </a:pPr>
             <a:r>
-              <a:t>СПЕЦИАЛЬНЫЙ ВЫЗОВ • GIGAHACK 2026</a:t>
+              <a:t>СПЕЦИАЛЬНЫЙ ВЫЗОВ ХАКАТОНА</a:t>
             </a:r>
           </a:p>
         </p:txBody>
@@ -4366,8 +4233,8 @@
         </p:nvSpPr>
         <p:spPr>
           <a:xfrm>
-            <a:off x="822960" y="685800"/>
-            <a:ext cx="8686800" cy="731520"/>
+            <a:off x="914400" y="685800"/>
+            <a:ext cx="10362895" cy="685800"/>
           </a:xfrm>
           <a:prstGeom prst="rect">
             <a:avLst/>
@@ -4380,8 +4247,8 @@
           </a:bodyPr>
           <a:lstStyle/>
           <a:p>
-            <a:pPr>
-              <a:defRPr sz="2200" b="1">
+            <a:pPr algn="ctr">
+              <a:defRPr sz="2400" b="1">
                 <a:solidFill>
                   <a:srgbClr val="FFFFFF"/>
                 </a:solidFill>
@@ -4389,7 +4256,7 @@
               </a:defRPr>
             </a:pPr>
             <a:r>
-              <a:t>Инженерные решения для Горячего Гриля (180°C – 250°C)</a:t>
+              <a:t>Материаловедение: 2 решения для витрин гриля (250°C)</a:t>
             </a:r>
           </a:p>
         </p:txBody>
@@ -4402,8 +4269,8 @@
         </p:nvSpPr>
         <p:spPr>
           <a:xfrm>
-            <a:off x="10241280" y="457200"/>
-            <a:ext cx="1188720" cy="365760"/>
+            <a:off x="10332720" y="365760"/>
+            <a:ext cx="1097280" cy="320040"/>
           </a:xfrm>
           <a:prstGeom prst="rect">
             <a:avLst/>
@@ -4417,7 +4284,7 @@
           <a:lstStyle/>
           <a:p>
             <a:pPr algn="r">
-              <a:defRPr sz="1200" b="1">
+              <a:defRPr sz="1100" b="1">
                 <a:solidFill>
                   <a:srgbClr val="94A3B8"/>
                 </a:solidFill>
@@ -4432,65 +4299,20 @@
       </p:sp>
       <p:sp>
         <p:nvSpPr>
-          <p:cNvPr id="6" name="Rectangle 5"/>
+          <p:cNvPr id="6" name="Rounded Rectangle 5"/>
           <p:cNvSpPr/>
           <p:nvPr/>
         </p:nvSpPr>
         <p:spPr>
           <a:xfrm>
-            <a:off x="822960" y="1371600"/>
-            <a:ext cx="10545775" cy="18288"/>
-          </a:xfrm>
-          <a:prstGeom prst="rect">
+            <a:off x="914400" y="1645920"/>
+            <a:ext cx="4846320" cy="4572000"/>
+          </a:xfrm>
+          <a:prstGeom prst="roundRect">
             <a:avLst/>
           </a:prstGeom>
           <a:solidFill>
-            <a:srgbClr val="24323B"/>
-          </a:solidFill>
-          <a:ln>
-            <a:solidFill>
-              <a:srgbClr val="24323B"/>
-            </a:solidFill>
-          </a:ln>
-        </p:spPr>
-        <p:style>
-          <a:lnRef idx="1">
-            <a:schemeClr val="accent1"/>
-          </a:lnRef>
-          <a:fillRef idx="3">
-            <a:schemeClr val="accent1"/>
-          </a:fillRef>
-          <a:effectRef idx="2">
-            <a:schemeClr val="accent1"/>
-          </a:effectRef>
-          <a:fontRef idx="minor">
-            <a:schemeClr val="lt1"/>
-          </a:fontRef>
-        </p:style>
-        <p:txBody>
-          <a:bodyPr rtlCol="0" anchor="ctr"/>
-          <a:lstStyle/>
-          <a:p>
-            <a:pPr algn="ctr"/>
-          </a:p>
-        </p:txBody>
-      </p:sp>
-      <p:sp>
-        <p:nvSpPr>
-          <p:cNvPr id="7" name="Rounded Rectangle 6"/>
-          <p:cNvSpPr/>
-          <p:nvPr/>
-        </p:nvSpPr>
-        <p:spPr>
-          <a:xfrm>
-            <a:off x="822960" y="1645920"/>
-            <a:ext cx="5120640" cy="4572000"/>
-          </a:xfrm>
-          <a:prstGeom prst="roundRect">
-            <a:avLst/>
-          </a:prstGeom>
-          <a:solidFill>
-            <a:srgbClr val="182026"/>
+            <a:srgbClr val="102E22"/>
           </a:solidFill>
           <a:ln w="19050">
             <a:solidFill>
@@ -4522,14 +4344,14 @@
       </p:sp>
       <p:sp>
         <p:nvSpPr>
-          <p:cNvPr id="8" name="TextBox 7"/>
+          <p:cNvPr id="7" name="TextBox 6"/>
           <p:cNvSpPr txBox="1"/>
           <p:nvPr/>
         </p:nvSpPr>
         <p:spPr>
           <a:xfrm>
-            <a:off x="1051560" y="1828800"/>
-            <a:ext cx="4663440" cy="4206240"/>
+            <a:off x="1097280" y="1828800"/>
+            <a:ext cx="4480560" cy="4114800"/>
           </a:xfrm>
           <a:prstGeom prst="rect">
             <a:avLst/>
@@ -4545,7 +4367,7 @@
             <a:pPr>
               <a:defRPr sz="1100" b="1">
                 <a:solidFill>
-                  <a:srgbClr val="10B981"/>
+                  <a:srgbClr val="34D399"/>
                 </a:solidFill>
                 <a:latin typeface="JetBrains Mono"/>
               </a:defRPr>
@@ -4556,7 +4378,7 @@
           </a:p>
           <a:p>
             <a:pPr>
-              <a:defRPr sz="2100" b="1">
+              <a:defRPr sz="2200" b="1">
                 <a:solidFill>
                   <a:srgbClr val="FFFFFF"/>
                 </a:solidFill>
@@ -4564,151 +4386,91 @@
               </a:defRPr>
             </a:pPr>
             <a:r>
-              <a:t>PackShift CPET Ultra-Flex</a:t>
+              <a:t>CPET Ultra-Flex</a:t>
             </a:r>
           </a:p>
           <a:p>
             <a:pPr>
-              <a:defRPr b="1" sz="1150">
-                <a:solidFill>
-                  <a:srgbClr val="34D399"/>
-                </a:solidFill>
-              </a:defRPr>
-            </a:pPr>
-            <a:r>
-              <a:t>Материал: </a:t>
-            </a:r>
-            <a:r>
-              <a:rPr b="0">
-                <a:solidFill>
-                  <a:srgbClr val="94A3B8"/>
-                </a:solidFill>
-              </a:rPr>
-              <a:t>Кристаллический модифицированный rPET (степень кристалличности &gt; 38%).</a:t>
+              <a:defRPr sz="1150">
+                <a:solidFill>
+                  <a:srgbClr val="FFFFFF"/>
+                </a:solidFill>
+              </a:defRPr>
+            </a:pPr>
+            <a:r>
+              <a:t>✔ Диапазон от -40°C до +250°C (Dual-Ovenable)</a:t>
             </a:r>
           </a:p>
           <a:p>
             <a:pPr>
-              <a:defRPr b="1" sz="1150">
-                <a:solidFill>
-                  <a:srgbClr val="34D399"/>
-                </a:solidFill>
-              </a:defRPr>
-            </a:pPr>
-            <a:r>
-              <a:t>Термостойкость: </a:t>
-            </a:r>
-            <a:r>
-              <a:rPr b="0">
-                <a:solidFill>
-                  <a:srgbClr val="94A3B8"/>
-                </a:solidFill>
-              </a:rPr>
-              <a:t>от -40°C до +250°C (Dual-Ovenable: разогрев прямо в упаковке).</a:t>
+              <a:defRPr sz="1150">
+                <a:solidFill>
+                  <a:srgbClr val="FFFFFF"/>
+                </a:solidFill>
+              </a:defRPr>
+            </a:pPr>
+            <a:r>
+              <a:t>✔ Кристалличность rPET &gt; 38% держит форму 6+ часов</a:t>
             </a:r>
           </a:p>
           <a:p>
             <a:pPr>
-              <a:defRPr b="1" sz="1150">
-                <a:solidFill>
-                  <a:srgbClr val="34D399"/>
-                </a:solidFill>
-              </a:defRPr>
-            </a:pPr>
-            <a:r>
-              <a:t>Тепловая витрина: </a:t>
-            </a:r>
-            <a:r>
-              <a:rPr b="0">
-                <a:solidFill>
-                  <a:srgbClr val="94A3B8"/>
-                </a:solidFill>
-              </a:rPr>
-              <a:t>6+ часов при 95°C–120°C без усадки, протечек и запаха.</a:t>
+              <a:defRPr sz="1150">
+                <a:solidFill>
+                  <a:srgbClr val="FFFFFF"/>
+                </a:solidFill>
+              </a:defRPr>
+            </a:pPr>
+            <a:r>
+              <a:t>✔ 100% жиробарьер Kit Test 12 без PFAS</a:t>
             </a:r>
           </a:p>
           <a:p>
             <a:pPr>
-              <a:defRPr b="1" sz="1150">
-                <a:solidFill>
-                  <a:srgbClr val="34D399"/>
-                </a:solidFill>
-              </a:defRPr>
-            </a:pPr>
-            <a:r>
-              <a:t>Жиростойкость: </a:t>
-            </a:r>
-            <a:r>
-              <a:rPr b="0">
-                <a:solidFill>
-                  <a:srgbClr val="94A3B8"/>
-                </a:solidFill>
-              </a:rPr>
-              <a:t>Высший класс Kit Test 12. 100% PFAS-Free.</a:t>
+              <a:defRPr sz="1150">
+                <a:solidFill>
+                  <a:srgbClr val="FFFFFF"/>
+                </a:solidFill>
+              </a:defRPr>
+            </a:pPr>
+            <a:r>
+              <a:t>✔ 100% вторичная переработка в поток ПЭТ-бутылок</a:t>
             </a:r>
           </a:p>
           <a:p>
             <a:pPr>
-              <a:defRPr b="1" sz="1150">
-                <a:solidFill>
-                  <a:srgbClr val="34D399"/>
-                </a:solidFill>
-              </a:defRPr>
-            </a:pPr>
-            <a:r>
-              <a:t>Рециклинг: </a:t>
-            </a:r>
-            <a:r>
-              <a:rPr b="0">
-                <a:solidFill>
-                  <a:srgbClr val="94A3B8"/>
-                </a:solidFill>
-              </a:rPr>
-              <a:t>100% моно-материал. Поток ПЭТ-бутылок (RecyClass Class A).</a:t>
-            </a:r>
-          </a:p>
-          <a:p>
-            <a:pPr>
-              <a:defRPr b="1" sz="1150">
-                <a:solidFill>
-                  <a:srgbClr val="34D399"/>
-                </a:solidFill>
-              </a:defRPr>
-            </a:pPr>
-            <a:r>
-              <a:t>Себестоимость: </a:t>
-            </a:r>
-            <a:r>
-              <a:rPr b="0">
-                <a:solidFill>
-                  <a:srgbClr val="94A3B8"/>
-                </a:solidFill>
-              </a:rPr>
-              <a:t>-14% vs импортный барьерный ламинат с алюминием.</a:t>
-            </a:r>
-          </a:p>
-        </p:txBody>
-      </p:sp>
-      <p:sp>
-        <p:nvSpPr>
-          <p:cNvPr id="9" name="Rounded Rectangle 8"/>
+              <a:defRPr sz="1150">
+                <a:solidFill>
+                  <a:srgbClr val="FFFFFF"/>
+                </a:solidFill>
+              </a:defRPr>
+            </a:pPr>
+            <a:r>
+              <a:t>✔ Себестоимость: -14% vs импортный ламинат с фольгой</a:t>
+            </a:r>
+          </a:p>
+        </p:txBody>
+      </p:sp>
+      <p:sp>
+        <p:nvSpPr>
+          <p:cNvPr id="8" name="Rounded Rectangle 7"/>
           <p:cNvSpPr/>
           <p:nvPr/>
         </p:nvSpPr>
         <p:spPr>
           <a:xfrm>
-            <a:off x="6217920" y="1645920"/>
-            <a:ext cx="5120640" cy="4572000"/>
+            <a:off x="6400800" y="1645920"/>
+            <a:ext cx="4846320" cy="4572000"/>
           </a:xfrm>
           <a:prstGeom prst="roundRect">
             <a:avLst/>
           </a:prstGeom>
           <a:solidFill>
-            <a:srgbClr val="182026"/>
+            <a:srgbClr val="12181D"/>
           </a:solidFill>
-          <a:ln w="12700">
+          <a:ln w="19050">
             <a:solidFill>
-              <a:srgbClr val="24323B"/>
+              <a:srgbClr val="1E2932"/>
             </a:solidFill>
           </a:ln>
         </p:spPr>
@@ -4736,14 +4498,14 @@
       </p:sp>
       <p:sp>
         <p:nvSpPr>
-          <p:cNvPr id="10" name="TextBox 9"/>
+          <p:cNvPr id="9" name="TextBox 8"/>
           <p:cNvSpPr txBox="1"/>
           <p:nvPr/>
         </p:nvSpPr>
         <p:spPr>
           <a:xfrm>
-            <a:off x="6446520" y="1828800"/>
-            <a:ext cx="4663440" cy="4206240"/>
+            <a:off x="6583680" y="1828800"/>
+            <a:ext cx="4480560" cy="4114800"/>
           </a:xfrm>
           <a:prstGeom prst="rect">
             <a:avLst/>
@@ -4759,18 +4521,18 @@
             <a:pPr>
               <a:defRPr sz="1100" b="1">
                 <a:solidFill>
-                  <a:srgbClr val="10B981"/>
+                  <a:srgbClr val="34D399"/>
                 </a:solidFill>
                 <a:latin typeface="JetBrains Mono"/>
               </a:defRPr>
             </a:pPr>
             <a:r>
-              <a:t>РЕШЕНИЕ Б: БИО-КОМПОЗИТ (PROFI BIO)</a:t>
+              <a:t>РЕШЕНИЕ Б: БИО-КОМПОЗИТ</a:t>
             </a:r>
           </a:p>
           <a:p>
             <a:pPr>
-              <a:defRPr sz="2100" b="1">
+              <a:defRPr sz="2200" b="1">
                 <a:solidFill>
                   <a:srgbClr val="FFFFFF"/>
                 </a:solidFill>
@@ -4778,127 +4540,67 @@
               </a:defRPr>
             </a:pPr>
             <a:r>
-              <a:t>LignoShield™ ThermoBox</a:t>
+              <a:t>LignoShield™ BioBox</a:t>
             </a:r>
           </a:p>
           <a:p>
             <a:pPr>
-              <a:defRPr b="1" sz="1150">
-                <a:solidFill>
-                  <a:srgbClr val="34D399"/>
-                </a:solidFill>
-              </a:defRPr>
-            </a:pPr>
-            <a:r>
-              <a:t>Материал: </a:t>
-            </a:r>
-            <a:r>
-              <a:rPr b="0">
-                <a:solidFill>
-                  <a:srgbClr val="94A3B8"/>
-                </a:solidFill>
-              </a:rPr>
-              <a:t>100% формованная багасса сахарного тростника + альгинат/хитозан из водорослей.</a:t>
+              <a:defRPr sz="1150">
+                <a:solidFill>
+                  <a:srgbClr val="FFFFFF"/>
+                </a:solidFill>
+              </a:defRPr>
+            </a:pPr>
+            <a:r>
+              <a:t>✔ 100% формованная багасса сахарного тростника</a:t>
             </a:r>
           </a:p>
           <a:p>
             <a:pPr>
-              <a:defRPr b="1" sz="1150">
-                <a:solidFill>
-                  <a:srgbClr val="34D399"/>
-                </a:solidFill>
-              </a:defRPr>
-            </a:pPr>
-            <a:r>
-              <a:t>Дышащая мембрана: </a:t>
-            </a:r>
-            <a:r>
-              <a:rPr b="0">
-                <a:solidFill>
-                  <a:srgbClr val="94A3B8"/>
-                </a:solidFill>
-              </a:rPr>
-              <a:t>Микропористая структура стравливает пар. Корочка гриля остается хрустящей.</a:t>
+              <a:defRPr sz="1150">
+                <a:solidFill>
+                  <a:srgbClr val="FFFFFF"/>
+                </a:solidFill>
+              </a:defRPr>
+            </a:pPr>
+            <a:r>
+              <a:t>✔ Водный нано-барьер из морских водорослей и хитозана</a:t>
             </a:r>
           </a:p>
           <a:p>
             <a:pPr>
-              <a:defRPr b="1" sz="1150">
-                <a:solidFill>
-                  <a:srgbClr val="34D399"/>
-                </a:solidFill>
-              </a:defRPr>
-            </a:pPr>
-            <a:r>
-              <a:t>Эко-жиробарьер: </a:t>
-            </a:r>
-            <a:r>
-              <a:rPr b="0">
-                <a:solidFill>
-                  <a:srgbClr val="94A3B8"/>
-                </a:solidFill>
-              </a:rPr>
-              <a:t>Водный нано-слой. 0% пластика, 0% фтора, 0% полиэтилена.</a:t>
+              <a:defRPr sz="1150">
+                <a:solidFill>
+                  <a:srgbClr val="FFFFFF"/>
+                </a:solidFill>
+              </a:defRPr>
+            </a:pPr>
+            <a:r>
+              <a:t>✔ Микропористая мембрана отводит пар (хруст корочки)</a:t>
             </a:r>
           </a:p>
           <a:p>
             <a:pPr>
-              <a:defRPr b="1" sz="1150">
-                <a:solidFill>
-                  <a:srgbClr val="34D399"/>
-                </a:solidFill>
-              </a:defRPr>
-            </a:pPr>
-            <a:r>
-              <a:t>Термостойкость: </a:t>
-            </a:r>
-            <a:r>
-              <a:rPr b="0">
-                <a:solidFill>
-                  <a:srgbClr val="94A3B8"/>
-                </a:solidFill>
-              </a:rPr>
-              <a:t>До +220°C кратковременно, 6 часов в тепловой витрине.</a:t>
+              <a:defRPr sz="1150">
+                <a:solidFill>
+                  <a:srgbClr val="FFFFFF"/>
+                </a:solidFill>
+              </a:defRPr>
+            </a:pPr>
+            <a:r>
+              <a:t>✔ Термостойкость до 220°C, 6 часов в витрине гриля</a:t>
             </a:r>
           </a:p>
           <a:p>
             <a:pPr>
-              <a:defRPr b="1" sz="1150">
-                <a:solidFill>
-                  <a:srgbClr val="34D399"/>
-                </a:solidFill>
-              </a:defRPr>
-            </a:pPr>
-            <a:r>
-              <a:t>Утилизация: </a:t>
-            </a:r>
-            <a:r>
-              <a:rPr b="0">
-                <a:solidFill>
-                  <a:srgbClr val="94A3B8"/>
-                </a:solidFill>
-              </a:rPr>
-              <a:t>Домашний компост за 60 дней (OK Compost HOME) или макулатура.</a:t>
-            </a:r>
-          </a:p>
-          <a:p>
-            <a:pPr>
-              <a:defRPr b="1" sz="1150">
-                <a:solidFill>
-                  <a:srgbClr val="34D399"/>
-                </a:solidFill>
-              </a:defRPr>
-            </a:pPr>
-            <a:r>
-              <a:t>Позиционирование: </a:t>
-            </a:r>
-            <a:r>
-              <a:rPr b="0">
-                <a:solidFill>
-                  <a:srgbClr val="94A3B8"/>
-                </a:solidFill>
-              </a:rPr>
-              <a:t>Премиальная эко-линейка готовой кулинарии сети Profi.</a:t>
+              <a:defRPr sz="1150">
+                <a:solidFill>
+                  <a:srgbClr val="FFFFFF"/>
+                </a:solidFill>
+              </a:defRPr>
+            </a:pPr>
+            <a:r>
+              <a:t>✔ Домашний компост за 60 дней (OK Compost HOME)</a:t>
             </a:r>
           </a:p>
         </p:txBody>
@@ -4936,11 +4638,11 @@
             <a:avLst/>
           </a:prstGeom>
           <a:solidFill>
-            <a:srgbClr val="0F1418"/>
+            <a:srgbClr val="0A0E11"/>
           </a:solidFill>
           <a:ln>
             <a:solidFill>
-              <a:srgbClr val="0F1418"/>
+              <a:srgbClr val="0A0E11"/>
             </a:solidFill>
           </a:ln>
         </p:spPr>
@@ -4974,8 +4676,8 @@
         </p:nvSpPr>
         <p:spPr>
           <a:xfrm>
-            <a:off x="822960" y="411480"/>
-            <a:ext cx="8686800" cy="320040"/>
+            <a:off x="914400" y="365760"/>
+            <a:ext cx="10362895" cy="320040"/>
           </a:xfrm>
           <a:prstGeom prst="rect">
             <a:avLst/>
@@ -4988,7 +4690,7 @@
           </a:bodyPr>
           <a:lstStyle/>
           <a:p>
-            <a:pPr>
+            <a:pPr algn="ctr">
               <a:defRPr sz="1100" b="1">
                 <a:solidFill>
                   <a:srgbClr val="34D399"/>
@@ -4997,7 +4699,7 @@
               </a:defRPr>
             </a:pPr>
             <a:r>
-              <a:t>МАСШТАБИРОВАНИЕ • GIGAHACK 2026</a:t>
+              <a:t>АРХИТЕКТУРА РЕШЕНИЙ</a:t>
             </a:r>
           </a:p>
         </p:txBody>
@@ -5010,8 +4712,8 @@
         </p:nvSpPr>
         <p:spPr>
           <a:xfrm>
-            <a:off x="822960" y="685800"/>
-            <a:ext cx="8686800" cy="731520"/>
+            <a:off x="914400" y="685800"/>
+            <a:ext cx="10362895" cy="685800"/>
           </a:xfrm>
           <a:prstGeom prst="rect">
             <a:avLst/>
@@ -5024,8 +4726,8 @@
           </a:bodyPr>
           <a:lstStyle/>
           <a:p>
-            <a:pPr>
-              <a:defRPr sz="2200" b="1">
+            <a:pPr algn="ctr">
+              <a:defRPr sz="2400" b="1">
                 <a:solidFill>
                   <a:srgbClr val="FFFFFF"/>
                 </a:solidFill>
@@ -5033,7 +4735,7 @@
               </a:defRPr>
             </a:pPr>
             <a:r>
-              <a:t>Комплексная оптимизация отделов супермаркета</a:t>
+              <a:t>Оптимизация 4 зон супермаркета сети Profi</a:t>
             </a:r>
           </a:p>
         </p:txBody>
@@ -5046,8 +4748,8 @@
         </p:nvSpPr>
         <p:spPr>
           <a:xfrm>
-            <a:off x="10241280" y="457200"/>
-            <a:ext cx="1188720" cy="365760"/>
+            <a:off x="10332720" y="365760"/>
+            <a:ext cx="1097280" cy="320040"/>
           </a:xfrm>
           <a:prstGeom prst="rect">
             <a:avLst/>
@@ -5061,7 +4763,7 @@
           <a:lstStyle/>
           <a:p>
             <a:pPr algn="r">
-              <a:defRPr sz="1200" b="1">
+              <a:defRPr sz="1100" b="1">
                 <a:solidFill>
                   <a:srgbClr val="94A3B8"/>
                 </a:solidFill>
@@ -5076,24 +4778,24 @@
       </p:sp>
       <p:sp>
         <p:nvSpPr>
-          <p:cNvPr id="6" name="Rectangle 5"/>
+          <p:cNvPr id="6" name="Rounded Rectangle 5"/>
           <p:cNvSpPr/>
           <p:nvPr/>
         </p:nvSpPr>
         <p:spPr>
           <a:xfrm>
-            <a:off x="822960" y="1371600"/>
-            <a:ext cx="10545775" cy="18288"/>
-          </a:xfrm>
-          <a:prstGeom prst="rect">
+            <a:off x="914400" y="1645920"/>
+            <a:ext cx="2423160" cy="4480560"/>
+          </a:xfrm>
+          <a:prstGeom prst="roundRect">
             <a:avLst/>
           </a:prstGeom>
           <a:solidFill>
-            <a:srgbClr val="24323B"/>
+            <a:srgbClr val="12181D"/>
           </a:solidFill>
-          <a:ln>
+          <a:ln w="12700">
             <a:solidFill>
-              <a:srgbClr val="24323B"/>
+              <a:srgbClr val="1E2932"/>
             </a:solidFill>
           </a:ln>
         </p:spPr>
@@ -5121,24 +4823,101 @@
       </p:sp>
       <p:sp>
         <p:nvSpPr>
-          <p:cNvPr id="7" name="Rounded Rectangle 6"/>
+          <p:cNvPr id="7" name="TextBox 6"/>
+          <p:cNvSpPr txBox="1"/>
+          <p:nvPr/>
+        </p:nvSpPr>
+        <p:spPr>
+          <a:xfrm>
+            <a:off x="1024128" y="1874520"/>
+            <a:ext cx="2203704" cy="4023360"/>
+          </a:xfrm>
+          <a:prstGeom prst="rect">
+            <a:avLst/>
+          </a:prstGeom>
+          <a:noFill/>
+        </p:spPr>
+        <p:txBody>
+          <a:bodyPr wrap="square">
+            <a:spAutoFit/>
+          </a:bodyPr>
+          <a:lstStyle/>
+          <a:p>
+            <a:pPr algn="ctr">
+              <a:defRPr sz="1300" b="1">
+                <a:solidFill>
+                  <a:srgbClr val="FFFFFF"/>
+                </a:solidFill>
+                <a:latin typeface="Plus Jakarta Sans"/>
+              </a:defRPr>
+            </a:pPr>
+            <a:r>
+              <a:t>🍗 Кулинария (Гриль)</a:t>
+            </a:r>
+          </a:p>
+          <a:p>
+            <a:pPr algn="ctr">
+              <a:defRPr sz="1400" b="1">
+                <a:solidFill>
+                  <a:srgbClr val="34D399"/>
+                </a:solidFill>
+                <a:latin typeface="JetBrains Mono"/>
+              </a:defRPr>
+            </a:pPr>
+            <a:r>
+              <a:t>CPET Ultra-Flex</a:t>
+            </a:r>
+          </a:p>
+          <a:p>
+            <a:pPr algn="ctr">
+              <a:defRPr sz="2200" b="1">
+                <a:solidFill>
+                  <a:srgbClr val="34D399"/>
+                </a:solidFill>
+                <a:latin typeface="JetBrains Mono"/>
+              </a:defRPr>
+            </a:pPr>
+            <a:br/>
+            <a:r>
+              <a:t>250°C</a:t>
+            </a:r>
+            <a:br/>
+          </a:p>
+          <a:p>
+            <a:pPr algn="ctr">
+              <a:defRPr sz="1100">
+                <a:solidFill>
+                  <a:srgbClr val="94A3B8"/>
+                </a:solidFill>
+                <a:latin typeface="Plus Jakarta Sans"/>
+              </a:defRPr>
+            </a:pPr>
+            <a:r>
+              <a:t>Выдержка 6ч в витрине, 100% rPET, Kit 12 без PFAS</a:t>
+            </a:r>
+          </a:p>
+        </p:txBody>
+      </p:sp>
+      <p:sp>
+        <p:nvSpPr>
+          <p:cNvPr id="8" name="Rounded Rectangle 7"/>
           <p:cNvSpPr/>
           <p:nvPr/>
         </p:nvSpPr>
         <p:spPr>
           <a:xfrm>
-            <a:off x="822960" y="1645920"/>
-            <a:ext cx="3328416" cy="4572000"/>
+            <a:off x="3557016" y="1645920"/>
+            <a:ext cx="2423160" cy="4480560"/>
           </a:xfrm>
           <a:prstGeom prst="roundRect">
             <a:avLst/>
           </a:prstGeom>
           <a:solidFill>
-            <a:srgbClr val="182026"/>
+            <a:srgbClr val="12181D"/>
           </a:solidFill>
           <a:ln w="12700">
             <a:solidFill>
-              <a:srgbClr val="24323B"/>
+              <a:srgbClr val="1E2932"/>
             </a:solidFill>
           </a:ln>
         </p:spPr>
@@ -5166,14 +4945,14 @@
       </p:sp>
       <p:sp>
         <p:nvSpPr>
-          <p:cNvPr id="8" name="TextBox 7"/>
+          <p:cNvPr id="9" name="TextBox 8"/>
           <p:cNvSpPr txBox="1"/>
           <p:nvPr/>
         </p:nvSpPr>
         <p:spPr>
           <a:xfrm>
-            <a:off x="987552" y="1810512"/>
-            <a:ext cx="2999232" cy="4242816"/>
+            <a:off x="3666744" y="1874520"/>
+            <a:ext cx="2203704" cy="4023360"/>
           </a:xfrm>
           <a:prstGeom prst="rect">
             <a:avLst/>
@@ -5186,153 +4965,81 @@
           </a:bodyPr>
           <a:lstStyle/>
           <a:p>
-            <a:pPr>
-              <a:defRPr sz="1100" b="1">
-                <a:solidFill>
-                  <a:srgbClr val="10B981"/>
+            <a:pPr algn="ctr">
+              <a:defRPr sz="1300" b="1">
+                <a:solidFill>
+                  <a:srgbClr val="FFFFFF"/>
+                </a:solidFill>
+                <a:latin typeface="Plus Jakarta Sans"/>
+              </a:defRPr>
+            </a:pPr>
+            <a:r>
+              <a:t>🥬 Свежие Овощи</a:t>
+            </a:r>
+          </a:p>
+          <a:p>
+            <a:pPr algn="ctr">
+              <a:defRPr sz="1400" b="1">
+                <a:solidFill>
+                  <a:srgbClr val="34D399"/>
                 </a:solidFill>
                 <a:latin typeface="JetBrains Mono"/>
               </a:defRPr>
             </a:pPr>
             <a:r>
-              <a:t>🥬 СВЕЖИЕ ОВОЩИ И ЗЕЛЕНЬ</a:t>
-            </a:r>
-          </a:p>
-          <a:p>
-            <a:pPr>
-              <a:defRPr sz="1800" b="1">
-                <a:solidFill>
-                  <a:srgbClr val="FFFFFF"/>
+              <a:t>EMAP Laser™</a:t>
+            </a:r>
+          </a:p>
+          <a:p>
+            <a:pPr algn="ctr">
+              <a:defRPr sz="2200" b="1">
+                <a:solidFill>
+                  <a:srgbClr val="34D399"/>
+                </a:solidFill>
+                <a:latin typeface="JetBrains Mono"/>
+              </a:defRPr>
+            </a:pPr>
+            <a:br/>
+            <a:r>
+              <a:t>+4 Дня</a:t>
+            </a:r>
+            <a:br/>
+          </a:p>
+          <a:p>
+            <a:pPr algn="ctr">
+              <a:defRPr sz="1100">
+                <a:solidFill>
+                  <a:srgbClr val="94A3B8"/>
                 </a:solidFill>
                 <a:latin typeface="Plus Jakarta Sans"/>
               </a:defRPr>
             </a:pPr>
             <a:r>
-              <a:t>EMAP Laser-Breathe™</a:t>
-            </a:r>
-          </a:p>
-          <a:p>
-            <a:pPr>
-              <a:defRPr b="1" sz="1100">
-                <a:solidFill>
-                  <a:srgbClr val="34D399"/>
-                </a:solidFill>
-              </a:defRPr>
-            </a:pPr>
-            <a:r>
-              <a:t>• Проблема: </a:t>
-            </a:r>
-            <a:r>
-              <a:rPr b="0">
-                <a:solidFill>
-                  <a:srgbClr val="94A3B8"/>
-                </a:solidFill>
-              </a:rPr>
-              <a:t>Конденсат, плесень, 28-35% списаний зелени и ягод.</a:t>
-            </a:r>
-          </a:p>
-          <a:p>
-            <a:pPr>
-              <a:defRPr b="1" sz="1100">
-                <a:solidFill>
-                  <a:srgbClr val="34D399"/>
-                </a:solidFill>
-              </a:defRPr>
-            </a:pPr>
-            <a:r>
-              <a:t>• Инновация: </a:t>
-            </a:r>
-            <a:r>
-              <a:rPr b="0">
-                <a:solidFill>
-                  <a:srgbClr val="94A3B8"/>
-                </a:solidFill>
-              </a:rPr>
-              <a:t>Моно-пленка rBOPP с лазерной микроперфорацией. Баланс O₂ (3-5%) и CO₂ (5-8%).</a:t>
-            </a:r>
-          </a:p>
-          <a:p>
-            <a:pPr>
-              <a:defRPr b="1" sz="1100">
-                <a:solidFill>
-                  <a:srgbClr val="34D399"/>
-                </a:solidFill>
-              </a:defRPr>
-            </a:pPr>
-            <a:r>
-              <a:t>• Эффект: </a:t>
-            </a:r>
-            <a:r>
-              <a:rPr b="0">
-                <a:solidFill>
-                  <a:srgbClr val="94A3B8"/>
-                </a:solidFill>
-              </a:rPr>
-              <a:t>+4 дня к сроку годности на полке.</a:t>
-            </a:r>
-          </a:p>
-          <a:p>
-            <a:pPr>
-              <a:defRPr b="1" sz="1100">
-                <a:solidFill>
-                  <a:srgbClr val="34D399"/>
-                </a:solidFill>
-              </a:defRPr>
-            </a:pPr>
-            <a:r>
-              <a:t>• Списания: </a:t>
-            </a:r>
-            <a:r>
-              <a:rPr b="0">
-                <a:solidFill>
-                  <a:srgbClr val="94A3B8"/>
-                </a:solidFill>
-              </a:rPr>
-              <a:t>Сокращение списаний в супермаркетах на 32%.</a:t>
-            </a:r>
-          </a:p>
-          <a:p>
-            <a:pPr>
-              <a:defRPr b="1" sz="1100">
-                <a:solidFill>
-                  <a:srgbClr val="34D399"/>
-                </a:solidFill>
-              </a:defRPr>
-            </a:pPr>
-            <a:r>
-              <a:t>• Материал: </a:t>
-            </a:r>
-            <a:r>
-              <a:rPr b="0">
-                <a:solidFill>
-                  <a:srgbClr val="94A3B8"/>
-                </a:solidFill>
-              </a:rPr>
-              <a:t>Моно-rBOPP • 100% Recyclable.</a:t>
-            </a:r>
-          </a:p>
-        </p:txBody>
-      </p:sp>
-      <p:sp>
-        <p:nvSpPr>
-          <p:cNvPr id="9" name="Rounded Rectangle 8"/>
+              <a:t>Лазерная микроперфорация O₂/CO₂, -32% списаний</a:t>
+            </a:r>
+          </a:p>
+        </p:txBody>
+      </p:sp>
+      <p:sp>
+        <p:nvSpPr>
+          <p:cNvPr id="10" name="Rounded Rectangle 9"/>
           <p:cNvSpPr/>
           <p:nvPr/>
         </p:nvSpPr>
         <p:spPr>
           <a:xfrm>
-            <a:off x="4425696" y="1645920"/>
-            <a:ext cx="3328416" cy="4572000"/>
+            <a:off x="6199632" y="1645920"/>
+            <a:ext cx="2423160" cy="4480560"/>
           </a:xfrm>
           <a:prstGeom prst="roundRect">
             <a:avLst/>
           </a:prstGeom>
           <a:solidFill>
-            <a:srgbClr val="182026"/>
+            <a:srgbClr val="12181D"/>
           </a:solidFill>
           <a:ln w="12700">
             <a:solidFill>
-              <a:srgbClr val="24323B"/>
+              <a:srgbClr val="1E2932"/>
             </a:solidFill>
           </a:ln>
         </p:spPr>
@@ -5360,14 +5067,14 @@
       </p:sp>
       <p:sp>
         <p:nvSpPr>
-          <p:cNvPr id="10" name="TextBox 9"/>
+          <p:cNvPr id="11" name="TextBox 10"/>
           <p:cNvSpPr txBox="1"/>
           <p:nvPr/>
         </p:nvSpPr>
         <p:spPr>
           <a:xfrm>
-            <a:off x="4590288" y="1810512"/>
-            <a:ext cx="2999232" cy="4242816"/>
+            <a:off x="6309360" y="1874520"/>
+            <a:ext cx="2203704" cy="4023360"/>
           </a:xfrm>
           <a:prstGeom prst="rect">
             <a:avLst/>
@@ -5380,153 +5087,81 @@
           </a:bodyPr>
           <a:lstStyle/>
           <a:p>
-            <a:pPr>
-              <a:defRPr sz="1100" b="1">
-                <a:solidFill>
-                  <a:srgbClr val="10B981"/>
+            <a:pPr algn="ctr">
+              <a:defRPr sz="1300" b="1">
+                <a:solidFill>
+                  <a:srgbClr val="FFFFFF"/>
+                </a:solidFill>
+                <a:latin typeface="Plus Jakarta Sans"/>
+              </a:defRPr>
+            </a:pPr>
+            <a:r>
+              <a:t>🥩 Мясной Отдел</a:t>
+            </a:r>
+          </a:p>
+          <a:p>
+            <a:pPr algn="ctr">
+              <a:defRPr sz="1400" b="1">
+                <a:solidFill>
+                  <a:srgbClr val="34D399"/>
                 </a:solidFill>
                 <a:latin typeface="JetBrains Mono"/>
               </a:defRPr>
             </a:pPr>
             <a:r>
-              <a:t>🥩 МЯСНОЙ И РЫБНЫЙ ОТДЕЛ</a:t>
-            </a:r>
-          </a:p>
-          <a:p>
-            <a:pPr>
-              <a:defRPr sz="1800" b="1">
-                <a:solidFill>
-                  <a:srgbClr val="FFFFFF"/>
+              <a:t>Capillary Tray</a:t>
+            </a:r>
+          </a:p>
+          <a:p>
+            <a:pPr algn="ctr">
+              <a:defRPr sz="2200" b="1">
+                <a:solidFill>
+                  <a:srgbClr val="34D399"/>
+                </a:solidFill>
+                <a:latin typeface="JetBrains Mono"/>
+              </a:defRPr>
+            </a:pPr>
+            <a:br/>
+            <a:r>
+              <a:t>0 Салфеток</a:t>
+            </a:r>
+            <a:br/>
+          </a:p>
+          <a:p>
+            <a:pPr algn="ctr">
+              <a:defRPr sz="1100">
+                <a:solidFill>
+                  <a:srgbClr val="94A3B8"/>
                 </a:solidFill>
                 <a:latin typeface="Plus Jakarta Sans"/>
               </a:defRPr>
             </a:pPr>
             <a:r>
-              <a:t>Capillary Tray (Pad-Less)</a:t>
-            </a:r>
-          </a:p>
-          <a:p>
-            <a:pPr>
-              <a:defRPr b="1" sz="1100">
-                <a:solidFill>
-                  <a:srgbClr val="34D399"/>
-                </a:solidFill>
-              </a:defRPr>
-            </a:pPr>
-            <a:r>
-              <a:t>• Проблема: </a:t>
-            </a:r>
-            <a:r>
-              <a:rPr b="0">
-                <a:solidFill>
-                  <a:srgbClr val="94A3B8"/>
-                </a:solidFill>
-              </a:rPr>
-              <a:t>Грязная синтетическая салфетка исключает лоток из рециклинга.</a:t>
-            </a:r>
-          </a:p>
-          <a:p>
-            <a:pPr>
-              <a:defRPr b="1" sz="1100">
-                <a:solidFill>
-                  <a:srgbClr val="34D399"/>
-                </a:solidFill>
-              </a:defRPr>
-            </a:pPr>
-            <a:r>
-              <a:t>• Инновация: </a:t>
-            </a:r>
-            <a:r>
-              <a:rPr b="0">
-                <a:solidFill>
-                  <a:srgbClr val="94A3B8"/>
-                </a:solidFill>
-              </a:rPr>
-              <a:t>Глубокоформованный моно-rPET лоток с капиллярным гидро-замком на 45 мл экссудата.</a:t>
-            </a:r>
-          </a:p>
-          <a:p>
-            <a:pPr>
-              <a:defRPr b="1" sz="1100">
-                <a:solidFill>
-                  <a:srgbClr val="34D399"/>
-                </a:solidFill>
-              </a:defRPr>
-            </a:pPr>
-            <a:r>
-              <a:t>• Эффект: </a:t>
-            </a:r>
-            <a:r>
-              <a:rPr b="0">
-                <a:solidFill>
-                  <a:srgbClr val="94A3B8"/>
-                </a:solidFill>
-              </a:rPr>
-              <a:t>0 синтетических салфеток-вкладышей.</a:t>
-            </a:r>
-          </a:p>
-          <a:p>
-            <a:pPr>
-              <a:defRPr b="1" sz="1100">
-                <a:solidFill>
-                  <a:srgbClr val="34D399"/>
-                </a:solidFill>
-              </a:defRPr>
-            </a:pPr>
-            <a:r>
-              <a:t>• Сортировка: </a:t>
-            </a:r>
-            <a:r>
-              <a:rPr b="0">
-                <a:solidFill>
-                  <a:srgbClr val="94A3B8"/>
-                </a:solidFill>
-              </a:rPr>
-              <a:t>100% чистый поток вторичной переработки.</a:t>
-            </a:r>
-          </a:p>
-          <a:p>
-            <a:pPr>
-              <a:defRPr b="1" sz="1100">
-                <a:solidFill>
-                  <a:srgbClr val="34D399"/>
-                </a:solidFill>
-              </a:defRPr>
-            </a:pPr>
-            <a:r>
-              <a:t>• Материал: </a:t>
-            </a:r>
-            <a:r>
-              <a:rPr b="0">
-                <a:solidFill>
-                  <a:srgbClr val="94A3B8"/>
-                </a:solidFill>
-              </a:rPr>
-              <a:t>85% rPET • RecyClass Class A.</a:t>
-            </a:r>
-          </a:p>
-        </p:txBody>
-      </p:sp>
-      <p:sp>
-        <p:nvSpPr>
-          <p:cNvPr id="11" name="Rounded Rectangle 10"/>
+              <a:t>Капиллярный замок экссудата на 45 мл, чистый рециклинг</a:t>
+            </a:r>
+          </a:p>
+        </p:txBody>
+      </p:sp>
+      <p:sp>
+        <p:nvSpPr>
+          <p:cNvPr id="12" name="Rounded Rectangle 11"/>
           <p:cNvSpPr/>
           <p:nvPr/>
         </p:nvSpPr>
         <p:spPr>
           <a:xfrm>
-            <a:off x="8028432" y="1645920"/>
-            <a:ext cx="3328416" cy="4572000"/>
+            <a:off x="8842248" y="1645920"/>
+            <a:ext cx="2423160" cy="4480560"/>
           </a:xfrm>
           <a:prstGeom prst="roundRect">
             <a:avLst/>
           </a:prstGeom>
           <a:solidFill>
-            <a:srgbClr val="182026"/>
+            <a:srgbClr val="12181D"/>
           </a:solidFill>
           <a:ln w="12700">
             <a:solidFill>
-              <a:srgbClr val="24323B"/>
+              <a:srgbClr val="1E2932"/>
             </a:solidFill>
           </a:ln>
         </p:spPr>
@@ -5554,14 +5189,14 @@
       </p:sp>
       <p:sp>
         <p:nvSpPr>
-          <p:cNvPr id="12" name="TextBox 11"/>
+          <p:cNvPr id="13" name="TextBox 12"/>
           <p:cNvSpPr txBox="1"/>
           <p:nvPr/>
         </p:nvSpPr>
         <p:spPr>
           <a:xfrm>
-            <a:off x="8193024" y="1810512"/>
-            <a:ext cx="2999232" cy="4242816"/>
+            <a:off x="8951976" y="1874520"/>
+            <a:ext cx="2203704" cy="4023360"/>
           </a:xfrm>
           <a:prstGeom prst="rect">
             <a:avLst/>
@@ -5574,129 +5209,57 @@
           </a:bodyPr>
           <a:lstStyle/>
           <a:p>
-            <a:pPr>
-              <a:defRPr sz="1100" b="1">
-                <a:solidFill>
-                  <a:srgbClr val="10B981"/>
+            <a:pPr algn="ctr">
+              <a:defRPr sz="1300" b="1">
+                <a:solidFill>
+                  <a:srgbClr val="FFFFFF"/>
+                </a:solidFill>
+                <a:latin typeface="Plus Jakarta Sans"/>
+              </a:defRPr>
+            </a:pPr>
+            <a:r>
+              <a:t>🥐 Пекарня</a:t>
+            </a:r>
+          </a:p>
+          <a:p>
+            <a:pPr algn="ctr">
+              <a:defRPr sz="1400" b="1">
+                <a:solidFill>
+                  <a:srgbClr val="34D399"/>
                 </a:solidFill>
                 <a:latin typeface="JetBrains Mono"/>
               </a:defRPr>
             </a:pPr>
             <a:r>
-              <a:t>🥐 ПЕКАРНЯ И ВЫПЕЧКА</a:t>
-            </a:r>
-          </a:p>
-          <a:p>
-            <a:pPr>
-              <a:defRPr sz="1800" b="1">
-                <a:solidFill>
-                  <a:srgbClr val="FFFFFF"/>
+              <a:t>NatureVent™</a:t>
+            </a:r>
+          </a:p>
+          <a:p>
+            <a:pPr algn="ctr">
+              <a:defRPr sz="2200" b="1">
+                <a:solidFill>
+                  <a:srgbClr val="34D399"/>
+                </a:solidFill>
+                <a:latin typeface="JetBrains Mono"/>
+              </a:defRPr>
+            </a:pPr>
+            <a:br/>
+            <a:r>
+              <a:t>Pulpable</a:t>
+            </a:r>
+            <a:br/>
+          </a:p>
+          <a:p>
+            <a:pPr algn="ctr">
+              <a:defRPr sz="1100">
+                <a:solidFill>
+                  <a:srgbClr val="94A3B8"/>
                 </a:solidFill>
                 <a:latin typeface="Plus Jakarta Sans"/>
               </a:defRPr>
             </a:pPr>
             <a:r>
-              <a:t>NatureVent Crisp™</a:t>
-            </a:r>
-          </a:p>
-          <a:p>
-            <a:pPr>
-              <a:defRPr b="1" sz="1100">
-                <a:solidFill>
-                  <a:srgbClr val="34D399"/>
-                </a:solidFill>
-              </a:defRPr>
-            </a:pPr>
-            <a:r>
-              <a:t>• Проблема: </a:t>
-            </a:r>
-            <a:r>
-              <a:rPr b="0">
-                <a:solidFill>
-                  <a:srgbClr val="94A3B8"/>
-                </a:solidFill>
-              </a:rPr>
-              <a:t>Пакеты со смотровыми окнами из полиэтилена сжигаются.</a:t>
-            </a:r>
-          </a:p>
-          <a:p>
-            <a:pPr>
-              <a:defRPr b="1" sz="1100">
-                <a:solidFill>
-                  <a:srgbClr val="34D399"/>
-                </a:solidFill>
-              </a:defRPr>
-            </a:pPr>
-            <a:r>
-              <a:t>• Инновация: </a:t>
-            </a:r>
-            <a:r>
-              <a:rPr b="0">
-                <a:solidFill>
-                  <a:srgbClr val="94A3B8"/>
-                </a:solidFill>
-              </a:rPr>
-              <a:t>Крафт FSC + прозрачное био-окно NatureFlex™ из древесной массы + водный био-воск.</a:t>
-            </a:r>
-          </a:p>
-          <a:p>
-            <a:pPr>
-              <a:defRPr b="1" sz="1100">
-                <a:solidFill>
-                  <a:srgbClr val="34D399"/>
-                </a:solidFill>
-              </a:defRPr>
-            </a:pPr>
-            <a:r>
-              <a:t>• Эффект: </a:t>
-            </a:r>
-            <a:r>
-              <a:rPr b="0">
-                <a:solidFill>
-                  <a:srgbClr val="94A3B8"/>
-                </a:solidFill>
-              </a:rPr>
-              <a:t>Сохранение хрустящей корочки круассанов.</a:t>
-            </a:r>
-          </a:p>
-          <a:p>
-            <a:pPr>
-              <a:defRPr b="1" sz="1100">
-                <a:solidFill>
-                  <a:srgbClr val="34D399"/>
-                </a:solidFill>
-              </a:defRPr>
-            </a:pPr>
-            <a:r>
-              <a:t>• Утилизация: </a:t>
-            </a:r>
-            <a:r>
-              <a:rPr b="0">
-                <a:solidFill>
-                  <a:srgbClr val="94A3B8"/>
-                </a:solidFill>
-              </a:rPr>
-              <a:t>100% Pulpable (переработка вместе с бумагой).</a:t>
-            </a:r>
-          </a:p>
-          <a:p>
-            <a:pPr>
-              <a:defRPr b="1" sz="1100">
-                <a:solidFill>
-                  <a:srgbClr val="34D399"/>
-                </a:solidFill>
-              </a:defRPr>
-            </a:pPr>
-            <a:r>
-              <a:t>• Материал: </a:t>
-            </a:r>
-            <a:r>
-              <a:rPr b="0">
-                <a:solidFill>
-                  <a:srgbClr val="94A3B8"/>
-                </a:solidFill>
-              </a:rPr>
-              <a:t>Крафт FSC + целлюлоза • 0% ПЭ.</a:t>
+              <a:t>Крафт FSC + целлюлозное био-окно NatureFlex™, тест CEPI</a:t>
             </a:r>
           </a:p>
         </p:txBody>
@@ -5734,11 +5297,11 @@
             <a:avLst/>
           </a:prstGeom>
           <a:solidFill>
-            <a:srgbClr val="0F1418"/>
+            <a:srgbClr val="0A0E11"/>
           </a:solidFill>
           <a:ln>
             <a:solidFill>
-              <a:srgbClr val="0F1418"/>
+              <a:srgbClr val="0A0E11"/>
             </a:solidFill>
           </a:ln>
         </p:spPr>
@@ -5772,8 +5335,8 @@
         </p:nvSpPr>
         <p:spPr>
           <a:xfrm>
-            <a:off x="822960" y="411480"/>
-            <a:ext cx="8686800" cy="320040"/>
+            <a:off x="914400" y="365760"/>
+            <a:ext cx="10362895" cy="320040"/>
           </a:xfrm>
           <a:prstGeom prst="rect">
             <a:avLst/>
@@ -5786,7 +5349,7 @@
           </a:bodyPr>
           <a:lstStyle/>
           <a:p>
-            <a:pPr>
+            <a:pPr algn="ctr">
               <a:defRPr sz="1100" b="1">
                 <a:solidFill>
                   <a:srgbClr val="34D399"/>
@@ -5795,7 +5358,7 @@
               </a:defRPr>
             </a:pPr>
             <a:r>
-              <a:t>БИЗНЕС-МОДЕЛЬ • GIGAHACK 2026</a:t>
+              <a:t>БИЗНЕС-КЕЙС ДЛЯ PROFI</a:t>
             </a:r>
           </a:p>
         </p:txBody>
@@ -5808,8 +5371,8 @@
         </p:nvSpPr>
         <p:spPr>
           <a:xfrm>
-            <a:off x="822960" y="685800"/>
-            <a:ext cx="8686800" cy="731520"/>
+            <a:off x="914400" y="685800"/>
+            <a:ext cx="10362895" cy="685800"/>
           </a:xfrm>
           <a:prstGeom prst="rect">
             <a:avLst/>
@@ -5822,8 +5385,8 @@
           </a:bodyPr>
           <a:lstStyle/>
           <a:p>
-            <a:pPr>
-              <a:defRPr sz="2200" b="1">
+            <a:pPr algn="ctr">
+              <a:defRPr sz="2400" b="1">
                 <a:solidFill>
                   <a:srgbClr val="FFFFFF"/>
                 </a:solidFill>
@@ -5831,7 +5394,7 @@
               </a:defRPr>
             </a:pPr>
             <a:r>
-              <a:t>Экономика и ESG-эффект: Расчет на 100 супермаркетов Profi</a:t>
+              <a:t>Экономический эффект на масштабе 100 магазинов</a:t>
             </a:r>
           </a:p>
         </p:txBody>
@@ -5844,8 +5407,8 @@
         </p:nvSpPr>
         <p:spPr>
           <a:xfrm>
-            <a:off x="10241280" y="457200"/>
-            <a:ext cx="1188720" cy="365760"/>
+            <a:off x="10332720" y="365760"/>
+            <a:ext cx="1097280" cy="320040"/>
           </a:xfrm>
           <a:prstGeom prst="rect">
             <a:avLst/>
@@ -5859,7 +5422,7 @@
           <a:lstStyle/>
           <a:p>
             <a:pPr algn="r">
-              <a:defRPr sz="1200" b="1">
+              <a:defRPr sz="1100" b="1">
                 <a:solidFill>
                   <a:srgbClr val="94A3B8"/>
                 </a:solidFill>
@@ -5874,24 +5437,24 @@
       </p:sp>
       <p:sp>
         <p:nvSpPr>
-          <p:cNvPr id="6" name="Rectangle 5"/>
+          <p:cNvPr id="6" name="Rounded Rectangle 5"/>
           <p:cNvSpPr/>
           <p:nvPr/>
         </p:nvSpPr>
         <p:spPr>
           <a:xfrm>
-            <a:off x="822960" y="1371600"/>
-            <a:ext cx="10545775" cy="18288"/>
-          </a:xfrm>
-          <a:prstGeom prst="rect">
+            <a:off x="914400" y="1645920"/>
+            <a:ext cx="2423160" cy="2926080"/>
+          </a:xfrm>
+          <a:prstGeom prst="roundRect">
             <a:avLst/>
           </a:prstGeom>
           <a:solidFill>
-            <a:srgbClr val="24323B"/>
+            <a:srgbClr val="12181D"/>
           </a:solidFill>
-          <a:ln>
+          <a:ln w="12700">
             <a:solidFill>
-              <a:srgbClr val="24323B"/>
+              <a:srgbClr val="1E2932"/>
             </a:solidFill>
           </a:ln>
         </p:spPr>
@@ -5919,24 +5482,87 @@
       </p:sp>
       <p:sp>
         <p:nvSpPr>
-          <p:cNvPr id="7" name="Rounded Rectangle 6"/>
+          <p:cNvPr id="7" name="TextBox 6"/>
+          <p:cNvSpPr txBox="1"/>
+          <p:nvPr/>
+        </p:nvSpPr>
+        <p:spPr>
+          <a:xfrm>
+            <a:off x="1024128" y="1828800"/>
+            <a:ext cx="2203704" cy="2560320"/>
+          </a:xfrm>
+          <a:prstGeom prst="rect">
+            <a:avLst/>
+          </a:prstGeom>
+          <a:noFill/>
+        </p:spPr>
+        <p:txBody>
+          <a:bodyPr wrap="square">
+            <a:spAutoFit/>
+          </a:bodyPr>
+          <a:lstStyle/>
+          <a:p>
+            <a:pPr algn="ctr">
+              <a:defRPr sz="2800" b="1">
+                <a:solidFill>
+                  <a:srgbClr val="34D399"/>
+                </a:solidFill>
+                <a:latin typeface="JetBrains Mono"/>
+              </a:defRPr>
+            </a:pPr>
+            <a:r>
+              <a:t>1 840 т</a:t>
+            </a:r>
+          </a:p>
+          <a:p>
+            <a:pPr algn="ctr">
+              <a:defRPr sz="1350" b="1">
+                <a:solidFill>
+                  <a:srgbClr val="FFFFFF"/>
+                </a:solidFill>
+                <a:latin typeface="Plus Jakarta Sans"/>
+              </a:defRPr>
+            </a:pPr>
+            <a:r>
+              <a:t>Первичный пластик</a:t>
+            </a:r>
+          </a:p>
+          <a:p>
+            <a:pPr algn="ctr">
+              <a:defRPr sz="1050">
+                <a:solidFill>
+                  <a:srgbClr val="94A3B8"/>
+                </a:solidFill>
+                <a:latin typeface="Plus Jakarta Sans"/>
+              </a:defRPr>
+            </a:pPr>
+            <a:br/>
+            <a:r>
+              <a:t>Тонн первичных полимеров замещено в год</a:t>
+            </a:r>
+          </a:p>
+        </p:txBody>
+      </p:sp>
+      <p:sp>
+        <p:nvSpPr>
+          <p:cNvPr id="8" name="Rounded Rectangle 7"/>
           <p:cNvSpPr/>
           <p:nvPr/>
         </p:nvSpPr>
         <p:spPr>
           <a:xfrm>
-            <a:off x="822960" y="1645920"/>
-            <a:ext cx="2468880" cy="2926080"/>
+            <a:off x="3557016" y="1645920"/>
+            <a:ext cx="2423160" cy="2926080"/>
           </a:xfrm>
           <a:prstGeom prst="roundRect">
             <a:avLst/>
           </a:prstGeom>
           <a:solidFill>
-            <a:srgbClr val="182026"/>
+            <a:srgbClr val="12181D"/>
           </a:solidFill>
           <a:ln w="12700">
             <a:solidFill>
-              <a:srgbClr val="24323B"/>
+              <a:srgbClr val="1E2932"/>
             </a:solidFill>
           </a:ln>
         </p:spPr>
@@ -5964,14 +5590,14 @@
       </p:sp>
       <p:sp>
         <p:nvSpPr>
-          <p:cNvPr id="8" name="TextBox 7"/>
+          <p:cNvPr id="9" name="TextBox 8"/>
           <p:cNvSpPr txBox="1"/>
           <p:nvPr/>
         </p:nvSpPr>
         <p:spPr>
           <a:xfrm>
-            <a:off x="960120" y="1828800"/>
-            <a:ext cx="2194560" cy="2560320"/>
+            <a:off x="3666744" y="1828800"/>
+            <a:ext cx="2203704" cy="2560320"/>
           </a:xfrm>
           <a:prstGeom prst="rect">
             <a:avLst/>
@@ -5984,8 +5610,8 @@
           </a:bodyPr>
           <a:lstStyle/>
           <a:p>
-            <a:pPr>
-              <a:defRPr sz="2600" b="1">
+            <a:pPr algn="ctr">
+              <a:defRPr sz="2800" b="1">
                 <a:solidFill>
                   <a:srgbClr val="34D399"/>
                 </a:solidFill>
@@ -5993,12 +5619,12 @@
               </a:defRPr>
             </a:pPr>
             <a:r>
-              <a:t>1 840 т</a:t>
-            </a:r>
-          </a:p>
-          <a:p>
-            <a:pPr>
-              <a:defRPr sz="1400" b="1">
+              <a:t>4 250 т</a:t>
+            </a:r>
+          </a:p>
+          <a:p>
+            <a:pPr algn="ctr">
+              <a:defRPr sz="1350" b="1">
                 <a:solidFill>
                   <a:srgbClr val="FFFFFF"/>
                 </a:solidFill>
@@ -6006,147 +5632,41 @@
               </a:defRPr>
             </a:pPr>
             <a:r>
-              <a:t>Первичный пластик</a:t>
-            </a:r>
-          </a:p>
-          <a:p>
-            <a:pPr>
-              <a:defRPr sz="1100">
+              <a:t>Выбросы CO₂e</a:t>
+            </a:r>
+          </a:p>
+          <a:p>
+            <a:pPr algn="ctr">
+              <a:defRPr sz="1050">
                 <a:solidFill>
                   <a:srgbClr val="94A3B8"/>
                 </a:solidFill>
                 <a:latin typeface="Plus Jakarta Sans"/>
               </a:defRPr>
             </a:pPr>
-            <a:r>
-              <a:t>Тонн первичных полимеров предотвращено в год благодаря rPET</a:t>
-            </a:r>
-          </a:p>
-        </p:txBody>
-      </p:sp>
-      <p:sp>
-        <p:nvSpPr>
-          <p:cNvPr id="9" name="Rounded Rectangle 8"/>
+            <a:br/>
+            <a:r>
+              <a:t>Предотвращено парниковых газов Scope 3</a:t>
+            </a:r>
+          </a:p>
+        </p:txBody>
+      </p:sp>
+      <p:sp>
+        <p:nvSpPr>
+          <p:cNvPr id="10" name="Rounded Rectangle 9"/>
           <p:cNvSpPr/>
           <p:nvPr/>
         </p:nvSpPr>
         <p:spPr>
           <a:xfrm>
-            <a:off x="3511296" y="1645920"/>
-            <a:ext cx="2468880" cy="2926080"/>
+            <a:off x="6199632" y="1645920"/>
+            <a:ext cx="2423160" cy="2926080"/>
           </a:xfrm>
           <a:prstGeom prst="roundRect">
             <a:avLst/>
           </a:prstGeom>
           <a:solidFill>
-            <a:srgbClr val="182026"/>
-          </a:solidFill>
-          <a:ln w="12700">
-            <a:solidFill>
-              <a:srgbClr val="24323B"/>
-            </a:solidFill>
-          </a:ln>
-        </p:spPr>
-        <p:style>
-          <a:lnRef idx="1">
-            <a:schemeClr val="accent1"/>
-          </a:lnRef>
-          <a:fillRef idx="3">
-            <a:schemeClr val="accent1"/>
-          </a:fillRef>
-          <a:effectRef idx="2">
-            <a:schemeClr val="accent1"/>
-          </a:effectRef>
-          <a:fontRef idx="minor">
-            <a:schemeClr val="lt1"/>
-          </a:fontRef>
-        </p:style>
-        <p:txBody>
-          <a:bodyPr rtlCol="0" anchor="ctr"/>
-          <a:lstStyle/>
-          <a:p>
-            <a:pPr algn="ctr"/>
-          </a:p>
-        </p:txBody>
-      </p:sp>
-      <p:sp>
-        <p:nvSpPr>
-          <p:cNvPr id="10" name="TextBox 9"/>
-          <p:cNvSpPr txBox="1"/>
-          <p:nvPr/>
-        </p:nvSpPr>
-        <p:spPr>
-          <a:xfrm>
-            <a:off x="3648456" y="1828800"/>
-            <a:ext cx="2194560" cy="2560320"/>
-          </a:xfrm>
-          <a:prstGeom prst="rect">
-            <a:avLst/>
-          </a:prstGeom>
-          <a:noFill/>
-        </p:spPr>
-        <p:txBody>
-          <a:bodyPr wrap="square">
-            <a:spAutoFit/>
-          </a:bodyPr>
-          <a:lstStyle/>
-          <a:p>
-            <a:pPr>
-              <a:defRPr sz="2600" b="1">
-                <a:solidFill>
-                  <a:srgbClr val="34D399"/>
-                </a:solidFill>
-                <a:latin typeface="JetBrains Mono"/>
-              </a:defRPr>
-            </a:pPr>
-            <a:r>
-              <a:t>4 250 т</a:t>
-            </a:r>
-          </a:p>
-          <a:p>
-            <a:pPr>
-              <a:defRPr sz="1400" b="1">
-                <a:solidFill>
-                  <a:srgbClr val="FFFFFF"/>
-                </a:solidFill>
-                <a:latin typeface="Plus Jakarta Sans"/>
-              </a:defRPr>
-            </a:pPr>
-            <a:r>
-              <a:t>Сокращение CO₂e</a:t>
-            </a:r>
-          </a:p>
-          <a:p>
-            <a:pPr>
-              <a:defRPr sz="1100">
-                <a:solidFill>
-                  <a:srgbClr val="94A3B8"/>
-                </a:solidFill>
-                <a:latin typeface="Plus Jakarta Sans"/>
-              </a:defRPr>
-            </a:pPr>
-            <a:r>
-              <a:t>Предотвращено выбросов парниковых газов (Scope 3 Profi)</a:t>
-            </a:r>
-          </a:p>
-        </p:txBody>
-      </p:sp>
-      <p:sp>
-        <p:nvSpPr>
-          <p:cNvPr id="11" name="Rounded Rectangle 10"/>
-          <p:cNvSpPr/>
-          <p:nvPr/>
-        </p:nvSpPr>
-        <p:spPr>
-          <a:xfrm>
-            <a:off x="6199632" y="1645920"/>
-            <a:ext cx="2468880" cy="2926080"/>
-          </a:xfrm>
-          <a:prstGeom prst="roundRect">
-            <a:avLst/>
-          </a:prstGeom>
-          <a:solidFill>
-            <a:srgbClr val="182026"/>
+            <a:srgbClr val="102E22"/>
           </a:solidFill>
           <a:ln w="19050">
             <a:solidFill>
@@ -6178,14 +5698,14 @@
       </p:sp>
       <p:sp>
         <p:nvSpPr>
-          <p:cNvPr id="12" name="TextBox 11"/>
+          <p:cNvPr id="11" name="TextBox 10"/>
           <p:cNvSpPr txBox="1"/>
           <p:nvPr/>
         </p:nvSpPr>
         <p:spPr>
           <a:xfrm>
-            <a:off x="6336792" y="1828800"/>
-            <a:ext cx="2194560" cy="2560320"/>
+            <a:off x="6309360" y="1828800"/>
+            <a:ext cx="2203704" cy="2560320"/>
           </a:xfrm>
           <a:prstGeom prst="rect">
             <a:avLst/>
@@ -6198,8 +5718,8 @@
           </a:bodyPr>
           <a:lstStyle/>
           <a:p>
-            <a:pPr>
-              <a:defRPr sz="2600" b="1">
+            <a:pPr algn="ctr">
+              <a:defRPr sz="2800" b="1">
                 <a:solidFill>
                   <a:srgbClr val="34D399"/>
                 </a:solidFill>
@@ -6207,12 +5727,12 @@
               </a:defRPr>
             </a:pPr>
             <a:r>
-              <a:t>€1 280 000</a:t>
-            </a:r>
-          </a:p>
-          <a:p>
-            <a:pPr>
-              <a:defRPr sz="1400" b="1">
+              <a:t>€1.28M</a:t>
+            </a:r>
+          </a:p>
+          <a:p>
+            <a:pPr algn="ctr">
+              <a:defRPr sz="1350" b="1">
                 <a:solidFill>
                   <a:srgbClr val="FFFFFF"/>
                 </a:solidFill>
@@ -6224,40 +5744,41 @@
             </a:r>
           </a:p>
           <a:p>
-            <a:pPr>
-              <a:defRPr sz="1100">
+            <a:pPr algn="ctr">
+              <a:defRPr sz="1050">
                 <a:solidFill>
                   <a:srgbClr val="94A3B8"/>
                 </a:solidFill>
                 <a:latin typeface="Plus Jakarta Sans"/>
               </a:defRPr>
             </a:pPr>
-            <a:r>
-              <a:t>Прямая годовая экономия на налоге за счет моно-материалов</a:t>
-            </a:r>
-          </a:p>
-        </p:txBody>
-      </p:sp>
-      <p:sp>
-        <p:nvSpPr>
-          <p:cNvPr id="13" name="Rounded Rectangle 12"/>
+            <a:br/>
+            <a:r>
+              <a:t>Прямая годовая экономия на эко-сборах</a:t>
+            </a:r>
+          </a:p>
+        </p:txBody>
+      </p:sp>
+      <p:sp>
+        <p:nvSpPr>
+          <p:cNvPr id="12" name="Rounded Rectangle 11"/>
           <p:cNvSpPr/>
           <p:nvPr/>
         </p:nvSpPr>
         <p:spPr>
           <a:xfrm>
-            <a:off x="8887968" y="1645920"/>
-            <a:ext cx="2468880" cy="2926080"/>
+            <a:off x="8842248" y="1645920"/>
+            <a:ext cx="2423160" cy="2926080"/>
           </a:xfrm>
           <a:prstGeom prst="roundRect">
             <a:avLst/>
           </a:prstGeom>
           <a:solidFill>
-            <a:srgbClr val="182026"/>
+            <a:srgbClr val="12181D"/>
           </a:solidFill>
           <a:ln w="12700">
             <a:solidFill>
-              <a:srgbClr val="24323B"/>
+              <a:srgbClr val="1E2932"/>
             </a:solidFill>
           </a:ln>
         </p:spPr>
@@ -6285,14 +5806,14 @@
       </p:sp>
       <p:sp>
         <p:nvSpPr>
-          <p:cNvPr id="14" name="TextBox 13"/>
+          <p:cNvPr id="13" name="TextBox 12"/>
           <p:cNvSpPr txBox="1"/>
           <p:nvPr/>
         </p:nvSpPr>
         <p:spPr>
           <a:xfrm>
-            <a:off x="9025128" y="1828800"/>
-            <a:ext cx="2194560" cy="2560320"/>
+            <a:off x="8951976" y="1828800"/>
+            <a:ext cx="2203704" cy="2560320"/>
           </a:xfrm>
           <a:prstGeom prst="rect">
             <a:avLst/>
@@ -6305,8 +5826,8 @@
           </a:bodyPr>
           <a:lstStyle/>
           <a:p>
-            <a:pPr>
-              <a:defRPr sz="2600" b="1">
+            <a:pPr algn="ctr">
+              <a:defRPr sz="2800" b="1">
                 <a:solidFill>
                   <a:srgbClr val="34D399"/>
                 </a:solidFill>
@@ -6314,12 +5835,12 @@
               </a:defRPr>
             </a:pPr>
             <a:r>
-              <a:t>€700 000</a:t>
-            </a:r>
-          </a:p>
-          <a:p>
-            <a:pPr>
-              <a:defRPr sz="1400" b="1">
+              <a:t>€700K</a:t>
+            </a:r>
+          </a:p>
+          <a:p>
+            <a:pPr algn="ctr">
+              <a:defRPr sz="1350" b="1">
                 <a:solidFill>
                   <a:srgbClr val="FFFFFF"/>
                 </a:solidFill>
@@ -6331,38 +5852,39 @@
             </a:r>
           </a:p>
           <a:p>
-            <a:pPr>
-              <a:defRPr sz="1100">
+            <a:pPr algn="ctr">
+              <a:defRPr sz="1050">
                 <a:solidFill>
                   <a:srgbClr val="94A3B8"/>
                 </a:solidFill>
                 <a:latin typeface="Plus Jakarta Sans"/>
               </a:defRPr>
             </a:pPr>
-            <a:r>
-              <a:t>Сбережение продукции за счет продления свежести (+4 дня)</a:t>
-            </a:r>
-          </a:p>
-        </p:txBody>
-      </p:sp>
-      <p:sp>
-        <p:nvSpPr>
-          <p:cNvPr id="15" name="Rounded Rectangle 14"/>
+            <a:br/>
+            <a:r>
+              <a:t>Сбереженная продукция (+4 дня свежести)</a:t>
+            </a:r>
+          </a:p>
+        </p:txBody>
+      </p:sp>
+      <p:sp>
+        <p:nvSpPr>
+          <p:cNvPr id="14" name="Rounded Rectangle 13"/>
           <p:cNvSpPr/>
           <p:nvPr/>
         </p:nvSpPr>
         <p:spPr>
           <a:xfrm>
-            <a:off x="822960" y="4846320"/>
-            <a:ext cx="10545775" cy="1371600"/>
+            <a:off x="914400" y="4846320"/>
+            <a:ext cx="10362895" cy="1280160"/>
           </a:xfrm>
           <a:prstGeom prst="roundRect">
             <a:avLst/>
           </a:prstGeom>
           <a:solidFill>
-            <a:srgbClr val="122E24"/>
+            <a:srgbClr val="102E22"/>
           </a:solidFill>
-          <a:ln w="12700">
+          <a:ln w="19050">
             <a:solidFill>
               <a:srgbClr val="10B981"/>
             </a:solidFill>
@@ -6392,14 +5914,14 @@
       </p:sp>
       <p:sp>
         <p:nvSpPr>
-          <p:cNvPr id="16" name="TextBox 15"/>
+          <p:cNvPr id="15" name="TextBox 14"/>
           <p:cNvSpPr txBox="1"/>
           <p:nvPr/>
         </p:nvSpPr>
         <p:spPr>
           <a:xfrm>
-            <a:off x="1051560" y="4983480"/>
-            <a:ext cx="10058400" cy="1097280"/>
+            <a:off x="1097280" y="4983480"/>
+            <a:ext cx="9966960" cy="1005840"/>
           </a:xfrm>
           <a:prstGeom prst="rect">
             <a:avLst/>
@@ -6412,29 +5934,29 @@
           </a:bodyPr>
           <a:lstStyle/>
           <a:p>
-            <a:pPr>
-              <a:defRPr b="1" sz="1400">
+            <a:pPr algn="ctr">
+              <a:defRPr sz="1300" b="1">
                 <a:solidFill>
                   <a:srgbClr val="34D399"/>
                 </a:solidFill>
+                <a:latin typeface="JetBrains Mono"/>
+              </a:defRPr>
+            </a:pPr>
+            <a:r>
+              <a:t>⚡ НУЛЕВОЙ CAPEX (DROP-IN COMPATIBILITY):</a:t>
+            </a:r>
+          </a:p>
+          <a:p>
+            <a:pPr algn="ctr">
+              <a:defRPr sz="1200">
+                <a:solidFill>
+                  <a:srgbClr val="FFFFFF"/>
+                </a:solidFill>
                 <a:latin typeface="Plus Jakarta Sans"/>
               </a:defRPr>
             </a:pPr>
             <a:r>
-              <a:t>💡 Нулевой CapEx для ритейлера (Drop-In Compatibility):</a:t>
-            </a:r>
-          </a:p>
-          <a:p>
-            <a:pPr>
-              <a:defRPr sz="1200">
-                <a:solidFill>
-                  <a:srgbClr val="FFFFFF"/>
-                </a:solidFill>
-                <a:latin typeface="Plus Jakarta Sans"/>
-              </a:defRPr>
-            </a:pPr>
-            <a:r>
-              <a:t>Упаковка PackShift полностью адаптирована под стандартные запайщики лотков, фасовочные линии и тепловые витрины супермаркетов Profi. Закупка нового оборудования не требуется. Себестоимость моно-пакетов CPET на 14% ниже импортных многослойных фольгированных ламинатов.</a:t>
+              <a:t>100% совместимость со стандартными запайщиками и тепловыми витринами Profi. Себестоимость моно-пакетов CPET на 14% ниже импортных многослойных ламинатов с фольгой.</a:t>
             </a:r>
           </a:p>
         </p:txBody>
@@ -6472,11 +5994,11 @@
             <a:avLst/>
           </a:prstGeom>
           <a:solidFill>
-            <a:srgbClr val="0F1418"/>
+            <a:srgbClr val="0A0E11"/>
           </a:solidFill>
           <a:ln>
             <a:solidFill>
-              <a:srgbClr val="0F1418"/>
+              <a:srgbClr val="0A0E11"/>
             </a:solidFill>
           </a:ln>
         </p:spPr>
@@ -6510,8 +6032,8 @@
         </p:nvSpPr>
         <p:spPr>
           <a:xfrm>
-            <a:off x="822960" y="411480"/>
-            <a:ext cx="8686800" cy="320040"/>
+            <a:off x="914400" y="365760"/>
+            <a:ext cx="10362895" cy="320040"/>
           </a:xfrm>
           <a:prstGeom prst="rect">
             <a:avLst/>
@@ -6524,7 +6046,7 @@
           </a:bodyPr>
           <a:lstStyle/>
           <a:p>
-            <a:pPr>
+            <a:pPr algn="ctr">
               <a:defRPr sz="1100" b="1">
                 <a:solidFill>
                   <a:srgbClr val="34D399"/>
@@ -6533,7 +6055,7 @@
               </a:defRPr>
             </a:pPr>
             <a:r>
-              <a:t>СТАНДАРТЫ И СЕРТИФИКАЦИЯ • GIGAHACK 2026</a:t>
+              <a:t>РЕГУЛЯТОРНЫЙ ЩИТ</a:t>
             </a:r>
           </a:p>
         </p:txBody>
@@ -6546,8 +6068,8 @@
         </p:nvSpPr>
         <p:spPr>
           <a:xfrm>
-            <a:off x="822960" y="685800"/>
-            <a:ext cx="8686800" cy="731520"/>
+            <a:off x="914400" y="685800"/>
+            <a:ext cx="10362895" cy="685800"/>
           </a:xfrm>
           <a:prstGeom prst="rect">
             <a:avLst/>
@@ -6560,8 +6082,8 @@
           </a:bodyPr>
           <a:lstStyle/>
           <a:p>
-            <a:pPr>
-              <a:defRPr sz="2200" b="1">
+            <a:pPr algn="ctr">
+              <a:defRPr sz="2400" b="1">
                 <a:solidFill>
                   <a:srgbClr val="FFFFFF"/>
                 </a:solidFill>
@@ -6569,7 +6091,7 @@
               </a:defRPr>
             </a:pPr>
             <a:r>
-              <a:t>Регуляторный щит и соответствие нормативам ЕС</a:t>
+              <a:t>Международные стандарты безопасности и рециклинга</a:t>
             </a:r>
           </a:p>
         </p:txBody>
@@ -6582,8 +6104,8 @@
         </p:nvSpPr>
         <p:spPr>
           <a:xfrm>
-            <a:off x="10241280" y="457200"/>
-            <a:ext cx="1188720" cy="365760"/>
+            <a:off x="10332720" y="365760"/>
+            <a:ext cx="1097280" cy="320040"/>
           </a:xfrm>
           <a:prstGeom prst="rect">
             <a:avLst/>
@@ -6597,7 +6119,7 @@
           <a:lstStyle/>
           <a:p>
             <a:pPr algn="r">
-              <a:defRPr sz="1200" b="1">
+              <a:defRPr sz="1100" b="1">
                 <a:solidFill>
                   <a:srgbClr val="94A3B8"/>
                 </a:solidFill>
@@ -6612,24 +6134,24 @@
       </p:sp>
       <p:sp>
         <p:nvSpPr>
-          <p:cNvPr id="6" name="Rectangle 5"/>
+          <p:cNvPr id="6" name="Rounded Rectangle 5"/>
           <p:cNvSpPr/>
           <p:nvPr/>
         </p:nvSpPr>
         <p:spPr>
           <a:xfrm>
-            <a:off x="822960" y="1371600"/>
-            <a:ext cx="10545775" cy="18288"/>
-          </a:xfrm>
-          <a:prstGeom prst="rect">
+            <a:off x="914400" y="1645920"/>
+            <a:ext cx="2423160" cy="4480560"/>
+          </a:xfrm>
+          <a:prstGeom prst="roundRect">
             <a:avLst/>
           </a:prstGeom>
           <a:solidFill>
-            <a:srgbClr val="24323B"/>
+            <a:srgbClr val="12181D"/>
           </a:solidFill>
-          <a:ln>
+          <a:ln w="12700">
             <a:solidFill>
-              <a:srgbClr val="24323B"/>
+              <a:srgbClr val="1E2932"/>
             </a:solidFill>
           </a:ln>
         </p:spPr>
@@ -6657,24 +6179,88 @@
       </p:sp>
       <p:sp>
         <p:nvSpPr>
-          <p:cNvPr id="7" name="Rounded Rectangle 6"/>
+          <p:cNvPr id="7" name="TextBox 6"/>
+          <p:cNvSpPr txBox="1"/>
+          <p:nvPr/>
+        </p:nvSpPr>
+        <p:spPr>
+          <a:xfrm>
+            <a:off x="1024128" y="1920240"/>
+            <a:ext cx="2203704" cy="3931920"/>
+          </a:xfrm>
+          <a:prstGeom prst="rect">
+            <a:avLst/>
+          </a:prstGeom>
+          <a:noFill/>
+        </p:spPr>
+        <p:txBody>
+          <a:bodyPr wrap="square">
+            <a:spAutoFit/>
+          </a:bodyPr>
+          <a:lstStyle/>
+          <a:p>
+            <a:pPr algn="ctr">
+              <a:defRPr sz="1100" b="1">
+                <a:solidFill>
+                  <a:srgbClr val="34D399"/>
+                </a:solidFill>
+                <a:latin typeface="JetBrains Mono"/>
+              </a:defRPr>
+            </a:pPr>
+            <a:r>
+              <a:t>RECYCLING</a:t>
+            </a:r>
+          </a:p>
+          <a:p>
+            <a:pPr algn="ctr">
+              <a:defRPr sz="2000" b="1">
+                <a:solidFill>
+                  <a:srgbClr val="FFFFFF"/>
+                </a:solidFill>
+                <a:latin typeface="Plus Jakarta Sans"/>
+              </a:defRPr>
+            </a:pPr>
+            <a:br/>
+            <a:r>
+              <a:t>RecyClass A</a:t>
+            </a:r>
+            <a:br/>
+          </a:p>
+          <a:p>
+            <a:pPr algn="ctr">
+              <a:defRPr sz="1150">
+                <a:solidFill>
+                  <a:srgbClr val="94A3B8"/>
+                </a:solidFill>
+                <a:latin typeface="Plus Jakarta Sans"/>
+              </a:defRPr>
+            </a:pPr>
+            <a:r>
+              <a:t>Высший класс сортировки. Совместимость с NIR-сепараторами и механическим рециклингом в ЕС.</a:t>
+            </a:r>
+          </a:p>
+        </p:txBody>
+      </p:sp>
+      <p:sp>
+        <p:nvSpPr>
+          <p:cNvPr id="8" name="Rounded Rectangle 7"/>
           <p:cNvSpPr/>
           <p:nvPr/>
         </p:nvSpPr>
         <p:spPr>
           <a:xfrm>
-            <a:off x="822960" y="1645920"/>
-            <a:ext cx="2468880" cy="4572000"/>
+            <a:off x="3557016" y="1645920"/>
+            <a:ext cx="2423160" cy="4480560"/>
           </a:xfrm>
           <a:prstGeom prst="roundRect">
             <a:avLst/>
           </a:prstGeom>
           <a:solidFill>
-            <a:srgbClr val="182026"/>
+            <a:srgbClr val="12181D"/>
           </a:solidFill>
           <a:ln w="12700">
             <a:solidFill>
-              <a:srgbClr val="24323B"/>
+              <a:srgbClr val="1E2932"/>
             </a:solidFill>
           </a:ln>
         </p:spPr>
@@ -6702,14 +6288,14 @@
       </p:sp>
       <p:sp>
         <p:nvSpPr>
-          <p:cNvPr id="8" name="TextBox 7"/>
+          <p:cNvPr id="9" name="TextBox 8"/>
           <p:cNvSpPr txBox="1"/>
           <p:nvPr/>
         </p:nvSpPr>
         <p:spPr>
           <a:xfrm>
-            <a:off x="987552" y="1828800"/>
-            <a:ext cx="2139696" cy="4206240"/>
+            <a:off x="3666744" y="1920240"/>
+            <a:ext cx="2203704" cy="3931920"/>
           </a:xfrm>
           <a:prstGeom prst="rect">
             <a:avLst/>
@@ -6722,34 +6308,36 @@
           </a:bodyPr>
           <a:lstStyle/>
           <a:p>
-            <a:pPr>
+            <a:pPr algn="ctr">
               <a:defRPr sz="1100" b="1">
                 <a:solidFill>
-                  <a:srgbClr val="10B981"/>
+                  <a:srgbClr val="34D399"/>
                 </a:solidFill>
                 <a:latin typeface="JetBrains Mono"/>
               </a:defRPr>
             </a:pPr>
             <a:r>
-              <a:t>RECYCLASS</a:t>
-            </a:r>
-          </a:p>
-          <a:p>
-            <a:pPr>
-              <a:defRPr sz="1700" b="1">
+              <a:t>REGULATION</a:t>
+            </a:r>
+          </a:p>
+          <a:p>
+            <a:pPr algn="ctr">
+              <a:defRPr sz="2000" b="1">
                 <a:solidFill>
                   <a:srgbClr val="FFFFFF"/>
                 </a:solidFill>
                 <a:latin typeface="Plus Jakarta Sans"/>
               </a:defRPr>
             </a:pPr>
-            <a:r>
-              <a:t>Grade A Recyclability</a:t>
-            </a:r>
-          </a:p>
-          <a:p>
-            <a:pPr>
-              <a:defRPr sz="1200">
+            <a:br/>
+            <a:r>
+              <a:t>PPWR 2030</a:t>
+            </a:r>
+            <a:br/>
+          </a:p>
+          <a:p>
+            <a:pPr algn="ctr">
+              <a:defRPr sz="1150">
                 <a:solidFill>
                   <a:srgbClr val="94A3B8"/>
                 </a:solidFill>
@@ -6757,31 +6345,31 @@
               </a:defRPr>
             </a:pPr>
             <a:r>
-              <a:t>Подтвержденная совместимость с оптической сортировкой (NIR) и механическим рециклингом в ЕС.</a:t>
-            </a:r>
-          </a:p>
-        </p:txBody>
-      </p:sp>
-      <p:sp>
-        <p:nvSpPr>
-          <p:cNvPr id="9" name="Rounded Rectangle 8"/>
+              <a:t>Упреждение европейских норм: &gt;35% пищевого rPET, 0% первичного пластика в фасовке.</a:t>
+            </a:r>
+          </a:p>
+        </p:txBody>
+      </p:sp>
+      <p:sp>
+        <p:nvSpPr>
+          <p:cNvPr id="10" name="Rounded Rectangle 9"/>
           <p:cNvSpPr/>
           <p:nvPr/>
         </p:nvSpPr>
         <p:spPr>
           <a:xfrm>
-            <a:off x="3511296" y="1645920"/>
-            <a:ext cx="2468880" cy="4572000"/>
+            <a:off x="6199632" y="1645920"/>
+            <a:ext cx="2423160" cy="4480560"/>
           </a:xfrm>
           <a:prstGeom prst="roundRect">
             <a:avLst/>
           </a:prstGeom>
           <a:solidFill>
-            <a:srgbClr val="182026"/>
+            <a:srgbClr val="12181D"/>
           </a:solidFill>
           <a:ln w="12700">
             <a:solidFill>
-              <a:srgbClr val="24323B"/>
+              <a:srgbClr val="1E2932"/>
             </a:solidFill>
           </a:ln>
         </p:spPr>
@@ -6809,14 +6397,14 @@
       </p:sp>
       <p:sp>
         <p:nvSpPr>
-          <p:cNvPr id="10" name="TextBox 9"/>
+          <p:cNvPr id="11" name="TextBox 10"/>
           <p:cNvSpPr txBox="1"/>
           <p:nvPr/>
         </p:nvSpPr>
         <p:spPr>
           <a:xfrm>
-            <a:off x="3675888" y="1828800"/>
-            <a:ext cx="2139696" cy="4206240"/>
+            <a:off x="6309360" y="1920240"/>
+            <a:ext cx="2203704" cy="3931920"/>
           </a:xfrm>
           <a:prstGeom prst="rect">
             <a:avLst/>
@@ -6829,34 +6417,36 @@
           </a:bodyPr>
           <a:lstStyle/>
           <a:p>
-            <a:pPr>
+            <a:pPr algn="ctr">
               <a:defRPr sz="1100" b="1">
                 <a:solidFill>
-                  <a:srgbClr val="10B981"/>
+                  <a:srgbClr val="34D399"/>
                 </a:solidFill>
                 <a:latin typeface="JetBrains Mono"/>
               </a:defRPr>
             </a:pPr>
             <a:r>
-              <a:t>EU PPWR</a:t>
-            </a:r>
-          </a:p>
-          <a:p>
-            <a:pPr>
-              <a:defRPr sz="1700" b="1">
+              <a:t>CHEMICAL SAFETY</a:t>
+            </a:r>
+          </a:p>
+          <a:p>
+            <a:pPr algn="ctr">
+              <a:defRPr sz="2000" b="1">
                 <a:solidFill>
                   <a:srgbClr val="FFFFFF"/>
                 </a:solidFill>
                 <a:latin typeface="Plus Jakarta Sans"/>
               </a:defRPr>
             </a:pPr>
-            <a:r>
-              <a:t>PPWR 2030 Ready</a:t>
-            </a:r>
-          </a:p>
-          <a:p>
-            <a:pPr>
-              <a:defRPr sz="1200">
+            <a:br/>
+            <a:r>
+              <a:t>Zero PFAS</a:t>
+            </a:r>
+            <a:br/>
+          </a:p>
+          <a:p>
+            <a:pPr algn="ctr">
+              <a:defRPr sz="1150">
                 <a:solidFill>
                   <a:srgbClr val="94A3B8"/>
                 </a:solidFill>
@@ -6864,31 +6454,31 @@
               </a:defRPr>
             </a:pPr>
             <a:r>
-              <a:t>Упреждение европейских норм: &gt;35% пищевого rPET, 0% первичного пластика в фасовочных пакетах.</a:t>
-            </a:r>
-          </a:p>
-        </p:txBody>
-      </p:sp>
-      <p:sp>
-        <p:nvSpPr>
-          <p:cNvPr id="11" name="Rounded Rectangle 10"/>
+              <a:t>100% PFAS-Free. Лабораторный тест на отсутствие фторорганики в контакте до 250°C.</a:t>
+            </a:r>
+          </a:p>
+        </p:txBody>
+      </p:sp>
+      <p:sp>
+        <p:nvSpPr>
+          <p:cNvPr id="12" name="Rounded Rectangle 11"/>
           <p:cNvSpPr/>
           <p:nvPr/>
         </p:nvSpPr>
         <p:spPr>
           <a:xfrm>
-            <a:off x="6199632" y="1645920"/>
-            <a:ext cx="2468880" cy="4572000"/>
+            <a:off x="8842248" y="1645920"/>
+            <a:ext cx="2423160" cy="4480560"/>
           </a:xfrm>
           <a:prstGeom prst="roundRect">
             <a:avLst/>
           </a:prstGeom>
           <a:solidFill>
-            <a:srgbClr val="182026"/>
+            <a:srgbClr val="12181D"/>
           </a:solidFill>
           <a:ln w="12700">
             <a:solidFill>
-              <a:srgbClr val="24323B"/>
+              <a:srgbClr val="1E2932"/>
             </a:solidFill>
           </a:ln>
         </p:spPr>
@@ -6916,14 +6506,14 @@
       </p:sp>
       <p:sp>
         <p:nvSpPr>
-          <p:cNvPr id="12" name="TextBox 11"/>
+          <p:cNvPr id="13" name="TextBox 12"/>
           <p:cNvSpPr txBox="1"/>
           <p:nvPr/>
         </p:nvSpPr>
         <p:spPr>
           <a:xfrm>
-            <a:off x="6364224" y="1828800"/>
-            <a:ext cx="2139696" cy="4206240"/>
+            <a:off x="8951976" y="1920240"/>
+            <a:ext cx="2203704" cy="3931920"/>
           </a:xfrm>
           <a:prstGeom prst="rect">
             <a:avLst/>
@@ -6936,34 +6526,36 @@
           </a:bodyPr>
           <a:lstStyle/>
           <a:p>
-            <a:pPr>
+            <a:pPr algn="ctr">
               <a:defRPr sz="1100" b="1">
                 <a:solidFill>
-                  <a:srgbClr val="10B981"/>
+                  <a:srgbClr val="34D399"/>
                 </a:solidFill>
                 <a:latin typeface="JetBrains Mono"/>
               </a:defRPr>
             </a:pPr>
             <a:r>
-              <a:t>ZERO TOXIC</a:t>
-            </a:r>
-          </a:p>
-          <a:p>
-            <a:pPr>
-              <a:defRPr sz="1700" b="1">
+              <a:t>FOOD CONTACT</a:t>
+            </a:r>
+          </a:p>
+          <a:p>
+            <a:pPr algn="ctr">
+              <a:defRPr sz="2000" b="1">
                 <a:solidFill>
                   <a:srgbClr val="FFFFFF"/>
                 </a:solidFill>
                 <a:latin typeface="Plus Jakarta Sans"/>
               </a:defRPr>
             </a:pPr>
-            <a:r>
-              <a:t>100% PFAS-Free</a:t>
-            </a:r>
-          </a:p>
-          <a:p>
-            <a:pPr>
-              <a:defRPr sz="1200">
+            <a:br/>
+            <a:r>
+              <a:t>EFSA / FDA</a:t>
+            </a:r>
+            <a:br/>
+          </a:p>
+          <a:p>
+            <a:pPr algn="ctr">
+              <a:defRPr sz="1150">
                 <a:solidFill>
                   <a:srgbClr val="94A3B8"/>
                 </a:solidFill>
@@ -6971,114 +6563,7 @@
               </a:defRPr>
             </a:pPr>
             <a:r>
-              <a:t>Сертификация отсутствия пер- и полифторалкильных веществ в контакте с горячим маслом до 250°C.</a:t>
-            </a:r>
-          </a:p>
-        </p:txBody>
-      </p:sp>
-      <p:sp>
-        <p:nvSpPr>
-          <p:cNvPr id="13" name="Rounded Rectangle 12"/>
-          <p:cNvSpPr/>
-          <p:nvPr/>
-        </p:nvSpPr>
-        <p:spPr>
-          <a:xfrm>
-            <a:off x="8887968" y="1645920"/>
-            <a:ext cx="2468880" cy="4572000"/>
-          </a:xfrm>
-          <a:prstGeom prst="roundRect">
-            <a:avLst/>
-          </a:prstGeom>
-          <a:solidFill>
-            <a:srgbClr val="182026"/>
-          </a:solidFill>
-          <a:ln w="12700">
-            <a:solidFill>
-              <a:srgbClr val="24323B"/>
-            </a:solidFill>
-          </a:ln>
-        </p:spPr>
-        <p:style>
-          <a:lnRef idx="1">
-            <a:schemeClr val="accent1"/>
-          </a:lnRef>
-          <a:fillRef idx="3">
-            <a:schemeClr val="accent1"/>
-          </a:fillRef>
-          <a:effectRef idx="2">
-            <a:schemeClr val="accent1"/>
-          </a:effectRef>
-          <a:fontRef idx="minor">
-            <a:schemeClr val="lt1"/>
-          </a:fontRef>
-        </p:style>
-        <p:txBody>
-          <a:bodyPr rtlCol="0" anchor="ctr"/>
-          <a:lstStyle/>
-          <a:p>
-            <a:pPr algn="ctr"/>
-          </a:p>
-        </p:txBody>
-      </p:sp>
-      <p:sp>
-        <p:nvSpPr>
-          <p:cNvPr id="14" name="TextBox 13"/>
-          <p:cNvSpPr txBox="1"/>
-          <p:nvPr/>
-        </p:nvSpPr>
-        <p:spPr>
-          <a:xfrm>
-            <a:off x="9052560" y="1828800"/>
-            <a:ext cx="2139696" cy="4206240"/>
-          </a:xfrm>
-          <a:prstGeom prst="rect">
-            <a:avLst/>
-          </a:prstGeom>
-          <a:noFill/>
-        </p:spPr>
-        <p:txBody>
-          <a:bodyPr wrap="square">
-            <a:spAutoFit/>
-          </a:bodyPr>
-          <a:lstStyle/>
-          <a:p>
-            <a:pPr>
-              <a:defRPr sz="1100" b="1">
-                <a:solidFill>
-                  <a:srgbClr val="10B981"/>
-                </a:solidFill>
-                <a:latin typeface="JetBrains Mono"/>
-              </a:defRPr>
-            </a:pPr>
-            <a:r>
-              <a:t>FOOD SAFE</a:t>
-            </a:r>
-          </a:p>
-          <a:p>
-            <a:pPr>
-              <a:defRPr sz="1700" b="1">
-                <a:solidFill>
-                  <a:srgbClr val="FFFFFF"/>
-                </a:solidFill>
-                <a:latin typeface="Plus Jakarta Sans"/>
-              </a:defRPr>
-            </a:pPr>
-            <a:r>
-              <a:t>EFSA / FDA Approved</a:t>
-            </a:r>
-          </a:p>
-          <a:p>
-            <a:pPr>
-              <a:defRPr sz="1200">
-                <a:solidFill>
-                  <a:srgbClr val="94A3B8"/>
-                </a:solidFill>
-                <a:latin typeface="Plus Jakarta Sans"/>
-              </a:defRPr>
-            </a:pPr>
-            <a:r>
-              <a:t>Соответствие Regulation EU No 10/2011 для прямого контакта с горячими и жирными продуктами.</a:t>
+              <a:t>Сертификация Regulation EU No 10/2011 для прямого контакта с горячим жиром.</a:t>
             </a:r>
           </a:p>
         </p:txBody>
@@ -7116,11 +6601,11 @@
             <a:avLst/>
           </a:prstGeom>
           <a:solidFill>
-            <a:srgbClr val="0F1418"/>
+            <a:srgbClr val="0A0E11"/>
           </a:solidFill>
           <a:ln>
             <a:solidFill>
-              <a:srgbClr val="0F1418"/>
+              <a:srgbClr val="0A0E11"/>
             </a:solidFill>
           </a:ln>
         </p:spPr>
@@ -7154,8 +6639,8 @@
         </p:nvSpPr>
         <p:spPr>
           <a:xfrm>
-            <a:off x="822960" y="411480"/>
-            <a:ext cx="8686800" cy="320040"/>
+            <a:off x="914400" y="365760"/>
+            <a:ext cx="10362895" cy="320040"/>
           </a:xfrm>
           <a:prstGeom prst="rect">
             <a:avLst/>
@@ -7168,7 +6653,7 @@
           </a:bodyPr>
           <a:lstStyle/>
           <a:p>
-            <a:pPr>
+            <a:pPr algn="ctr">
               <a:defRPr sz="1100" b="1">
                 <a:solidFill>
                   <a:srgbClr val="34D399"/>
@@ -7177,7 +6662,7 @@
               </a:defRPr>
             </a:pPr>
             <a:r>
-              <a:t>ДОРОЖНАЯ КАРТА • GIGAHACK 2026</a:t>
+              <a:t>ДОРОЖНАЯ КАРТА ВНЕДРЕНИЯ</a:t>
             </a:r>
           </a:p>
         </p:txBody>
@@ -7190,8 +6675,8 @@
         </p:nvSpPr>
         <p:spPr>
           <a:xfrm>
-            <a:off x="822960" y="685800"/>
-            <a:ext cx="8686800" cy="731520"/>
+            <a:off x="914400" y="685800"/>
+            <a:ext cx="10362895" cy="685800"/>
           </a:xfrm>
           <a:prstGeom prst="rect">
             <a:avLst/>
@@ -7204,8 +6689,8 @@
           </a:bodyPr>
           <a:lstStyle/>
           <a:p>
-            <a:pPr>
-              <a:defRPr sz="2200" b="1">
+            <a:pPr algn="ctr">
+              <a:defRPr sz="2400" b="1">
                 <a:solidFill>
                   <a:srgbClr val="FFFFFF"/>
                 </a:solidFill>
@@ -7213,7 +6698,7 @@
               </a:defRPr>
             </a:pPr>
             <a:r>
-              <a:t>План пилотного запуска в Profi: 6 недель до результата</a:t>
+              <a:t>План пилотного запуска в Profi: 6 недель</a:t>
             </a:r>
           </a:p>
         </p:txBody>
@@ -7226,8 +6711,8 @@
         </p:nvSpPr>
         <p:spPr>
           <a:xfrm>
-            <a:off x="10241280" y="457200"/>
-            <a:ext cx="1188720" cy="365760"/>
+            <a:off x="10332720" y="365760"/>
+            <a:ext cx="1097280" cy="320040"/>
           </a:xfrm>
           <a:prstGeom prst="rect">
             <a:avLst/>
@@ -7241,7 +6726,7 @@
           <a:lstStyle/>
           <a:p>
             <a:pPr algn="r">
-              <a:defRPr sz="1200" b="1">
+              <a:defRPr sz="1100" b="1">
                 <a:solidFill>
                   <a:srgbClr val="94A3B8"/>
                 </a:solidFill>
@@ -7256,65 +6741,20 @@
       </p:sp>
       <p:sp>
         <p:nvSpPr>
-          <p:cNvPr id="6" name="Rectangle 5"/>
+          <p:cNvPr id="6" name="Rounded Rectangle 5"/>
           <p:cNvSpPr/>
           <p:nvPr/>
         </p:nvSpPr>
         <p:spPr>
           <a:xfrm>
-            <a:off x="822960" y="1371600"/>
-            <a:ext cx="10545775" cy="18288"/>
-          </a:xfrm>
-          <a:prstGeom prst="rect">
+            <a:off x="914400" y="1645920"/>
+            <a:ext cx="3291840" cy="2926080"/>
+          </a:xfrm>
+          <a:prstGeom prst="roundRect">
             <a:avLst/>
           </a:prstGeom>
           <a:solidFill>
-            <a:srgbClr val="24323B"/>
-          </a:solidFill>
-          <a:ln>
-            <a:solidFill>
-              <a:srgbClr val="24323B"/>
-            </a:solidFill>
-          </a:ln>
-        </p:spPr>
-        <p:style>
-          <a:lnRef idx="1">
-            <a:schemeClr val="accent1"/>
-          </a:lnRef>
-          <a:fillRef idx="3">
-            <a:schemeClr val="accent1"/>
-          </a:fillRef>
-          <a:effectRef idx="2">
-            <a:schemeClr val="accent1"/>
-          </a:effectRef>
-          <a:fontRef idx="minor">
-            <a:schemeClr val="lt1"/>
-          </a:fontRef>
-        </p:style>
-        <p:txBody>
-          <a:bodyPr rtlCol="0" anchor="ctr"/>
-          <a:lstStyle/>
-          <a:p>
-            <a:pPr algn="ctr"/>
-          </a:p>
-        </p:txBody>
-      </p:sp>
-      <p:sp>
-        <p:nvSpPr>
-          <p:cNvPr id="7" name="Rounded Rectangle 6"/>
-          <p:cNvSpPr/>
-          <p:nvPr/>
-        </p:nvSpPr>
-        <p:spPr>
-          <a:xfrm>
-            <a:off x="822960" y="1645920"/>
-            <a:ext cx="3328416" cy="3291840"/>
-          </a:xfrm>
-          <a:prstGeom prst="roundRect">
-            <a:avLst/>
-          </a:prstGeom>
-          <a:solidFill>
-            <a:srgbClr val="182026"/>
+            <a:srgbClr val="102E22"/>
           </a:solidFill>
           <a:ln w="19050">
             <a:solidFill>
@@ -7346,14 +6786,14 @@
       </p:sp>
       <p:sp>
         <p:nvSpPr>
-          <p:cNvPr id="8" name="TextBox 7"/>
+          <p:cNvPr id="7" name="TextBox 6"/>
           <p:cNvSpPr txBox="1"/>
           <p:nvPr/>
         </p:nvSpPr>
         <p:spPr>
           <a:xfrm>
-            <a:off x="987552" y="1810512"/>
-            <a:ext cx="2999232" cy="2962656"/>
+            <a:off x="1051560" y="1874520"/>
+            <a:ext cx="3017520" cy="2468880"/>
           </a:xfrm>
           <a:prstGeom prst="rect">
             <a:avLst/>
@@ -7366,20 +6806,20 @@
           </a:bodyPr>
           <a:lstStyle/>
           <a:p>
-            <a:pPr>
+            <a:pPr algn="ctr">
               <a:defRPr sz="1100" b="1">
                 <a:solidFill>
-                  <a:srgbClr val="10B981"/>
+                  <a:srgbClr val="34D399"/>
                 </a:solidFill>
                 <a:latin typeface="JetBrains Mono"/>
               </a:defRPr>
             </a:pPr>
             <a:r>
-              <a:t>ЭТАП 1 • 2 недели</a:t>
-            </a:r>
-          </a:p>
-          <a:p>
-            <a:pPr>
+              <a:t>ЭТАП 1 • 2 НЕДЕЛИ</a:t>
+            </a:r>
+          </a:p>
+          <a:p>
+            <a:pPr algn="ctr">
               <a:defRPr sz="1800" b="1">
                 <a:solidFill>
                   <a:srgbClr val="FFFFFF"/>
@@ -7387,12 +6827,14 @@
                 <a:latin typeface="Plus Jakarta Sans"/>
               </a:defRPr>
             </a:pPr>
+            <a:br/>
             <a:r>
               <a:t>Лабораторный тест</a:t>
             </a:r>
-          </a:p>
-          <a:p>
-            <a:pPr>
+            <a:br/>
+          </a:p>
+          <a:p>
+            <a:pPr algn="ctr">
               <a:defRPr sz="1150">
                 <a:solidFill>
                   <a:srgbClr val="94A3B8"/>
@@ -7401,57 +6843,31 @@
               </a:defRPr>
             </a:pPr>
             <a:r>
-              <a:t>• Тестирование пакетов CPET и термобоксов на витринах гриля Profi при 95°C–120°C.</a:t>
-            </a:r>
-          </a:p>
-          <a:p>
-            <a:pPr>
-              <a:defRPr sz="1150">
-                <a:solidFill>
-                  <a:srgbClr val="94A3B8"/>
-                </a:solidFill>
-                <a:latin typeface="Plus Jakarta Sans"/>
-              </a:defRPr>
-            </a:pPr>
-            <a:r>
-              <a:t>• Проверка герметичности, жиростойкости (Kit 12) и отсутствия посторонних запахов.</a:t>
-            </a:r>
-          </a:p>
-          <a:p>
-            <a:pPr>
-              <a:defRPr sz="1150">
-                <a:solidFill>
-                  <a:srgbClr val="94A3B8"/>
-                </a:solidFill>
-                <a:latin typeface="Plus Jakarta Sans"/>
-              </a:defRPr>
-            </a:pPr>
-            <a:r>
-              <a:t>• Протокол миграции EFSA для контакта с горячим куриным жиром.</a:t>
-            </a:r>
-          </a:p>
-        </p:txBody>
-      </p:sp>
-      <p:sp>
-        <p:nvSpPr>
-          <p:cNvPr id="9" name="Rounded Rectangle 8"/>
+              <a:t>Тест пакетов CPET и боксов при 95°C–120°C (6 часов). Проверка удержания жира Kit 12 и протокол EFSA.</a:t>
+            </a:r>
+          </a:p>
+        </p:txBody>
+      </p:sp>
+      <p:sp>
+        <p:nvSpPr>
+          <p:cNvPr id="8" name="Rounded Rectangle 7"/>
           <p:cNvSpPr/>
           <p:nvPr/>
         </p:nvSpPr>
         <p:spPr>
           <a:xfrm>
-            <a:off x="4425696" y="1645920"/>
-            <a:ext cx="3328416" cy="3291840"/>
+            <a:off x="4443984" y="1645920"/>
+            <a:ext cx="3291840" cy="2926080"/>
           </a:xfrm>
           <a:prstGeom prst="roundRect">
             <a:avLst/>
           </a:prstGeom>
           <a:solidFill>
-            <a:srgbClr val="182026"/>
+            <a:srgbClr val="12181D"/>
           </a:solidFill>
           <a:ln w="12700">
             <a:solidFill>
-              <a:srgbClr val="24323B"/>
+              <a:srgbClr val="1E2932"/>
             </a:solidFill>
           </a:ln>
         </p:spPr>
@@ -7479,14 +6895,14 @@
       </p:sp>
       <p:sp>
         <p:nvSpPr>
-          <p:cNvPr id="10" name="TextBox 9"/>
+          <p:cNvPr id="9" name="TextBox 8"/>
           <p:cNvSpPr txBox="1"/>
           <p:nvPr/>
         </p:nvSpPr>
         <p:spPr>
           <a:xfrm>
-            <a:off x="4590288" y="1810512"/>
-            <a:ext cx="2999232" cy="2962656"/>
+            <a:off x="4581144" y="1874520"/>
+            <a:ext cx="3017520" cy="2468880"/>
           </a:xfrm>
           <a:prstGeom prst="rect">
             <a:avLst/>
@@ -7499,20 +6915,20 @@
           </a:bodyPr>
           <a:lstStyle/>
           <a:p>
-            <a:pPr>
+            <a:pPr algn="ctr">
               <a:defRPr sz="1100" b="1">
                 <a:solidFill>
-                  <a:srgbClr val="10B981"/>
+                  <a:srgbClr val="34D399"/>
                 </a:solidFill>
                 <a:latin typeface="JetBrains Mono"/>
               </a:defRPr>
             </a:pPr>
             <a:r>
-              <a:t>ЭТАП 2 • 4 недели</a:t>
-            </a:r>
-          </a:p>
-          <a:p>
-            <a:pPr>
+              <a:t>ЭТАП 2 • 4 НЕДЕЛИ</a:t>
+            </a:r>
+          </a:p>
+          <a:p>
+            <a:pPr algn="ctr">
               <a:defRPr sz="1800" b="1">
                 <a:solidFill>
                   <a:srgbClr val="FFFFFF"/>
@@ -7520,12 +6936,14 @@
                 <a:latin typeface="Plus Jakarta Sans"/>
               </a:defRPr>
             </a:pPr>
+            <a:br/>
             <a:r>
               <a:t>Пилот в 5 магазинах</a:t>
             </a:r>
-          </a:p>
-          <a:p>
-            <a:pPr>
+            <a:br/>
+          </a:p>
+          <a:p>
+            <a:pPr algn="ctr">
               <a:defRPr sz="1150">
                 <a:solidFill>
                   <a:srgbClr val="94A3B8"/>
@@ -7534,57 +6952,31 @@
               </a:defRPr>
             </a:pPr>
             <a:r>
-              <a:t>• Запуск в 5 флагманских супермаркетах Profi в отделах Гриль и Овощи.</a:t>
-            </a:r>
-          </a:p>
-          <a:p>
-            <a:pPr>
-              <a:defRPr sz="1150">
-                <a:solidFill>
-                  <a:srgbClr val="94A3B8"/>
-                </a:solidFill>
-                <a:latin typeface="Plus Jakarta Sans"/>
-              </a:defRPr>
-            </a:pPr>
-            <a:r>
-              <a:t>• Сбор обратной связи от поваров кулинарии и покупателей.</a:t>
-            </a:r>
-          </a:p>
-          <a:p>
-            <a:pPr>
-              <a:defRPr sz="1150">
-                <a:solidFill>
-                  <a:srgbClr val="94A3B8"/>
-                </a:solidFill>
-                <a:latin typeface="Plus Jakarta Sans"/>
-              </a:defRPr>
-            </a:pPr>
-            <a:r>
-              <a:t>• Замер динамики списаний и сохранности хрустящей корочки гриля.</a:t>
-            </a:r>
-          </a:p>
-        </p:txBody>
-      </p:sp>
-      <p:sp>
-        <p:nvSpPr>
-          <p:cNvPr id="11" name="Rounded Rectangle 10"/>
+              <a:t>Полевое тестирование в отделах Гриль и Овощи. Сбор отзывов поваров кулинарии и покупателей сети.</a:t>
+            </a:r>
+          </a:p>
+        </p:txBody>
+      </p:sp>
+      <p:sp>
+        <p:nvSpPr>
+          <p:cNvPr id="10" name="Rounded Rectangle 9"/>
           <p:cNvSpPr/>
           <p:nvPr/>
         </p:nvSpPr>
         <p:spPr>
           <a:xfrm>
-            <a:off x="8028432" y="1645920"/>
-            <a:ext cx="3328416" cy="3291840"/>
+            <a:off x="7973568" y="1645920"/>
+            <a:ext cx="3291840" cy="2926080"/>
           </a:xfrm>
           <a:prstGeom prst="roundRect">
             <a:avLst/>
           </a:prstGeom>
           <a:solidFill>
-            <a:srgbClr val="182026"/>
+            <a:srgbClr val="12181D"/>
           </a:solidFill>
           <a:ln w="12700">
             <a:solidFill>
-              <a:srgbClr val="24323B"/>
+              <a:srgbClr val="1E2932"/>
             </a:solidFill>
           </a:ln>
         </p:spPr>
@@ -7612,14 +7004,14 @@
       </p:sp>
       <p:sp>
         <p:nvSpPr>
-          <p:cNvPr id="12" name="TextBox 11"/>
+          <p:cNvPr id="11" name="TextBox 10"/>
           <p:cNvSpPr txBox="1"/>
           <p:nvPr/>
         </p:nvSpPr>
         <p:spPr>
           <a:xfrm>
-            <a:off x="8193024" y="1810512"/>
-            <a:ext cx="2999232" cy="2962656"/>
+            <a:off x="8110728" y="1874520"/>
+            <a:ext cx="3017520" cy="2468880"/>
           </a:xfrm>
           <a:prstGeom prst="rect">
             <a:avLst/>
@@ -7632,20 +7024,20 @@
           </a:bodyPr>
           <a:lstStyle/>
           <a:p>
-            <a:pPr>
+            <a:pPr algn="ctr">
               <a:defRPr sz="1100" b="1">
                 <a:solidFill>
-                  <a:srgbClr val="10B981"/>
+                  <a:srgbClr val="34D399"/>
                 </a:solidFill>
                 <a:latin typeface="JetBrains Mono"/>
               </a:defRPr>
             </a:pPr>
             <a:r>
-              <a:t>ЭТАП 3 • Квартал 2</a:t>
-            </a:r>
-          </a:p>
-          <a:p>
-            <a:pPr>
+              <a:t>ЭТАП 3 • КВАРТАЛ 2</a:t>
+            </a:r>
+          </a:p>
+          <a:p>
+            <a:pPr algn="ctr">
               <a:defRPr sz="1800" b="1">
                 <a:solidFill>
                   <a:srgbClr val="FFFFFF"/>
@@ -7653,12 +7045,14 @@
                 <a:latin typeface="Plus Jakarta Sans"/>
               </a:defRPr>
             </a:pPr>
+            <a:br/>
             <a:r>
               <a:t>Масштабирование</a:t>
             </a:r>
-          </a:p>
-          <a:p>
-            <a:pPr>
+            <a:br/>
+          </a:p>
+          <a:p>
+            <a:pPr algn="ctr">
               <a:defRPr sz="1150">
                 <a:solidFill>
                   <a:srgbClr val="94A3B8"/>
@@ -7667,53 +7061,27 @@
               </a:defRPr>
             </a:pPr>
             <a:r>
-              <a:t>• Полноформатное развертывание в сети супермаркетов Profi.</a:t>
-            </a:r>
-          </a:p>
-          <a:p>
-            <a:pPr>
-              <a:defRPr sz="1150">
-                <a:solidFill>
-                  <a:srgbClr val="94A3B8"/>
-                </a:solidFill>
-                <a:latin typeface="Plus Jakarta Sans"/>
-              </a:defRPr>
-            </a:pPr>
-            <a:r>
-              <a:t>• Подключение автоматизированного дашборда учета сокращения выбросов Scope 3.</a:t>
-            </a:r>
-          </a:p>
-          <a:p>
-            <a:pPr>
-              <a:defRPr sz="1150">
-                <a:solidFill>
-                  <a:srgbClr val="94A3B8"/>
-                </a:solidFill>
-                <a:latin typeface="Plus Jakarta Sans"/>
-              </a:defRPr>
-            </a:pPr>
-            <a:r>
-              <a:t>• Оптимизация логистики оптовых поставок rPET моно-упаковки.</a:t>
-            </a:r>
-          </a:p>
-        </p:txBody>
-      </p:sp>
-      <p:sp>
-        <p:nvSpPr>
-          <p:cNvPr id="13" name="Rounded Rectangle 12"/>
+              <a:t>Развертывание в сети Profi, подключение автоматического дашборда учета сокращения Scope 3 выбросов.</a:t>
+            </a:r>
+          </a:p>
+        </p:txBody>
+      </p:sp>
+      <p:sp>
+        <p:nvSpPr>
+          <p:cNvPr id="12" name="Rounded Rectangle 11"/>
           <p:cNvSpPr/>
           <p:nvPr/>
         </p:nvSpPr>
         <p:spPr>
           <a:xfrm>
-            <a:off x="822960" y="5212080"/>
-            <a:ext cx="10545775" cy="1097280"/>
+            <a:off x="914400" y="4846320"/>
+            <a:ext cx="10362895" cy="1280160"/>
           </a:xfrm>
           <a:prstGeom prst="roundRect">
             <a:avLst/>
           </a:prstGeom>
           <a:solidFill>
-            <a:srgbClr val="122E24"/>
+            <a:srgbClr val="102E22"/>
           </a:solidFill>
           <a:ln w="19050">
             <a:solidFill>
@@ -7745,14 +7113,14 @@
       </p:sp>
       <p:sp>
         <p:nvSpPr>
-          <p:cNvPr id="14" name="TextBox 13"/>
+          <p:cNvPr id="13" name="TextBox 12"/>
           <p:cNvSpPr txBox="1"/>
           <p:nvPr/>
         </p:nvSpPr>
         <p:spPr>
           <a:xfrm>
-            <a:off x="1051560" y="5303520"/>
-            <a:ext cx="10058400" cy="914400"/>
+            <a:off x="1097280" y="4983480"/>
+            <a:ext cx="9966960" cy="1005840"/>
           </a:xfrm>
           <a:prstGeom prst="rect">
             <a:avLst/>
@@ -7765,29 +7133,29 @@
           </a:bodyPr>
           <a:lstStyle/>
           <a:p>
-            <a:pPr>
-              <a:defRPr b="1" sz="1400">
+            <a:pPr algn="ctr">
+              <a:defRPr sz="1300" b="1">
                 <a:solidFill>
                   <a:srgbClr val="34D399"/>
                 </a:solidFill>
+                <a:latin typeface="JetBrains Mono"/>
+              </a:defRPr>
+            </a:pPr>
+            <a:r>
+              <a:t>📦 ПАРТИЯ ИЗ 200 ОБРАЗЦОВ ГОТОВА К ПЕРЕДАЧЕ PROFI</a:t>
+            </a:r>
+          </a:p>
+          <a:p>
+            <a:pPr algn="ctr">
+              <a:defRPr sz="1200">
+                <a:solidFill>
+                  <a:srgbClr val="FFFFFF"/>
+                </a:solidFill>
                 <a:latin typeface="Plus Jakarta Sans"/>
               </a:defRPr>
             </a:pPr>
             <a:r>
-              <a:t>📦 Комплект из 200 образцов готов к передаче технологической службе Profi:</a:t>
-            </a:r>
-          </a:p>
-          <a:p>
-            <a:pPr>
-              <a:defRPr sz="1200">
-                <a:solidFill>
-                  <a:srgbClr val="FFFFFF"/>
-                </a:solidFill>
-                <a:latin typeface="Plus Jakarta Sans"/>
-              </a:defRPr>
-            </a:pPr>
-            <a:r>
-              <a:t>Партия пакетов CPET Ultra-Flex и термобоксов LignoShield подготовлена для старта испытаний на тепловых витринах гриля Profi уже на следующей неделе.</a:t>
+              <a:t>Комплект пакетов CPET Ultra-Flex и термобоксов LignoShield подготовлен к испытаниям на тепловых витринах сети Profi.</a:t>
             </a:r>
           </a:p>
         </p:txBody>
@@ -7825,11 +7193,11 @@
             <a:avLst/>
           </a:prstGeom>
           <a:solidFill>
-            <a:srgbClr val="0F1418"/>
+            <a:srgbClr val="0A0E11"/>
           </a:solidFill>
           <a:ln>
             <a:solidFill>
-              <a:srgbClr val="0F1418"/>
+              <a:srgbClr val="0A0E11"/>
             </a:solidFill>
           </a:ln>
         </p:spPr>
@@ -7870,7 +7238,7 @@
             <a:avLst/>
           </a:prstGeom>
           <a:solidFill>
-            <a:srgbClr val="182026"/>
+            <a:srgbClr val="12181D"/>
           </a:solidFill>
           <a:ln w="25400">
             <a:solidFill>
@@ -7908,8 +7276,8 @@
         </p:nvSpPr>
         <p:spPr>
           <a:xfrm>
-            <a:off x="1645920" y="1463040"/>
-            <a:ext cx="8899855" cy="3931920"/>
+            <a:off x="1645920" y="1371600"/>
+            <a:ext cx="8899855" cy="4114800"/>
           </a:xfrm>
           <a:prstGeom prst="rect">
             <a:avLst/>
@@ -7936,53 +7304,55 @@
           </a:p>
           <a:p>
             <a:pPr algn="ctr">
-              <a:defRPr sz="3800" b="1">
+              <a:defRPr sz="3200" b="1">
                 <a:solidFill>
                   <a:srgbClr val="FFFFFF"/>
                 </a:solidFill>
                 <a:latin typeface="Plus Jakarta Sans"/>
               </a:defRPr>
             </a:pPr>
-            <a:r>
-              <a:t>PackShift</a:t>
-            </a:r>
-          </a:p>
-          <a:p>
-            <a:pPr algn="ctr">
-              <a:defRPr sz="2000" b="1">
+            <a:br/>
+            <a:r>
+              <a:t>Делаем циркулярность прибыльной для Profi уже сегодня</a:t>
+            </a:r>
+          </a:p>
+          <a:p>
+            <a:pPr algn="ctr">
+              <a:defRPr sz="1500" b="1">
                 <a:solidFill>
                   <a:srgbClr val="34D399"/>
                 </a:solidFill>
+                <a:latin typeface="JetBrains Mono"/>
+              </a:defRPr>
+            </a:pPr>
+            <a:r>
+              <a:t>0% первичного пластика • -14% себестоимость • Нулевой CapEx</a:t>
+            </a:r>
+          </a:p>
+          <a:p>
+            <a:pPr algn="ctr">
+              <a:defRPr sz="1350">
+                <a:solidFill>
+                  <a:srgbClr val="94A3B8"/>
+                </a:solidFill>
                 <a:latin typeface="Plus Jakarta Sans"/>
               </a:defRPr>
             </a:pPr>
-            <a:r>
-              <a:t>Делаем циркулярность прибыльной для Profi уже сегодня</a:t>
-            </a:r>
-          </a:p>
-          <a:p>
-            <a:pPr algn="ctr">
-              <a:defRPr sz="1300">
-                <a:solidFill>
-                  <a:srgbClr val="94A3B8"/>
+            <a:br/>
+            <a:r>
+              <a:t>PackShift позволяет сети Profi закрыть норматив EU PPWR 2030, защитить маржинальность кулинарии и гарантировать пищевую безопасность покупателей.</a:t>
+            </a:r>
+          </a:p>
+          <a:p>
+            <a:pPr algn="ctr">
+              <a:defRPr sz="1800" b="1">
+                <a:solidFill>
+                  <a:srgbClr val="FFFFFF"/>
                 </a:solidFill>
                 <a:latin typeface="Plus Jakarta Sans"/>
               </a:defRPr>
             </a:pPr>
             <a:br/>
-            <a:r>
-              <a:t>0% первичного пластика • -14% себестоимость • Нулевой CapEx • Защита маржинальности Profi</a:t>
-            </a:r>
-          </a:p>
-          <a:p>
-            <a:pPr algn="ctr">
-              <a:defRPr sz="1700" b="1">
-                <a:solidFill>
-                  <a:srgbClr val="FFFFFF"/>
-                </a:solidFill>
-                <a:latin typeface="Plus Jakarta Sans"/>
-              </a:defRPr>
-            </a:pPr>
             <a:br/>
             <a:r>
               <a:t>Благодарим за внимание! Готовы ответить на ваши вопросы.</a:t>

</xml_diff>